<commit_message>
Enhance defense presentation with professional design and dental theme
</commit_message>
<xml_diff>
--- a/GDCMAS_Final_Defense_Presentation.pptx
+++ b/GDCMAS_Final_Defense_Presentation.pptx
@@ -3099,19 +3099,76 @@
       <p:grpSpPr/>
       <p:sp>
         <p:nvSpPr>
-          <p:cNvPr id="2" name="Title 1"/>
-          <p:cNvSpPr>
-            <a:spLocks noGrp="1"/>
-          </p:cNvSpPr>
-          <p:nvPr>
-            <p:ph type="ctrTitle"/>
-          </p:nvPr>
-        </p:nvSpPr>
-        <p:spPr/>
-        <p:txBody>
-          <a:bodyPr/>
-          <a:lstStyle/>
-          <a:p>
+          <p:cNvPr id="2" name="Rectangle 1"/>
+          <p:cNvSpPr/>
+          <p:nvPr/>
+        </p:nvSpPr>
+        <p:spPr>
+          <a:xfrm>
+            <a:off x="0" y="0"/>
+            <a:ext cx="9144000" cy="1097280"/>
+          </a:xfrm>
+          <a:prstGeom prst="rect">
+            <a:avLst/>
+          </a:prstGeom>
+          <a:solidFill>
+            <a:srgbClr val="4A7A5C"/>
+          </a:solidFill>
+          <a:ln>
+            <a:noFill/>
+          </a:ln>
+        </p:spPr>
+        <p:style>
+          <a:lnRef idx="1">
+            <a:schemeClr val="accent1"/>
+          </a:lnRef>
+          <a:fillRef idx="3">
+            <a:schemeClr val="accent1"/>
+          </a:fillRef>
+          <a:effectRef idx="2">
+            <a:schemeClr val="accent1"/>
+          </a:effectRef>
+          <a:fontRef idx="minor">
+            <a:schemeClr val="lt1"/>
+          </a:fontRef>
+        </p:style>
+        <p:txBody>
+          <a:bodyPr rtlCol="0" anchor="ctr"/>
+          <a:lstStyle/>
+          <a:p>
+            <a:pPr algn="ctr"/>
+          </a:p>
+        </p:txBody>
+      </p:sp>
+      <p:sp>
+        <p:nvSpPr>
+          <p:cNvPr id="3" name="TextBox 2"/>
+          <p:cNvSpPr txBox="1"/>
+          <p:nvPr/>
+        </p:nvSpPr>
+        <p:spPr>
+          <a:xfrm>
+            <a:off x="457200" y="1371600"/>
+            <a:ext cx="8229600" cy="1371600"/>
+          </a:xfrm>
+          <a:prstGeom prst="rect">
+            <a:avLst/>
+          </a:prstGeom>
+          <a:noFill/>
+        </p:spPr>
+        <p:txBody>
+          <a:bodyPr wrap="none">
+            <a:spAutoFit/>
+          </a:bodyPr>
+          <a:lstStyle/>
+          <a:p>
+            <a:pPr algn="ctr">
+              <a:defRPr sz="3200" b="1">
+                <a:solidFill>
+                  <a:srgbClr val="1E3A8A"/>
+                </a:solidFill>
+              </a:defRPr>
+            </a:pPr>
             <a:r>
               <a:t>GONZAGA DENTAL CLINIC MANAGEMENT AUTOMATION SYSTEM (GDCMAS)</a:t>
             </a:r>
@@ -3120,25 +3177,65 @@
       </p:sp>
       <p:sp>
         <p:nvSpPr>
-          <p:cNvPr id="3" name="Subtitle 2"/>
-          <p:cNvSpPr>
-            <a:spLocks noGrp="1"/>
-          </p:cNvSpPr>
-          <p:nvPr>
-            <p:ph type="subTitle" idx="1"/>
-          </p:nvPr>
-        </p:nvSpPr>
-        <p:spPr/>
-        <p:txBody>
-          <a:bodyPr/>
-          <a:lstStyle/>
-          <a:p>
-            <a:r>
-              <a:t>A Business Process Automation Plan for Streamlining Patient Records, Appointment Scheduling, and Dental Clinic Operations at Gonzaga Dental Clinic</a:t>
-            </a:r>
-          </a:p>
-          <a:p/>
-          <a:p>
+          <p:cNvPr id="4" name="TextBox 3"/>
+          <p:cNvSpPr txBox="1"/>
+          <p:nvPr/>
+        </p:nvSpPr>
+        <p:spPr>
+          <a:xfrm>
+            <a:off x="457200" y="2926080"/>
+            <a:ext cx="8229600" cy="914400"/>
+          </a:xfrm>
+          <a:prstGeom prst="rect">
+            <a:avLst/>
+          </a:prstGeom>
+          <a:noFill/>
+        </p:spPr>
+        <p:txBody>
+          <a:bodyPr wrap="none">
+            <a:spAutoFit/>
+          </a:bodyPr>
+          <a:lstStyle/>
+          <a:p>
+            <a:pPr algn="ctr">
+              <a:defRPr sz="1800"/>
+            </a:pPr>
+            <a:r>
+              <a:t>A Business Process Automation Plan for Streamlining Patient Records,</a:t>
+            </a:r>
+          </a:p>
+          <a:p>
+            <a:r>
+              <a:t>Appointment Scheduling, and Dental Clinic Operations at Gonzaga Dental Clinic</a:t>
+            </a:r>
+          </a:p>
+        </p:txBody>
+      </p:sp>
+      <p:sp>
+        <p:nvSpPr>
+          <p:cNvPr id="5" name="TextBox 4"/>
+          <p:cNvSpPr txBox="1"/>
+          <p:nvPr/>
+        </p:nvSpPr>
+        <p:spPr>
+          <a:xfrm>
+            <a:off x="457200" y="4114800"/>
+            <a:ext cx="8229600" cy="1371600"/>
+          </a:xfrm>
+          <a:prstGeom prst="rect">
+            <a:avLst/>
+          </a:prstGeom>
+          <a:noFill/>
+        </p:spPr>
+        <p:txBody>
+          <a:bodyPr wrap="none">
+            <a:spAutoFit/>
+          </a:bodyPr>
+          <a:lstStyle/>
+          <a:p>
+            <a:pPr algn="ctr">
+              <a:defRPr sz="1600"/>
+            </a:pPr>
             <a:r>
               <a:t>Amor, Khent Vincent C. | Galve, Fritz Michael G. | Gayem, Vince</a:t>
             </a:r>
@@ -3153,20 +3250,35 @@
               <a:t>Suasin, Ela | Tamba, Mon Wilbert</a:t>
             </a:r>
           </a:p>
-          <a:p/>
-          <a:p>
-            <a:r>
-              <a:t>PHINMA University of Iloilo</a:t>
-            </a:r>
-          </a:p>
-          <a:p>
-            <a:r>
-              <a:t>College of Information Technology Education</a:t>
-            </a:r>
-          </a:p>
-          <a:p>
-            <a:r>
-              <a:t>October 2026</a:t>
+        </p:txBody>
+      </p:sp>
+      <p:sp>
+        <p:nvSpPr>
+          <p:cNvPr id="6" name="TextBox 5"/>
+          <p:cNvSpPr txBox="1"/>
+          <p:nvPr/>
+        </p:nvSpPr>
+        <p:spPr>
+          <a:xfrm>
+            <a:off x="457200" y="5486400"/>
+            <a:ext cx="8229600" cy="731520"/>
+          </a:xfrm>
+          <a:prstGeom prst="rect">
+            <a:avLst/>
+          </a:prstGeom>
+          <a:noFill/>
+        </p:spPr>
+        <p:txBody>
+          <a:bodyPr wrap="none">
+            <a:spAutoFit/>
+          </a:bodyPr>
+          <a:lstStyle/>
+          <a:p>
+            <a:pPr algn="ctr">
+              <a:defRPr sz="1400"/>
+            </a:pPr>
+            <a:r>
+              <a:t>PHINMA University of Iloilo | College of Information Technology Education | October 2026</a:t>
             </a:r>
           </a:p>
         </p:txBody>
@@ -3191,19 +3303,76 @@
       <p:grpSpPr/>
       <p:sp>
         <p:nvSpPr>
-          <p:cNvPr id="2" name="Title 1"/>
-          <p:cNvSpPr>
-            <a:spLocks noGrp="1"/>
-          </p:cNvSpPr>
-          <p:nvPr>
-            <p:ph type="ctrTitle"/>
-          </p:nvPr>
-        </p:nvSpPr>
-        <p:spPr/>
-        <p:txBody>
-          <a:bodyPr/>
-          <a:lstStyle/>
-          <a:p>
+          <p:cNvPr id="2" name="Rectangle 1"/>
+          <p:cNvSpPr/>
+          <p:nvPr/>
+        </p:nvSpPr>
+        <p:spPr>
+          <a:xfrm>
+            <a:off x="0" y="0"/>
+            <a:ext cx="9144000" cy="1371600"/>
+          </a:xfrm>
+          <a:prstGeom prst="rect">
+            <a:avLst/>
+          </a:prstGeom>
+          <a:solidFill>
+            <a:srgbClr val="4A7A5C"/>
+          </a:solidFill>
+          <a:ln>
+            <a:noFill/>
+          </a:ln>
+        </p:spPr>
+        <p:style>
+          <a:lnRef idx="1">
+            <a:schemeClr val="accent1"/>
+          </a:lnRef>
+          <a:fillRef idx="3">
+            <a:schemeClr val="accent1"/>
+          </a:fillRef>
+          <a:effectRef idx="2">
+            <a:schemeClr val="accent1"/>
+          </a:effectRef>
+          <a:fontRef idx="minor">
+            <a:schemeClr val="lt1"/>
+          </a:fontRef>
+        </p:style>
+        <p:txBody>
+          <a:bodyPr rtlCol="0" anchor="ctr"/>
+          <a:lstStyle/>
+          <a:p>
+            <a:pPr algn="ctr"/>
+          </a:p>
+        </p:txBody>
+      </p:sp>
+      <p:sp>
+        <p:nvSpPr>
+          <p:cNvPr id="3" name="TextBox 2"/>
+          <p:cNvSpPr txBox="1"/>
+          <p:nvPr/>
+        </p:nvSpPr>
+        <p:spPr>
+          <a:xfrm>
+            <a:off x="457200" y="1828800"/>
+            <a:ext cx="8229600" cy="914400"/>
+          </a:xfrm>
+          <a:prstGeom prst="rect">
+            <a:avLst/>
+          </a:prstGeom>
+          <a:noFill/>
+        </p:spPr>
+        <p:txBody>
+          <a:bodyPr wrap="none">
+            <a:spAutoFit/>
+          </a:bodyPr>
+          <a:lstStyle/>
+          <a:p>
+            <a:pPr algn="ctr">
+              <a:defRPr sz="6000" b="1">
+                <a:solidFill>
+                  <a:srgbClr val="1E3A8A"/>
+                </a:solidFill>
+              </a:defRPr>
+            </a:pPr>
             <a:r>
               <a:t>THANK YOU!</a:t>
             </a:r>
@@ -3212,38 +3381,67 @@
       </p:sp>
       <p:sp>
         <p:nvSpPr>
-          <p:cNvPr id="3" name="Subtitle 2"/>
-          <p:cNvSpPr>
-            <a:spLocks noGrp="1"/>
-          </p:cNvSpPr>
-          <p:nvPr>
-            <p:ph type="subTitle" idx="1"/>
-          </p:nvPr>
-        </p:nvSpPr>
-        <p:spPr/>
-        <p:txBody>
-          <a:bodyPr/>
-          <a:lstStyle/>
-          <a:p>
+          <p:cNvPr id="4" name="TextBox 3"/>
+          <p:cNvSpPr txBox="1"/>
+          <p:nvPr/>
+        </p:nvSpPr>
+        <p:spPr>
+          <a:xfrm>
+            <a:off x="457200" y="3200400"/>
+            <a:ext cx="8229600" cy="914400"/>
+          </a:xfrm>
+          <a:prstGeom prst="rect">
+            <a:avLst/>
+          </a:prstGeom>
+          <a:noFill/>
+        </p:spPr>
+        <p:txBody>
+          <a:bodyPr wrap="none">
+            <a:spAutoFit/>
+          </a:bodyPr>
+          <a:lstStyle/>
+          <a:p>
+            <a:pPr algn="ctr">
+              <a:defRPr sz="3200"/>
+            </a:pPr>
             <a:r>
               <a:t>Questions and Answers</a:t>
             </a:r>
           </a:p>
-          <a:p/>
-          <a:p>
+        </p:txBody>
+      </p:sp>
+      <p:sp>
+        <p:nvSpPr>
+          <p:cNvPr id="5" name="TextBox 4"/>
+          <p:cNvSpPr txBox="1"/>
+          <p:nvPr/>
+        </p:nvSpPr>
+        <p:spPr>
+          <a:xfrm>
+            <a:off x="457200" y="5029200"/>
+            <a:ext cx="8229600" cy="914400"/>
+          </a:xfrm>
+          <a:prstGeom prst="rect">
+            <a:avLst/>
+          </a:prstGeom>
+          <a:noFill/>
+        </p:spPr>
+        <p:txBody>
+          <a:bodyPr wrap="none">
+            <a:spAutoFit/>
+          </a:bodyPr>
+          <a:lstStyle/>
+          <a:p>
+            <a:pPr algn="ctr">
+              <a:defRPr sz="1600"/>
+            </a:pPr>
             <a:r>
               <a:t>Gonzaga Dental Clinic Management Automation System (GDCMAS)</a:t>
             </a:r>
           </a:p>
-          <a:p/>
-          <a:p>
-            <a:r>
-              <a:t>PHINMA University of Iloilo</a:t>
-            </a:r>
-          </a:p>
-          <a:p>
-            <a:r>
-              <a:t>College of Information Technology Education</a:t>
+          <a:p>
+            <a:r>
+              <a:t>PHINMA University of Iloilo - College of Information Technology Education</a:t>
             </a:r>
           </a:p>
         </p:txBody>
@@ -3268,38 +3466,102 @@
       <p:grpSpPr/>
       <p:sp>
         <p:nvSpPr>
-          <p:cNvPr id="2" name="Title 1"/>
-          <p:cNvSpPr>
-            <a:spLocks noGrp="1"/>
-          </p:cNvSpPr>
-          <p:nvPr>
-            <p:ph type="title"/>
-          </p:nvPr>
-        </p:nvSpPr>
-        <p:spPr/>
-        <p:txBody>
-          <a:bodyPr/>
-          <a:lstStyle/>
-          <a:p>
-            <a:r>
-              <a:t>Business Problem</a:t>
-            </a:r>
-          </a:p>
-        </p:txBody>
-      </p:sp>
-      <p:sp>
-        <p:nvSpPr>
-          <p:cNvPr id="3" name="Content Placeholder 2"/>
-          <p:cNvSpPr>
-            <a:spLocks noGrp="1"/>
-          </p:cNvSpPr>
-          <p:nvPr>
-            <p:ph idx="1"/>
-          </p:nvPr>
-        </p:nvSpPr>
-        <p:spPr/>
-        <p:txBody>
-          <a:bodyPr/>
+          <p:cNvPr id="2" name="Rectangle 1"/>
+          <p:cNvSpPr/>
+          <p:nvPr/>
+        </p:nvSpPr>
+        <p:spPr>
+          <a:xfrm>
+            <a:off x="0" y="0"/>
+            <a:ext cx="9144000" cy="731520"/>
+          </a:xfrm>
+          <a:prstGeom prst="rect">
+            <a:avLst/>
+          </a:prstGeom>
+          <a:solidFill>
+            <a:srgbClr val="4A7A5C"/>
+          </a:solidFill>
+          <a:ln>
+            <a:noFill/>
+          </a:ln>
+        </p:spPr>
+        <p:style>
+          <a:lnRef idx="1">
+            <a:schemeClr val="accent1"/>
+          </a:lnRef>
+          <a:fillRef idx="3">
+            <a:schemeClr val="accent1"/>
+          </a:fillRef>
+          <a:effectRef idx="2">
+            <a:schemeClr val="accent1"/>
+          </a:effectRef>
+          <a:fontRef idx="minor">
+            <a:schemeClr val="lt1"/>
+          </a:fontRef>
+        </p:style>
+        <p:txBody>
+          <a:bodyPr rtlCol="0" anchor="ctr"/>
+          <a:lstStyle/>
+          <a:p>
+            <a:pPr algn="ctr"/>
+          </a:p>
+        </p:txBody>
+      </p:sp>
+      <p:sp>
+        <p:nvSpPr>
+          <p:cNvPr id="3" name="TextBox 2"/>
+          <p:cNvSpPr txBox="1"/>
+          <p:nvPr/>
+        </p:nvSpPr>
+        <p:spPr>
+          <a:xfrm>
+            <a:off x="457200" y="91440"/>
+            <a:ext cx="8229600" cy="548640"/>
+          </a:xfrm>
+          <a:prstGeom prst="rect">
+            <a:avLst/>
+          </a:prstGeom>
+          <a:noFill/>
+        </p:spPr>
+        <p:txBody>
+          <a:bodyPr wrap="none">
+            <a:spAutoFit/>
+          </a:bodyPr>
+          <a:lstStyle/>
+          <a:p>
+            <a:pPr>
+              <a:defRPr sz="3200" b="1">
+                <a:solidFill>
+                  <a:srgbClr val="FFFFFF"/>
+                </a:solidFill>
+              </a:defRPr>
+            </a:pPr>
+            <a:r>
+              <a:t>BUSINESS PROBLEM</a:t>
+            </a:r>
+          </a:p>
+        </p:txBody>
+      </p:sp>
+      <p:sp>
+        <p:nvSpPr>
+          <p:cNvPr id="4" name="TextBox 3"/>
+          <p:cNvSpPr txBox="1"/>
+          <p:nvPr/>
+        </p:nvSpPr>
+        <p:spPr>
+          <a:xfrm>
+            <a:off x="457200" y="1097280"/>
+            <a:ext cx="8229600" cy="4572000"/>
+          </a:xfrm>
+          <a:prstGeom prst="rect">
+            <a:avLst/>
+          </a:prstGeom>
+          <a:noFill/>
+        </p:spPr>
+        <p:txBody>
+          <a:bodyPr wrap="none">
+            <a:spAutoFit/>
+          </a:bodyPr>
           <a:lstStyle/>
           <a:p>
             <a:r>
@@ -3307,39 +3569,67 @@
             </a:r>
           </a:p>
           <a:p>
-            <a:pPr lvl="1"/>
+            <a:pPr lvl="1">
+              <a:defRPr sz="2000"/>
+            </a:pPr>
             <a:r>
               <a:t>• Patient records stored in physical envelopes, binders, and cabinets</a:t>
             </a:r>
           </a:p>
           <a:p>
-            <a:pPr lvl="1"/>
+            <a:pPr lvl="1">
+              <a:defRPr sz="2000"/>
+            </a:pPr>
             <a:r>
               <a:t>• Appointment information maintained in a logbook</a:t>
             </a:r>
           </a:p>
           <a:p>
-            <a:pPr lvl="1"/>
+            <a:pPr lvl="1">
+              <a:defRPr sz="2000"/>
+            </a:pPr>
             <a:r>
               <a:t>• Treatment updates recorded on index cards</a:t>
             </a:r>
           </a:p>
           <a:p>
-            <a:pPr lvl="1"/>
-            <a:r>
-              <a:t>• Records not accessible between branches (Main &amp; Second Branch)</a:t>
-            </a:r>
-          </a:p>
-          <a:p>
-            <a:pPr lvl="1"/>
+            <a:pPr lvl="1">
+              <a:defRPr sz="2000"/>
+            </a:pPr>
+            <a:r>
+              <a:t>• Records not accessible between branches (Main Branch &amp; Second Branch)</a:t>
+            </a:r>
+          </a:p>
+          <a:p>
+            <a:pPr lvl="1">
+              <a:defRPr sz="2000"/>
+            </a:pPr>
             <a:r>
               <a:t>• No backup system for physical records</a:t>
             </a:r>
           </a:p>
           <a:p>
-            <a:pPr lvl="1"/>
+            <a:pPr lvl="1">
+              <a:defRPr sz="2000"/>
+            </a:pPr>
             <a:r>
               <a:t>• Risk of duplicate patient records</a:t>
+            </a:r>
+          </a:p>
+          <a:p>
+            <a:pPr lvl="1">
+              <a:defRPr sz="2000"/>
+            </a:pPr>
+            <a:r>
+              <a:t>• Difficulty in checking schedule availability</a:t>
+            </a:r>
+          </a:p>
+          <a:p>
+            <a:pPr lvl="1">
+              <a:defRPr sz="2000"/>
+            </a:pPr>
+            <a:r>
+              <a:t>• Reliance on sharing photos/messages between branches</a:t>
             </a:r>
           </a:p>
         </p:txBody>
@@ -3364,72 +3654,146 @@
       <p:grpSpPr/>
       <p:sp>
         <p:nvSpPr>
-          <p:cNvPr id="2" name="Title 1"/>
-          <p:cNvSpPr>
-            <a:spLocks noGrp="1"/>
-          </p:cNvSpPr>
-          <p:nvPr>
-            <p:ph type="title"/>
-          </p:nvPr>
-        </p:nvSpPr>
-        <p:spPr/>
-        <p:txBody>
-          <a:bodyPr/>
-          <a:lstStyle/>
-          <a:p>
-            <a:r>
-              <a:t>Current Process (As-Is)</a:t>
-            </a:r>
-          </a:p>
-        </p:txBody>
-      </p:sp>
-      <p:sp>
-        <p:nvSpPr>
-          <p:cNvPr id="3" name="Content Placeholder 2"/>
-          <p:cNvSpPr>
-            <a:spLocks noGrp="1"/>
-          </p:cNvSpPr>
-          <p:nvPr>
-            <p:ph idx="1"/>
-          </p:nvPr>
-        </p:nvSpPr>
-        <p:spPr/>
-        <p:txBody>
-          <a:bodyPr/>
-          <a:lstStyle/>
-          <a:p>
-            <a:r>
-              <a:t>1. Patient Registration - Fill out paper intake forms and consent</a:t>
-            </a:r>
-          </a:p>
-          <a:p>
-            <a:pPr lvl="1"/>
-            <a:r>
-              <a:t>2. Record Storage - Documents placed in labeled envelopes</a:t>
-            </a:r>
-          </a:p>
-          <a:p>
-            <a:pPr lvl="1"/>
+          <p:cNvPr id="2" name="Rectangle 1"/>
+          <p:cNvSpPr/>
+          <p:nvPr/>
+        </p:nvSpPr>
+        <p:spPr>
+          <a:xfrm>
+            <a:off x="0" y="0"/>
+            <a:ext cx="9144000" cy="731520"/>
+          </a:xfrm>
+          <a:prstGeom prst="rect">
+            <a:avLst/>
+          </a:prstGeom>
+          <a:solidFill>
+            <a:srgbClr val="4A7A5C"/>
+          </a:solidFill>
+          <a:ln>
+            <a:noFill/>
+          </a:ln>
+        </p:spPr>
+        <p:style>
+          <a:lnRef idx="1">
+            <a:schemeClr val="accent1"/>
+          </a:lnRef>
+          <a:fillRef idx="3">
+            <a:schemeClr val="accent1"/>
+          </a:fillRef>
+          <a:effectRef idx="2">
+            <a:schemeClr val="accent1"/>
+          </a:effectRef>
+          <a:fontRef idx="minor">
+            <a:schemeClr val="lt1"/>
+          </a:fontRef>
+        </p:style>
+        <p:txBody>
+          <a:bodyPr rtlCol="0" anchor="ctr"/>
+          <a:lstStyle/>
+          <a:p>
+            <a:pPr algn="ctr"/>
+          </a:p>
+        </p:txBody>
+      </p:sp>
+      <p:sp>
+        <p:nvSpPr>
+          <p:cNvPr id="3" name="TextBox 2"/>
+          <p:cNvSpPr txBox="1"/>
+          <p:nvPr/>
+        </p:nvSpPr>
+        <p:spPr>
+          <a:xfrm>
+            <a:off x="457200" y="91440"/>
+            <a:ext cx="8229600" cy="548640"/>
+          </a:xfrm>
+          <a:prstGeom prst="rect">
+            <a:avLst/>
+          </a:prstGeom>
+          <a:noFill/>
+        </p:spPr>
+        <p:txBody>
+          <a:bodyPr wrap="none">
+            <a:spAutoFit/>
+          </a:bodyPr>
+          <a:lstStyle/>
+          <a:p>
+            <a:pPr>
+              <a:defRPr sz="3200" b="1">
+                <a:solidFill>
+                  <a:srgbClr val="FFFFFF"/>
+                </a:solidFill>
+              </a:defRPr>
+            </a:pPr>
+            <a:r>
+              <a:t>CURRENT PROCESS (AS-IS)</a:t>
+            </a:r>
+          </a:p>
+        </p:txBody>
+      </p:sp>
+      <p:sp>
+        <p:nvSpPr>
+          <p:cNvPr id="4" name="TextBox 3"/>
+          <p:cNvSpPr txBox="1"/>
+          <p:nvPr/>
+        </p:nvSpPr>
+        <p:spPr>
+          <a:xfrm>
+            <a:off x="457200" y="1097280"/>
+            <a:ext cx="8229600" cy="4572000"/>
+          </a:xfrm>
+          <a:prstGeom prst="rect">
+            <a:avLst/>
+          </a:prstGeom>
+          <a:noFill/>
+        </p:spPr>
+        <p:txBody>
+          <a:bodyPr wrap="none">
+            <a:spAutoFit/>
+          </a:bodyPr>
+          <a:lstStyle/>
+          <a:p>
+            <a:r>
+              <a:t>1. Patient Registration - Fill out paper intake forms and consent documents</a:t>
+            </a:r>
+          </a:p>
+          <a:p>
+            <a:pPr lvl="1">
+              <a:defRPr sz="2200"/>
+            </a:pPr>
+            <a:r>
+              <a:t>2. Record Storage - Documents placed in labeled envelopes and cabinets</a:t>
+            </a:r>
+          </a:p>
+          <a:p>
+            <a:pPr lvl="1">
+              <a:defRPr sz="2200"/>
+            </a:pPr>
             <a:r>
               <a:t>3. Consultation - Dentist reviews patient history from physical files</a:t>
             </a:r>
           </a:p>
           <a:p>
-            <a:pPr lvl="1"/>
+            <a:pPr lvl="1">
+              <a:defRPr sz="2200"/>
+            </a:pPr>
             <a:r>
               <a:t>4. Treatment Recording - Updates written on index cards</a:t>
             </a:r>
           </a:p>
           <a:p>
-            <a:pPr lvl="1"/>
+            <a:pPr lvl="1">
+              <a:defRPr sz="2200"/>
+            </a:pPr>
             <a:r>
               <a:t>5. Appointment Booking - Recorded manually in a logbook</a:t>
             </a:r>
           </a:p>
           <a:p>
-            <a:pPr lvl="1"/>
-            <a:r>
-              <a:t>6. Inter-Branch Coordination - Through text/messages or sharing photos</a:t>
+            <a:pPr lvl="1">
+              <a:defRPr sz="2200"/>
+            </a:pPr>
+            <a:r>
+              <a:t>6. Inter-Branch Coordination - Through text messages or sharing photos</a:t>
             </a:r>
           </a:p>
         </p:txBody>
@@ -3454,38 +3818,102 @@
       <p:grpSpPr/>
       <p:sp>
         <p:nvSpPr>
-          <p:cNvPr id="2" name="Title 1"/>
-          <p:cNvSpPr>
-            <a:spLocks noGrp="1"/>
-          </p:cNvSpPr>
-          <p:nvPr>
-            <p:ph type="title"/>
-          </p:nvPr>
-        </p:nvSpPr>
-        <p:spPr/>
-        <p:txBody>
-          <a:bodyPr/>
-          <a:lstStyle/>
-          <a:p>
-            <a:r>
-              <a:t>Problems Identified</a:t>
-            </a:r>
-          </a:p>
-        </p:txBody>
-      </p:sp>
-      <p:sp>
-        <p:nvSpPr>
-          <p:cNvPr id="3" name="Content Placeholder 2"/>
-          <p:cNvSpPr>
-            <a:spLocks noGrp="1"/>
-          </p:cNvSpPr>
-          <p:nvPr>
-            <p:ph idx="1"/>
-          </p:nvPr>
-        </p:nvSpPr>
-        <p:spPr/>
-        <p:txBody>
-          <a:bodyPr/>
+          <p:cNvPr id="2" name="Rectangle 1"/>
+          <p:cNvSpPr/>
+          <p:nvPr/>
+        </p:nvSpPr>
+        <p:spPr>
+          <a:xfrm>
+            <a:off x="0" y="0"/>
+            <a:ext cx="9144000" cy="731520"/>
+          </a:xfrm>
+          <a:prstGeom prst="rect">
+            <a:avLst/>
+          </a:prstGeom>
+          <a:solidFill>
+            <a:srgbClr val="4A7A5C"/>
+          </a:solidFill>
+          <a:ln>
+            <a:noFill/>
+          </a:ln>
+        </p:spPr>
+        <p:style>
+          <a:lnRef idx="1">
+            <a:schemeClr val="accent1"/>
+          </a:lnRef>
+          <a:fillRef idx="3">
+            <a:schemeClr val="accent1"/>
+          </a:fillRef>
+          <a:effectRef idx="2">
+            <a:schemeClr val="accent1"/>
+          </a:effectRef>
+          <a:fontRef idx="minor">
+            <a:schemeClr val="lt1"/>
+          </a:fontRef>
+        </p:style>
+        <p:txBody>
+          <a:bodyPr rtlCol="0" anchor="ctr"/>
+          <a:lstStyle/>
+          <a:p>
+            <a:pPr algn="ctr"/>
+          </a:p>
+        </p:txBody>
+      </p:sp>
+      <p:sp>
+        <p:nvSpPr>
+          <p:cNvPr id="3" name="TextBox 2"/>
+          <p:cNvSpPr txBox="1"/>
+          <p:nvPr/>
+        </p:nvSpPr>
+        <p:spPr>
+          <a:xfrm>
+            <a:off x="457200" y="91440"/>
+            <a:ext cx="8229600" cy="548640"/>
+          </a:xfrm>
+          <a:prstGeom prst="rect">
+            <a:avLst/>
+          </a:prstGeom>
+          <a:noFill/>
+        </p:spPr>
+        <p:txBody>
+          <a:bodyPr wrap="none">
+            <a:spAutoFit/>
+          </a:bodyPr>
+          <a:lstStyle/>
+          <a:p>
+            <a:pPr>
+              <a:defRPr sz="3200" b="1">
+                <a:solidFill>
+                  <a:srgbClr val="FFFFFF"/>
+                </a:solidFill>
+              </a:defRPr>
+            </a:pPr>
+            <a:r>
+              <a:t>PROBLEMS IDENTIFIED</a:t>
+            </a:r>
+          </a:p>
+        </p:txBody>
+      </p:sp>
+      <p:sp>
+        <p:nvSpPr>
+          <p:cNvPr id="4" name="TextBox 3"/>
+          <p:cNvSpPr txBox="1"/>
+          <p:nvPr/>
+        </p:nvSpPr>
+        <p:spPr>
+          <a:xfrm>
+            <a:off x="457200" y="1097280"/>
+            <a:ext cx="8229600" cy="4572000"/>
+          </a:xfrm>
+          <a:prstGeom prst="rect">
+            <a:avLst/>
+          </a:prstGeom>
+          <a:noFill/>
+        </p:spPr>
+        <p:txBody>
+          <a:bodyPr wrap="none">
+            <a:spAutoFit/>
+          </a:bodyPr>
           <a:lstStyle/>
           <a:p>
             <a:r>
@@ -3493,39 +3921,59 @@
             </a:r>
           </a:p>
           <a:p>
-            <a:pPr lvl="1"/>
+            <a:pPr lvl="1">
+              <a:defRPr sz="2000"/>
+            </a:pPr>
             <a:r>
               <a:t>• Limited Accessibility - Cannot access records instantly between branches</a:t>
             </a:r>
           </a:p>
           <a:p>
-            <a:pPr lvl="1"/>
-            <a:r>
-              <a:t>• Manual Tracking - Time-consuming search for records</a:t>
-            </a:r>
-          </a:p>
-          <a:p>
-            <a:pPr lvl="1"/>
-            <a:r>
-              <a:t>• Scheduling Conflicts - Risk of double-booking</a:t>
-            </a:r>
-          </a:p>
-          <a:p>
-            <a:pPr lvl="1"/>
+            <a:pPr lvl="1">
+              <a:defRPr sz="2000"/>
+            </a:pPr>
+            <a:r>
+              <a:t>• Manual Tracking - Time-consuming search for patient records</a:t>
+            </a:r>
+          </a:p>
+          <a:p>
+            <a:pPr lvl="1">
+              <a:defRPr sz="2000"/>
+            </a:pPr>
+            <a:r>
+              <a:t>• Scheduling Conflicts - Risk of double-booking due to manual logbook</a:t>
+            </a:r>
+          </a:p>
+          <a:p>
+            <a:pPr lvl="1">
+              <a:defRPr sz="2000"/>
+            </a:pPr>
             <a:r>
               <a:t>• No Data Backup - Records vulnerable to loss or damage</a:t>
             </a:r>
           </a:p>
           <a:p>
-            <a:pPr lvl="1"/>
+            <a:pPr lvl="1">
+              <a:defRPr sz="2000"/>
+            </a:pPr>
             <a:r>
               <a:t>• Duplicate Records - Created when existing files cannot be located</a:t>
             </a:r>
           </a:p>
           <a:p>
-            <a:pPr lvl="1"/>
-            <a:r>
-              <a:t>• Lack of Accountability - No audit trail</a:t>
+            <a:pPr lvl="1">
+              <a:defRPr sz="2000"/>
+            </a:pPr>
+            <a:r>
+              <a:t>• Lack of Accountability - No audit trail of system activities</a:t>
+            </a:r>
+          </a:p>
+          <a:p>
+            <a:pPr lvl="1">
+              <a:defRPr sz="2000"/>
+            </a:pPr>
+            <a:r>
+              <a:t>• Inefficient Coordination - Delays in inter-branch record sharing</a:t>
             </a:r>
           </a:p>
         </p:txBody>
@@ -3550,90 +3998,173 @@
       <p:grpSpPr/>
       <p:sp>
         <p:nvSpPr>
-          <p:cNvPr id="2" name="Title 1"/>
-          <p:cNvSpPr>
-            <a:spLocks noGrp="1"/>
-          </p:cNvSpPr>
-          <p:nvPr>
-            <p:ph type="title"/>
-          </p:nvPr>
-        </p:nvSpPr>
-        <p:spPr/>
-        <p:txBody>
-          <a:bodyPr/>
-          <a:lstStyle/>
-          <a:p>
-            <a:r>
-              <a:t>Proposed Solution</a:t>
-            </a:r>
-          </a:p>
-        </p:txBody>
-      </p:sp>
-      <p:sp>
-        <p:nvSpPr>
-          <p:cNvPr id="3" name="Content Placeholder 2"/>
-          <p:cNvSpPr>
-            <a:spLocks noGrp="1"/>
-          </p:cNvSpPr>
-          <p:nvPr>
-            <p:ph idx="1"/>
-          </p:nvPr>
-        </p:nvSpPr>
-        <p:spPr/>
-        <p:txBody>
-          <a:bodyPr/>
-          <a:lstStyle/>
-          <a:p>
+          <p:cNvPr id="2" name="Rectangle 1"/>
+          <p:cNvSpPr/>
+          <p:nvPr/>
+        </p:nvSpPr>
+        <p:spPr>
+          <a:xfrm>
+            <a:off x="0" y="0"/>
+            <a:ext cx="9144000" cy="731520"/>
+          </a:xfrm>
+          <a:prstGeom prst="rect">
+            <a:avLst/>
+          </a:prstGeom>
+          <a:solidFill>
+            <a:srgbClr val="4A7A5C"/>
+          </a:solidFill>
+          <a:ln>
+            <a:noFill/>
+          </a:ln>
+        </p:spPr>
+        <p:style>
+          <a:lnRef idx="1">
+            <a:schemeClr val="accent1"/>
+          </a:lnRef>
+          <a:fillRef idx="3">
+            <a:schemeClr val="accent1"/>
+          </a:fillRef>
+          <a:effectRef idx="2">
+            <a:schemeClr val="accent1"/>
+          </a:effectRef>
+          <a:fontRef idx="minor">
+            <a:schemeClr val="lt1"/>
+          </a:fontRef>
+        </p:style>
+        <p:txBody>
+          <a:bodyPr rtlCol="0" anchor="ctr"/>
+          <a:lstStyle/>
+          <a:p>
+            <a:pPr algn="ctr"/>
+          </a:p>
+        </p:txBody>
+      </p:sp>
+      <p:sp>
+        <p:nvSpPr>
+          <p:cNvPr id="3" name="TextBox 2"/>
+          <p:cNvSpPr txBox="1"/>
+          <p:nvPr/>
+        </p:nvSpPr>
+        <p:spPr>
+          <a:xfrm>
+            <a:off x="457200" y="91440"/>
+            <a:ext cx="8229600" cy="548640"/>
+          </a:xfrm>
+          <a:prstGeom prst="rect">
+            <a:avLst/>
+          </a:prstGeom>
+          <a:noFill/>
+        </p:spPr>
+        <p:txBody>
+          <a:bodyPr wrap="none">
+            <a:spAutoFit/>
+          </a:bodyPr>
+          <a:lstStyle/>
+          <a:p>
+            <a:pPr>
+              <a:defRPr sz="3200" b="1">
+                <a:solidFill>
+                  <a:srgbClr val="FFFFFF"/>
+                </a:solidFill>
+              </a:defRPr>
+            </a:pPr>
+            <a:r>
+              <a:t>PROPOSED SOLUTION</a:t>
+            </a:r>
+          </a:p>
+        </p:txBody>
+      </p:sp>
+      <p:sp>
+        <p:nvSpPr>
+          <p:cNvPr id="4" name="TextBox 3"/>
+          <p:cNvSpPr txBox="1"/>
+          <p:nvPr/>
+        </p:nvSpPr>
+        <p:spPr>
+          <a:xfrm>
+            <a:off x="457200" y="914400"/>
+            <a:ext cx="8229600" cy="914400"/>
+          </a:xfrm>
+          <a:prstGeom prst="rect">
+            <a:avLst/>
+          </a:prstGeom>
+          <a:noFill/>
+        </p:spPr>
+        <p:txBody>
+          <a:bodyPr wrap="none">
+            <a:spAutoFit/>
+          </a:bodyPr>
+          <a:lstStyle/>
+          <a:p>
+            <a:pPr>
+              <a:defRPr sz="2400" b="1">
+                <a:solidFill>
+                  <a:srgbClr val="1E3A8A"/>
+                </a:solidFill>
+              </a:defRPr>
+            </a:pPr>
             <a:r>
               <a:t>GDCMAS - Gonzaga Dental Clinic Management Automation System</a:t>
             </a:r>
           </a:p>
-          <a:p>
-            <a:pPr lvl="1"/>
+        </p:txBody>
+      </p:sp>
+      <p:sp>
+        <p:nvSpPr>
+          <p:cNvPr id="5" name="TextBox 4"/>
+          <p:cNvSpPr txBox="1"/>
+          <p:nvPr/>
+        </p:nvSpPr>
+        <p:spPr>
+          <a:xfrm>
+            <a:off x="457200" y="2011680"/>
+            <a:ext cx="8229600" cy="3657600"/>
+          </a:xfrm>
+          <a:prstGeom prst="rect">
+            <a:avLst/>
+          </a:prstGeom>
+          <a:noFill/>
+        </p:spPr>
+        <p:txBody>
+          <a:bodyPr wrap="none">
+            <a:spAutoFit/>
+          </a:bodyPr>
+          <a:lstStyle/>
+          <a:p>
             <a:r>
               <a:t>A centralized, web-based system that digitizes:</a:t>
             </a:r>
           </a:p>
           <a:p>
-            <a:pPr lvl="2"/>
-            <a:r>
-              <a:t>• Patient Records Management - Centralized digital profiles</a:t>
-            </a:r>
-          </a:p>
-          <a:p>
-            <a:pPr lvl="2"/>
-            <a:r>
-              <a:t>• Treatment History Tracking - Digital dental chart with FDI notation</a:t>
-            </a:r>
-          </a:p>
-          <a:p>
-            <a:pPr lvl="2"/>
-            <a:r>
-              <a:t>• Appointment Scheduling - Automated slot generation</a:t>
-            </a:r>
-          </a:p>
-          <a:p>
-            <a:pPr lvl="2"/>
-            <a:r>
-              <a:t>• Consent Documentation - Digital versioned consent forms</a:t>
-            </a:r>
-          </a:p>
-          <a:p>
-            <a:pPr lvl="2"/>
-            <a:r>
-              <a:t>• Inter-Branch Access - Unified records across both branches</a:t>
-            </a:r>
-          </a:p>
-          <a:p>
-            <a:pPr lvl="2"/>
-            <a:r>
-              <a:t>• Role-Based Access Control - Secure, authorized access</a:t>
-            </a:r>
-          </a:p>
-          <a:p>
-            <a:pPr lvl="2"/>
-            <a:r>
-              <a:t>• Public Booking Portal - Online appointment requests</a:t>
+            <a:pPr lvl="1">
+              <a:defRPr sz="1800"/>
+            </a:pPr>
+            <a:r>
+              <a:t>• Patient Records Management | • Treatment History with FDI Tooth Chart</a:t>
+            </a:r>
+          </a:p>
+          <a:p>
+            <a:pPr lvl="1">
+              <a:defRPr sz="1800"/>
+            </a:pPr>
+            <a:r>
+              <a:t>• Appointment Scheduling &amp; Calendar Management | • Digital Consent Forms</a:t>
+            </a:r>
+          </a:p>
+          <a:p>
+            <a:pPr lvl="1">
+              <a:defRPr sz="1800"/>
+            </a:pPr>
+            <a:r>
+              <a:t>• Inter-Branch Access | • Role-Based Access Control</a:t>
+            </a:r>
+          </a:p>
+          <a:p>
+            <a:pPr lvl="1">
+              <a:defRPr sz="1800"/>
+            </a:pPr>
+            <a:r>
+              <a:t>• Public Patient Booking Portal | • Audit Logging &amp; Security</a:t>
             </a:r>
           </a:p>
         </p:txBody>
@@ -3658,38 +4189,102 @@
       <p:grpSpPr/>
       <p:sp>
         <p:nvSpPr>
-          <p:cNvPr id="2" name="Title 1"/>
-          <p:cNvSpPr>
-            <a:spLocks noGrp="1"/>
-          </p:cNvSpPr>
-          <p:nvPr>
-            <p:ph type="title"/>
-          </p:nvPr>
-        </p:nvSpPr>
-        <p:spPr/>
-        <p:txBody>
-          <a:bodyPr/>
-          <a:lstStyle/>
-          <a:p>
-            <a:r>
-              <a:t>Future-State Process (To-Be)</a:t>
-            </a:r>
-          </a:p>
-        </p:txBody>
-      </p:sp>
-      <p:sp>
-        <p:nvSpPr>
-          <p:cNvPr id="3" name="Content Placeholder 2"/>
-          <p:cNvSpPr>
-            <a:spLocks noGrp="1"/>
-          </p:cNvSpPr>
-          <p:nvPr>
-            <p:ph idx="1"/>
-          </p:nvPr>
-        </p:nvSpPr>
-        <p:spPr/>
-        <p:txBody>
-          <a:bodyPr/>
+          <p:cNvPr id="2" name="Rectangle 1"/>
+          <p:cNvSpPr/>
+          <p:nvPr/>
+        </p:nvSpPr>
+        <p:spPr>
+          <a:xfrm>
+            <a:off x="0" y="0"/>
+            <a:ext cx="9144000" cy="731520"/>
+          </a:xfrm>
+          <a:prstGeom prst="rect">
+            <a:avLst/>
+          </a:prstGeom>
+          <a:solidFill>
+            <a:srgbClr val="4A7A5C"/>
+          </a:solidFill>
+          <a:ln>
+            <a:noFill/>
+          </a:ln>
+        </p:spPr>
+        <p:style>
+          <a:lnRef idx="1">
+            <a:schemeClr val="accent1"/>
+          </a:lnRef>
+          <a:fillRef idx="3">
+            <a:schemeClr val="accent1"/>
+          </a:fillRef>
+          <a:effectRef idx="2">
+            <a:schemeClr val="accent1"/>
+          </a:effectRef>
+          <a:fontRef idx="minor">
+            <a:schemeClr val="lt1"/>
+          </a:fontRef>
+        </p:style>
+        <p:txBody>
+          <a:bodyPr rtlCol="0" anchor="ctr"/>
+          <a:lstStyle/>
+          <a:p>
+            <a:pPr algn="ctr"/>
+          </a:p>
+        </p:txBody>
+      </p:sp>
+      <p:sp>
+        <p:nvSpPr>
+          <p:cNvPr id="3" name="TextBox 2"/>
+          <p:cNvSpPr txBox="1"/>
+          <p:nvPr/>
+        </p:nvSpPr>
+        <p:spPr>
+          <a:xfrm>
+            <a:off x="457200" y="91440"/>
+            <a:ext cx="8229600" cy="548640"/>
+          </a:xfrm>
+          <a:prstGeom prst="rect">
+            <a:avLst/>
+          </a:prstGeom>
+          <a:noFill/>
+        </p:spPr>
+        <p:txBody>
+          <a:bodyPr wrap="none">
+            <a:spAutoFit/>
+          </a:bodyPr>
+          <a:lstStyle/>
+          <a:p>
+            <a:pPr>
+              <a:defRPr sz="2800" b="1">
+                <a:solidFill>
+                  <a:srgbClr val="FFFFFF"/>
+                </a:solidFill>
+              </a:defRPr>
+            </a:pPr>
+            <a:r>
+              <a:t>FUTURE-STATE PROCESS (TO-BE)</a:t>
+            </a:r>
+          </a:p>
+        </p:txBody>
+      </p:sp>
+      <p:sp>
+        <p:nvSpPr>
+          <p:cNvPr id="4" name="TextBox 3"/>
+          <p:cNvSpPr txBox="1"/>
+          <p:nvPr/>
+        </p:nvSpPr>
+        <p:spPr>
+          <a:xfrm>
+            <a:off x="457200" y="1097280"/>
+            <a:ext cx="8229600" cy="4572000"/>
+          </a:xfrm>
+          <a:prstGeom prst="rect">
+            <a:avLst/>
+          </a:prstGeom>
+          <a:noFill/>
+        </p:spPr>
+        <p:txBody>
+          <a:bodyPr wrap="none">
+            <a:spAutoFit/>
+          </a:bodyPr>
           <a:lstStyle/>
           <a:p>
             <a:r>
@@ -3697,39 +4292,55 @@
             </a:r>
           </a:p>
           <a:p>
-            <a:pPr lvl="1"/>
+            <a:pPr lvl="1">
+              <a:defRPr sz="1800"/>
+            </a:pPr>
             <a:r>
               <a:t>2. Appointment Booking → Schedule with automatic availability checking</a:t>
             </a:r>
           </a:p>
           <a:p>
-            <a:pPr lvl="1"/>
+            <a:pPr lvl="1">
+              <a:defRPr sz="1800"/>
+            </a:pPr>
             <a:r>
               <a:t>3. Consultation &amp; Treatment → Access digital records, update via digital tooth chart</a:t>
             </a:r>
           </a:p>
           <a:p>
-            <a:pPr lvl="1"/>
-            <a:r>
-              <a:t>4. Record Management → All data automatically stored and synced</a:t>
-            </a:r>
-          </a:p>
-          <a:p>
-            <a:pPr lvl="1"/>
+            <a:pPr lvl="1">
+              <a:defRPr sz="1800"/>
+            </a:pPr>
+            <a:r>
+              <a:t>4. Record Management → All data automatically stored and synced across branches</a:t>
+            </a:r>
+          </a:p>
+          <a:p>
+            <a:pPr lvl="1">
+              <a:defRPr sz="1800"/>
+            </a:pPr>
             <a:r>
               <a:t>5. Consent Documentation → Digital consent captured with audit trail</a:t>
             </a:r>
           </a:p>
           <a:p>
-            <a:pPr lvl="1"/>
-            <a:r>
-              <a:t>6. Reporting &amp; Monitoring → Real-time overview of appointments</a:t>
-            </a:r>
-          </a:p>
-          <a:p>
-            <a:pPr lvl="1"/>
-            <a:r>
-              <a:t>Key Improvement: Standardized, automated, and centralized process</a:t>
+            <a:pPr lvl="1">
+              <a:defRPr sz="1800"/>
+            </a:pPr>
+            <a:r>
+              <a:t>6. Reporting &amp; Monitoring → Real-time overview of appointments and operations</a:t>
+            </a:r>
+          </a:p>
+          <a:p>
+            <a:pPr lvl="1">
+              <a:defRPr sz="2000" b="1">
+                <a:solidFill>
+                  <a:srgbClr val="4A7A5C"/>
+                </a:solidFill>
+              </a:defRPr>
+            </a:pPr>
+            <a:r>
+              <a:t>Key Improvement: Standardized, automated, and centralized process with full traceability</a:t>
             </a:r>
           </a:p>
         </p:txBody>
@@ -3754,84 +4365,182 @@
       <p:grpSpPr/>
       <p:sp>
         <p:nvSpPr>
-          <p:cNvPr id="2" name="Title 1"/>
-          <p:cNvSpPr>
-            <a:spLocks noGrp="1"/>
-          </p:cNvSpPr>
-          <p:nvPr>
-            <p:ph type="title"/>
-          </p:nvPr>
-        </p:nvSpPr>
-        <p:spPr/>
-        <p:txBody>
-          <a:bodyPr/>
-          <a:lstStyle/>
-          <a:p>
-            <a:r>
-              <a:t>Business Benefits</a:t>
-            </a:r>
-          </a:p>
-        </p:txBody>
-      </p:sp>
-      <p:sp>
-        <p:nvSpPr>
-          <p:cNvPr id="3" name="Content Placeholder 2"/>
-          <p:cNvSpPr>
-            <a:spLocks noGrp="1"/>
-          </p:cNvSpPr>
-          <p:nvPr>
-            <p:ph idx="1"/>
-          </p:nvPr>
-        </p:nvSpPr>
-        <p:spPr/>
-        <p:txBody>
-          <a:bodyPr/>
-          <a:lstStyle/>
-          <a:p>
-            <a:r>
-              <a:t>• Centralization - Single source of truth across both branches</a:t>
-            </a:r>
-          </a:p>
-          <a:p>
-            <a:pPr lvl="1"/>
-            <a:r>
-              <a:t>• Accessibility - Instant access to patient records</a:t>
-            </a:r>
-          </a:p>
-          <a:p>
-            <a:pPr lvl="1"/>
-            <a:r>
-              <a:t>• Efficiency - Faster retrieval, automated scheduling</a:t>
-            </a:r>
-          </a:p>
-          <a:p>
-            <a:pPr lvl="1"/>
-            <a:r>
-              <a:t>• Accountability - Complete audit trail</a:t>
-            </a:r>
-          </a:p>
-          <a:p>
-            <a:pPr lvl="1"/>
-            <a:r>
-              <a:t>• Data Security - Multi-layered security with RLS</a:t>
-            </a:r>
-          </a:p>
-          <a:p>
-            <a:pPr lvl="1"/>
-            <a:r>
-              <a:t>• Accuracy - Duplicate detection prevents fragmented histories</a:t>
-            </a:r>
-          </a:p>
-          <a:p>
-            <a:pPr lvl="1"/>
-            <a:r>
-              <a:t>• Convenience - Public booking portal for patients</a:t>
-            </a:r>
-          </a:p>
-          <a:p>
-            <a:pPr lvl="1"/>
-            <a:r>
-              <a:t>• Data Integrity - Structured, validated records</a:t>
+          <p:cNvPr id="2" name="Rectangle 1"/>
+          <p:cNvSpPr/>
+          <p:nvPr/>
+        </p:nvSpPr>
+        <p:spPr>
+          <a:xfrm>
+            <a:off x="0" y="0"/>
+            <a:ext cx="9144000" cy="731520"/>
+          </a:xfrm>
+          <a:prstGeom prst="rect">
+            <a:avLst/>
+          </a:prstGeom>
+          <a:solidFill>
+            <a:srgbClr val="4A7A5C"/>
+          </a:solidFill>
+          <a:ln>
+            <a:noFill/>
+          </a:ln>
+        </p:spPr>
+        <p:style>
+          <a:lnRef idx="1">
+            <a:schemeClr val="accent1"/>
+          </a:lnRef>
+          <a:fillRef idx="3">
+            <a:schemeClr val="accent1"/>
+          </a:fillRef>
+          <a:effectRef idx="2">
+            <a:schemeClr val="accent1"/>
+          </a:effectRef>
+          <a:fontRef idx="minor">
+            <a:schemeClr val="lt1"/>
+          </a:fontRef>
+        </p:style>
+        <p:txBody>
+          <a:bodyPr rtlCol="0" anchor="ctr"/>
+          <a:lstStyle/>
+          <a:p>
+            <a:pPr algn="ctr"/>
+          </a:p>
+        </p:txBody>
+      </p:sp>
+      <p:sp>
+        <p:nvSpPr>
+          <p:cNvPr id="3" name="TextBox 2"/>
+          <p:cNvSpPr txBox="1"/>
+          <p:nvPr/>
+        </p:nvSpPr>
+        <p:spPr>
+          <a:xfrm>
+            <a:off x="457200" y="91440"/>
+            <a:ext cx="8229600" cy="548640"/>
+          </a:xfrm>
+          <a:prstGeom prst="rect">
+            <a:avLst/>
+          </a:prstGeom>
+          <a:noFill/>
+        </p:spPr>
+        <p:txBody>
+          <a:bodyPr wrap="none">
+            <a:spAutoFit/>
+          </a:bodyPr>
+          <a:lstStyle/>
+          <a:p>
+            <a:pPr>
+              <a:defRPr sz="3200" b="1">
+                <a:solidFill>
+                  <a:srgbClr val="FFFFFF"/>
+                </a:solidFill>
+              </a:defRPr>
+            </a:pPr>
+            <a:r>
+              <a:t>BUSINESS BENEFITS</a:t>
+            </a:r>
+          </a:p>
+        </p:txBody>
+      </p:sp>
+      <p:sp>
+        <p:nvSpPr>
+          <p:cNvPr id="4" name="TextBox 3"/>
+          <p:cNvSpPr txBox="1"/>
+          <p:nvPr/>
+        </p:nvSpPr>
+        <p:spPr>
+          <a:xfrm>
+            <a:off x="457200" y="1097280"/>
+            <a:ext cx="4114800" cy="4572000"/>
+          </a:xfrm>
+          <a:prstGeom prst="rect">
+            <a:avLst/>
+          </a:prstGeom>
+          <a:noFill/>
+        </p:spPr>
+        <p:txBody>
+          <a:bodyPr wrap="none">
+            <a:spAutoFit/>
+          </a:bodyPr>
+          <a:lstStyle/>
+          <a:p>
+            <a:r>
+              <a:t>• Centralization</a:t>
+            </a:r>
+          </a:p>
+          <a:p>
+            <a:pPr lvl="1">
+              <a:defRPr sz="2200"/>
+            </a:pPr>
+            <a:r>
+              <a:t>• Accessibility</a:t>
+            </a:r>
+          </a:p>
+          <a:p>
+            <a:pPr lvl="1">
+              <a:defRPr sz="2200"/>
+            </a:pPr>
+            <a:r>
+              <a:t>• Efficiency</a:t>
+            </a:r>
+          </a:p>
+          <a:p>
+            <a:pPr lvl="1">
+              <a:defRPr sz="2200"/>
+            </a:pPr>
+            <a:r>
+              <a:t>• Accountability</a:t>
+            </a:r>
+          </a:p>
+        </p:txBody>
+      </p:sp>
+      <p:sp>
+        <p:nvSpPr>
+          <p:cNvPr id="5" name="TextBox 4"/>
+          <p:cNvSpPr txBox="1"/>
+          <p:nvPr/>
+        </p:nvSpPr>
+        <p:spPr>
+          <a:xfrm>
+            <a:off x="4572000" y="1097280"/>
+            <a:ext cx="4114800" cy="4572000"/>
+          </a:xfrm>
+          <a:prstGeom prst="rect">
+            <a:avLst/>
+          </a:prstGeom>
+          <a:noFill/>
+        </p:spPr>
+        <p:txBody>
+          <a:bodyPr wrap="none">
+            <a:spAutoFit/>
+          </a:bodyPr>
+          <a:lstStyle/>
+          <a:p>
+            <a:r>
+              <a:t>• Data Security</a:t>
+            </a:r>
+          </a:p>
+          <a:p>
+            <a:pPr lvl="1">
+              <a:defRPr sz="2200"/>
+            </a:pPr>
+            <a:r>
+              <a:t>• Accuracy</a:t>
+            </a:r>
+          </a:p>
+          <a:p>
+            <a:pPr lvl="1">
+              <a:defRPr sz="2200"/>
+            </a:pPr>
+            <a:r>
+              <a:t>• Convenience</a:t>
+            </a:r>
+          </a:p>
+          <a:p>
+            <a:pPr lvl="1">
+              <a:defRPr sz="2200"/>
+            </a:pPr>
+            <a:r>
+              <a:t>• Data Integrity</a:t>
             </a:r>
           </a:p>
         </p:txBody>
@@ -3856,38 +4565,102 @@
       <p:grpSpPr/>
       <p:sp>
         <p:nvSpPr>
-          <p:cNvPr id="2" name="Title 1"/>
-          <p:cNvSpPr>
-            <a:spLocks noGrp="1"/>
-          </p:cNvSpPr>
-          <p:nvPr>
-            <p:ph type="title"/>
-          </p:nvPr>
-        </p:nvSpPr>
-        <p:spPr/>
-        <p:txBody>
-          <a:bodyPr/>
-          <a:lstStyle/>
-          <a:p>
-            <a:r>
-              <a:t>Technology Stack &amp; Security</a:t>
-            </a:r>
-          </a:p>
-        </p:txBody>
-      </p:sp>
-      <p:sp>
-        <p:nvSpPr>
-          <p:cNvPr id="3" name="Content Placeholder 2"/>
-          <p:cNvSpPr>
-            <a:spLocks noGrp="1"/>
-          </p:cNvSpPr>
-          <p:nvPr>
-            <p:ph idx="1"/>
-          </p:nvPr>
-        </p:nvSpPr>
-        <p:spPr/>
-        <p:txBody>
-          <a:bodyPr/>
+          <p:cNvPr id="2" name="Rectangle 1"/>
+          <p:cNvSpPr/>
+          <p:nvPr/>
+        </p:nvSpPr>
+        <p:spPr>
+          <a:xfrm>
+            <a:off x="0" y="0"/>
+            <a:ext cx="9144000" cy="731520"/>
+          </a:xfrm>
+          <a:prstGeom prst="rect">
+            <a:avLst/>
+          </a:prstGeom>
+          <a:solidFill>
+            <a:srgbClr val="4A7A5C"/>
+          </a:solidFill>
+          <a:ln>
+            <a:noFill/>
+          </a:ln>
+        </p:spPr>
+        <p:style>
+          <a:lnRef idx="1">
+            <a:schemeClr val="accent1"/>
+          </a:lnRef>
+          <a:fillRef idx="3">
+            <a:schemeClr val="accent1"/>
+          </a:fillRef>
+          <a:effectRef idx="2">
+            <a:schemeClr val="accent1"/>
+          </a:effectRef>
+          <a:fontRef idx="minor">
+            <a:schemeClr val="lt1"/>
+          </a:fontRef>
+        </p:style>
+        <p:txBody>
+          <a:bodyPr rtlCol="0" anchor="ctr"/>
+          <a:lstStyle/>
+          <a:p>
+            <a:pPr algn="ctr"/>
+          </a:p>
+        </p:txBody>
+      </p:sp>
+      <p:sp>
+        <p:nvSpPr>
+          <p:cNvPr id="3" name="TextBox 2"/>
+          <p:cNvSpPr txBox="1"/>
+          <p:nvPr/>
+        </p:nvSpPr>
+        <p:spPr>
+          <a:xfrm>
+            <a:off x="457200" y="91440"/>
+            <a:ext cx="8229600" cy="548640"/>
+          </a:xfrm>
+          <a:prstGeom prst="rect">
+            <a:avLst/>
+          </a:prstGeom>
+          <a:noFill/>
+        </p:spPr>
+        <p:txBody>
+          <a:bodyPr wrap="none">
+            <a:spAutoFit/>
+          </a:bodyPr>
+          <a:lstStyle/>
+          <a:p>
+            <a:pPr>
+              <a:defRPr sz="2800" b="1">
+                <a:solidFill>
+                  <a:srgbClr val="FFFFFF"/>
+                </a:solidFill>
+              </a:defRPr>
+            </a:pPr>
+            <a:r>
+              <a:t>TECHNOLOGY STACK &amp; SECURITY</a:t>
+            </a:r>
+          </a:p>
+        </p:txBody>
+      </p:sp>
+      <p:sp>
+        <p:nvSpPr>
+          <p:cNvPr id="4" name="TextBox 3"/>
+          <p:cNvSpPr txBox="1"/>
+          <p:nvPr/>
+        </p:nvSpPr>
+        <p:spPr>
+          <a:xfrm>
+            <a:off x="457200" y="914400"/>
+            <a:ext cx="8229600" cy="1828800"/>
+          </a:xfrm>
+          <a:prstGeom prst="rect">
+            <a:avLst/>
+          </a:prstGeom>
+          <a:noFill/>
+        </p:spPr>
+        <p:txBody>
+          <a:bodyPr wrap="none">
+            <a:spAutoFit/>
+          </a:bodyPr>
           <a:lstStyle/>
           <a:p>
             <a:r>
@@ -3895,49 +4668,89 @@
             </a:r>
           </a:p>
           <a:p>
-            <a:pPr lvl="2"/>
+            <a:pPr lvl="2">
+              <a:defRPr sz="1800"/>
+            </a:pPr>
             <a:r>
               <a:t>• Frontend: Next.js 16, React 19, TypeScript, Tailwind CSS 4</a:t>
             </a:r>
           </a:p>
           <a:p>
-            <a:pPr lvl="2"/>
-            <a:r>
-              <a:t>• Backend/Database: Supabase (PostgreSQL, Auth, RLS)</a:t>
-            </a:r>
-          </a:p>
-          <a:p>
-            <a:pPr lvl="2"/>
+            <a:pPr lvl="2">
+              <a:defRPr sz="1800"/>
+            </a:pPr>
+            <a:r>
+              <a:t>• Backend/Database: Supabase (PostgreSQL, Auth, Row Level Security)</a:t>
+            </a:r>
+          </a:p>
+          <a:p>
+            <a:pPr lvl="2">
+              <a:defRPr sz="1800"/>
+            </a:pPr>
             <a:r>
               <a:t>• Validation: Zod</a:t>
             </a:r>
           </a:p>
-          <a:p>
-            <a:pPr lvl="1"/>
-            <a:r>
-              <a:t>Security Measures (3-Layer Protection):</a:t>
-            </a:r>
-          </a:p>
-          <a:p>
-            <a:pPr lvl="2"/>
-            <a:r>
-              <a:t>1. Proxy Layer - Initial session check</a:t>
-            </a:r>
-          </a:p>
-          <a:p>
-            <a:pPr lvl="2"/>
-            <a:r>
-              <a:t>2. Server Layer - Database-validated session &amp; role checking</a:t>
-            </a:r>
-          </a:p>
-          <a:p>
-            <a:pPr lvl="2"/>
-            <a:r>
-              <a:t>3. Database Layer (RLS) - Row Level Security as real boundary</a:t>
-            </a:r>
-          </a:p>
-          <a:p>
-            <a:pPr lvl="1"/>
+        </p:txBody>
+      </p:sp>
+      <p:sp>
+        <p:nvSpPr>
+          <p:cNvPr id="5" name="TextBox 4"/>
+          <p:cNvSpPr txBox="1"/>
+          <p:nvPr/>
+        </p:nvSpPr>
+        <p:spPr>
+          <a:xfrm>
+            <a:off x="457200" y="2926080"/>
+            <a:ext cx="8229600" cy="2743200"/>
+          </a:xfrm>
+          <a:prstGeom prst="rect">
+            <a:avLst/>
+          </a:prstGeom>
+          <a:noFill/>
+        </p:spPr>
+        <p:txBody>
+          <a:bodyPr wrap="none">
+            <a:spAutoFit/>
+          </a:bodyPr>
+          <a:lstStyle/>
+          <a:p>
+            <a:r>
+              <a:t>3-Layer Security Protection:</a:t>
+            </a:r>
+          </a:p>
+          <a:p>
+            <a:pPr lvl="1">
+              <a:defRPr sz="1600"/>
+            </a:pPr>
+            <a:r>
+              <a:t>1. Proxy Layer - Fast redirect for unauthenticated sessions</a:t>
+            </a:r>
+          </a:p>
+          <a:p>
+            <a:pPr lvl="1">
+              <a:defRPr sz="1600"/>
+            </a:pPr>
+            <a:r>
+              <a:t>2. Server Layer - Database-validated sessions &amp; role checking</a:t>
+            </a:r>
+          </a:p>
+          <a:p>
+            <a:pPr lvl="1">
+              <a:defRPr sz="1600"/>
+            </a:pPr>
+            <a:r>
+              <a:t>3. Database Layer (RLS) - Row Level Security as the real boundary</a:t>
+            </a:r>
+          </a:p>
+          <a:p>
+            <a:pPr lvl="1">
+              <a:defRPr sz="1800" b="1">
+                <a:solidFill>
+                  <a:srgbClr val="4A7A5C"/>
+                </a:solidFill>
+              </a:defRPr>
+            </a:pPr>
             <a:r>
               <a:t>User Roles: Dentist | Secretary | Administrator</a:t>
             </a:r>
@@ -3964,70 +4777,156 @@
       <p:grpSpPr/>
       <p:sp>
         <p:nvSpPr>
-          <p:cNvPr id="2" name="Title 1"/>
-          <p:cNvSpPr>
-            <a:spLocks noGrp="1"/>
-          </p:cNvSpPr>
-          <p:nvPr>
-            <p:ph type="title"/>
-          </p:nvPr>
-        </p:nvSpPr>
-        <p:spPr/>
-        <p:txBody>
-          <a:bodyPr/>
-          <a:lstStyle/>
-          <a:p>
-            <a:r>
-              <a:t>Conclusion</a:t>
-            </a:r>
-          </a:p>
-        </p:txBody>
-      </p:sp>
-      <p:sp>
-        <p:nvSpPr>
-          <p:cNvPr id="3" name="Content Placeholder 2"/>
-          <p:cNvSpPr>
-            <a:spLocks noGrp="1"/>
-          </p:cNvSpPr>
-          <p:nvPr>
-            <p:ph idx="1"/>
-          </p:nvPr>
-        </p:nvSpPr>
-        <p:spPr/>
-        <p:txBody>
-          <a:bodyPr/>
-          <a:lstStyle/>
-          <a:p>
-            <a:r>
-              <a:t>• Process Standardization: The issue is lack of standardized, centralized process</a:t>
-            </a:r>
-          </a:p>
-          <a:p>
-            <a:pPr lvl="1"/>
+          <p:cNvPr id="2" name="Rectangle 1"/>
+          <p:cNvSpPr/>
+          <p:nvPr/>
+        </p:nvSpPr>
+        <p:spPr>
+          <a:xfrm>
+            <a:off x="0" y="0"/>
+            <a:ext cx="9144000" cy="731520"/>
+          </a:xfrm>
+          <a:prstGeom prst="rect">
+            <a:avLst/>
+          </a:prstGeom>
+          <a:solidFill>
+            <a:srgbClr val="4A7A5C"/>
+          </a:solidFill>
+          <a:ln>
+            <a:noFill/>
+          </a:ln>
+        </p:spPr>
+        <p:style>
+          <a:lnRef idx="1">
+            <a:schemeClr val="accent1"/>
+          </a:lnRef>
+          <a:fillRef idx="3">
+            <a:schemeClr val="accent1"/>
+          </a:fillRef>
+          <a:effectRef idx="2">
+            <a:schemeClr val="accent1"/>
+          </a:effectRef>
+          <a:fontRef idx="minor">
+            <a:schemeClr val="lt1"/>
+          </a:fontRef>
+        </p:style>
+        <p:txBody>
+          <a:bodyPr rtlCol="0" anchor="ctr"/>
+          <a:lstStyle/>
+          <a:p>
+            <a:pPr algn="ctr"/>
+          </a:p>
+        </p:txBody>
+      </p:sp>
+      <p:sp>
+        <p:nvSpPr>
+          <p:cNvPr id="3" name="TextBox 2"/>
+          <p:cNvSpPr txBox="1"/>
+          <p:nvPr/>
+        </p:nvSpPr>
+        <p:spPr>
+          <a:xfrm>
+            <a:off x="457200" y="91440"/>
+            <a:ext cx="8229600" cy="548640"/>
+          </a:xfrm>
+          <a:prstGeom prst="rect">
+            <a:avLst/>
+          </a:prstGeom>
+          <a:noFill/>
+        </p:spPr>
+        <p:txBody>
+          <a:bodyPr wrap="none">
+            <a:spAutoFit/>
+          </a:bodyPr>
+          <a:lstStyle/>
+          <a:p>
+            <a:pPr>
+              <a:defRPr sz="3200" b="1">
+                <a:solidFill>
+                  <a:srgbClr val="FFFFFF"/>
+                </a:solidFill>
+              </a:defRPr>
+            </a:pPr>
+            <a:r>
+              <a:t>CONCLUSION</a:t>
+            </a:r>
+          </a:p>
+        </p:txBody>
+      </p:sp>
+      <p:sp>
+        <p:nvSpPr>
+          <p:cNvPr id="4" name="TextBox 3"/>
+          <p:cNvSpPr txBox="1"/>
+          <p:nvPr/>
+        </p:nvSpPr>
+        <p:spPr>
+          <a:xfrm>
+            <a:off x="457200" y="1097280"/>
+            <a:ext cx="8229600" cy="4572000"/>
+          </a:xfrm>
+          <a:prstGeom prst="rect">
+            <a:avLst/>
+          </a:prstGeom>
+          <a:noFill/>
+        </p:spPr>
+        <p:txBody>
+          <a:bodyPr wrap="none">
+            <a:spAutoFit/>
+          </a:bodyPr>
+          <a:lstStyle/>
+          <a:p>
+            <a:r>
+              <a:t>• The problem is not just absence of software, but lack of a standardized process</a:t>
+            </a:r>
+          </a:p>
+          <a:p>
+            <a:pPr lvl="1">
+              <a:defRPr sz="1800"/>
+            </a:pPr>
             <a:r>
               <a:t>• Business Process Automation: Standardize first, then automate with technology</a:t>
             </a:r>
           </a:p>
           <a:p>
-            <a:pPr lvl="1"/>
-            <a:r>
-              <a:t>• Improved Operations: Enhances efficiency, accessibility, security, and accountability</a:t>
-            </a:r>
-          </a:p>
-          <a:p>
-            <a:pPr lvl="1"/>
-            <a:r>
-              <a:t>• Better Patient Care: Enables continuity of care across both branches</a:t>
-            </a:r>
-          </a:p>
-          <a:p>
-            <a:pPr lvl="1"/>
-            <a:r>
-              <a:t>• Ready for Implementation: Solid foundation for digital transformation</a:t>
-            </a:r>
-          </a:p>
-          <a:p>
-            <a:pPr lvl="1"/>
+            <a:pPr lvl="1">
+              <a:defRPr sz="1800"/>
+            </a:pPr>
+            <a:r>
+              <a:t>• GDCMAS addresses all identified issues through centralization and automation</a:t>
+            </a:r>
+          </a:p>
+          <a:p>
+            <a:pPr lvl="1">
+              <a:defRPr sz="1800"/>
+            </a:pPr>
+            <a:r>
+              <a:t>• Improves efficiency, accessibility, security, accountability, and patient care</a:t>
+            </a:r>
+          </a:p>
+          <a:p>
+            <a:pPr lvl="1">
+              <a:defRPr sz="1800"/>
+            </a:pPr>
+            <a:r>
+              <a:t>• Enables better continuity of care across both branches</a:t>
+            </a:r>
+          </a:p>
+          <a:p>
+            <a:pPr lvl="1">
+              <a:defRPr sz="1800"/>
+            </a:pPr>
+            <a:r>
+              <a:t>• Provides a solid foundation for the clinic's digital transformation</a:t>
+            </a:r>
+          </a:p>
+          <a:p>
+            <a:pPr lvl="1">
+              <a:defRPr sz="1600" i="1">
+                <a:solidFill>
+                  <a:srgbClr val="4A7A5C"/>
+                </a:solidFill>
+              </a:defRPr>
+            </a:pPr>
             <a:r>
               <a:t>"Business Process Automation allows the organization to standardize the process first and then use technology to support and automate it."</a:t>
             </a:r>

</xml_diff>

<commit_message>
Update defense presentation with improved content and design
</commit_message>
<xml_diff>
--- a/GDCMAS_Final_Defense_Presentation.pptx
+++ b/GDCMAS_Final_Defense_Presentation.pptx
@@ -3106,7 +3106,7 @@
         <p:spPr>
           <a:xfrm>
             <a:off x="0" y="0"/>
-            <a:ext cx="9144000" cy="1097280"/>
+            <a:ext cx="9144000" cy="1188720"/>
           </a:xfrm>
           <a:prstGeom prst="rect">
             <a:avLst/>
@@ -3148,8 +3148,8 @@
         </p:nvSpPr>
         <p:spPr>
           <a:xfrm>
-            <a:off x="457200" y="1371600"/>
-            <a:ext cx="8229600" cy="1371600"/>
+            <a:off x="274320" y="1463040"/>
+            <a:ext cx="8595360" cy="1828800"/>
           </a:xfrm>
           <a:prstGeom prst="rect">
             <a:avLst/>
@@ -3163,7 +3163,10 @@
           <a:lstStyle/>
           <a:p>
             <a:pPr algn="ctr">
-              <a:defRPr sz="3200" b="1">
+              <a:lnSpc>
+                <a:spcPct val="120000"/>
+              </a:lnSpc>
+              <a:defRPr sz="2800" b="1">
                 <a:solidFill>
                   <a:srgbClr val="1E3A8A"/>
                 </a:solidFill>
@@ -3183,8 +3186,8 @@
         </p:nvSpPr>
         <p:spPr>
           <a:xfrm>
-            <a:off x="457200" y="2926080"/>
-            <a:ext cx="8229600" cy="914400"/>
+            <a:off x="274320" y="3474720"/>
+            <a:ext cx="8595360" cy="1097280"/>
           </a:xfrm>
           <a:prstGeom prst="rect">
             <a:avLst/>
@@ -3198,7 +3201,11 @@
           <a:lstStyle/>
           <a:p>
             <a:pPr algn="ctr">
-              <a:defRPr sz="1800"/>
+              <a:defRPr sz="1600">
+                <a:solidFill>
+                  <a:srgbClr val="333333"/>
+                </a:solidFill>
+              </a:defRPr>
             </a:pPr>
             <a:r>
               <a:t>A Business Process Automation Plan for Streamlining Patient Records,</a:t>
@@ -3219,8 +3226,8 @@
         </p:nvSpPr>
         <p:spPr>
           <a:xfrm>
-            <a:off x="457200" y="4114800"/>
-            <a:ext cx="8229600" cy="1371600"/>
+            <a:off x="274320" y="4754880"/>
+            <a:ext cx="8595360" cy="1371600"/>
           </a:xfrm>
           <a:prstGeom prst="rect">
             <a:avLst/>
@@ -3234,7 +3241,7 @@
           <a:lstStyle/>
           <a:p>
             <a:pPr algn="ctr">
-              <a:defRPr sz="1600"/>
+              <a:defRPr sz="1400"/>
             </a:pPr>
             <a:r>
               <a:t>Amor, Khent Vincent C. | Galve, Fritz Michael G. | Gayem, Vince</a:t>
@@ -3260,8 +3267,8 @@
         </p:nvSpPr>
         <p:spPr>
           <a:xfrm>
-            <a:off x="457200" y="5486400"/>
-            <a:ext cx="8229600" cy="731520"/>
+            <a:off x="274320" y="6217920"/>
+            <a:ext cx="8595360" cy="548640"/>
           </a:xfrm>
           <a:prstGeom prst="rect">
             <a:avLst/>
@@ -3275,7 +3282,11 @@
           <a:lstStyle/>
           <a:p>
             <a:pPr algn="ctr">
-              <a:defRPr sz="1400"/>
+              <a:defRPr sz="1200">
+                <a:solidFill>
+                  <a:srgbClr val="4A7A5C"/>
+                </a:solidFill>
+              </a:defRPr>
             </a:pPr>
             <a:r>
               <a:t>PHINMA University of Iloilo | College of Information Technology Education | October 2026</a:t>
@@ -3310,7 +3321,7 @@
         <p:spPr>
           <a:xfrm>
             <a:off x="0" y="0"/>
-            <a:ext cx="9144000" cy="1371600"/>
+            <a:ext cx="9144000" cy="822960"/>
           </a:xfrm>
           <a:prstGeom prst="rect">
             <a:avLst/>
@@ -3352,8 +3363,8 @@
         </p:nvSpPr>
         <p:spPr>
           <a:xfrm>
-            <a:off x="457200" y="1828800"/>
-            <a:ext cx="8229600" cy="914400"/>
+            <a:off x="457200" y="137160"/>
+            <a:ext cx="8229600" cy="640080"/>
           </a:xfrm>
           <a:prstGeom prst="rect">
             <a:avLst/>
@@ -3366,8 +3377,111 @@
           </a:bodyPr>
           <a:lstStyle/>
           <a:p>
+            <a:pPr>
+              <a:defRPr sz="3200" b="1">
+                <a:solidFill>
+                  <a:srgbClr val="FFFFFF"/>
+                </a:solidFill>
+              </a:defRPr>
+            </a:pPr>
+            <a:r>
+              <a:t>CONCLUSION</a:t>
+            </a:r>
+          </a:p>
+        </p:txBody>
+      </p:sp>
+      <p:sp>
+        <p:nvSpPr>
+          <p:cNvPr id="4" name="TextBox 3"/>
+          <p:cNvSpPr txBox="1"/>
+          <p:nvPr/>
+        </p:nvSpPr>
+        <p:spPr>
+          <a:xfrm>
+            <a:off x="548640" y="1188720"/>
+            <a:ext cx="8046720" cy="3200400"/>
+          </a:xfrm>
+          <a:prstGeom prst="rect">
+            <a:avLst/>
+          </a:prstGeom>
+          <a:noFill/>
+        </p:spPr>
+        <p:txBody>
+          <a:bodyPr wrap="none">
+            <a:spAutoFit/>
+          </a:bodyPr>
+          <a:lstStyle/>
+          <a:p>
+            <a:r>
+              <a:t>• The problem is the lack of a standardized, centralized process - NOT just software</a:t>
+            </a:r>
+          </a:p>
+          <a:p>
+            <a:pPr lvl="1">
+              <a:defRPr sz="1700"/>
+            </a:pPr>
+            <a:r>
+              <a:t>• GDCMAS standardizes the workflow first, then automates it through technology</a:t>
+            </a:r>
+          </a:p>
+          <a:p>
+            <a:pPr lvl="1">
+              <a:defRPr sz="1700"/>
+            </a:pPr>
+            <a:r>
+              <a:t>• Successfully addresses all identified issues in clinic operations</a:t>
+            </a:r>
+          </a:p>
+          <a:p>
+            <a:pPr lvl="1">
+              <a:defRPr sz="1700"/>
+            </a:pPr>
+            <a:r>
+              <a:t>• Improves efficiency, accessibility, security, accountability &amp; patient care</a:t>
+            </a:r>
+          </a:p>
+          <a:p>
+            <a:pPr lvl="1">
+              <a:defRPr sz="1700"/>
+            </a:pPr>
+            <a:r>
+              <a:t>• Provides a solid foundation for the clinic's digital transformation</a:t>
+            </a:r>
+          </a:p>
+          <a:p>
+            <a:pPr lvl="1">
+              <a:defRPr sz="1700"/>
+            </a:pPr>
+            <a:r>
+              <a:t>• Ready for implementation with proper validation and training</a:t>
+            </a:r>
+          </a:p>
+        </p:txBody>
+      </p:sp>
+      <p:sp>
+        <p:nvSpPr>
+          <p:cNvPr id="5" name="TextBox 4"/>
+          <p:cNvSpPr txBox="1"/>
+          <p:nvPr/>
+        </p:nvSpPr>
+        <p:spPr>
+          <a:xfrm>
+            <a:off x="457200" y="4754880"/>
+            <a:ext cx="8229600" cy="1371600"/>
+          </a:xfrm>
+          <a:prstGeom prst="rect">
+            <a:avLst/>
+          </a:prstGeom>
+          <a:noFill/>
+        </p:spPr>
+        <p:txBody>
+          <a:bodyPr wrap="none">
+            <a:spAutoFit/>
+          </a:bodyPr>
+          <a:lstStyle/>
+          <a:p>
             <a:pPr algn="ctr">
-              <a:defRPr sz="6000" b="1">
+              <a:defRPr sz="4000" b="1">
                 <a:solidFill>
                   <a:srgbClr val="1E3A8A"/>
                 </a:solidFill>
@@ -3377,71 +3491,21 @@
               <a:t>THANK YOU!</a:t>
             </a:r>
           </a:p>
-        </p:txBody>
-      </p:sp>
-      <p:sp>
-        <p:nvSpPr>
-          <p:cNvPr id="4" name="TextBox 3"/>
-          <p:cNvSpPr txBox="1"/>
-          <p:nvPr/>
-        </p:nvSpPr>
-        <p:spPr>
-          <a:xfrm>
-            <a:off x="457200" y="3200400"/>
-            <a:ext cx="8229600" cy="914400"/>
-          </a:xfrm>
-          <a:prstGeom prst="rect">
-            <a:avLst/>
-          </a:prstGeom>
-          <a:noFill/>
-        </p:spPr>
-        <p:txBody>
-          <a:bodyPr wrap="none">
-            <a:spAutoFit/>
-          </a:bodyPr>
-          <a:lstStyle/>
+          <a:p>
+            <a:r>
+              <a:t>Questions and Answers</a:t>
+            </a:r>
+          </a:p>
           <a:p>
             <a:pPr algn="ctr">
-              <a:defRPr sz="3200"/>
-            </a:pPr>
-            <a:r>
-              <a:t>Questions and Answers</a:t>
-            </a:r>
-          </a:p>
-        </p:txBody>
-      </p:sp>
-      <p:sp>
-        <p:nvSpPr>
-          <p:cNvPr id="5" name="TextBox 4"/>
-          <p:cNvSpPr txBox="1"/>
-          <p:nvPr/>
-        </p:nvSpPr>
-        <p:spPr>
-          <a:xfrm>
-            <a:off x="457200" y="5029200"/>
-            <a:ext cx="8229600" cy="914400"/>
-          </a:xfrm>
-          <a:prstGeom prst="rect">
-            <a:avLst/>
-          </a:prstGeom>
-          <a:noFill/>
-        </p:spPr>
-        <p:txBody>
-          <a:bodyPr wrap="none">
-            <a:spAutoFit/>
-          </a:bodyPr>
-          <a:lstStyle/>
-          <a:p>
-            <a:pPr algn="ctr">
-              <a:defRPr sz="1600"/>
-            </a:pPr>
-            <a:r>
-              <a:t>Gonzaga Dental Clinic Management Automation System (GDCMAS)</a:t>
-            </a:r>
-          </a:p>
-          <a:p>
-            <a:r>
-              <a:t>PHINMA University of Iloilo - College of Information Technology Education</a:t>
+              <a:defRPr sz="1600">
+                <a:solidFill>
+                  <a:srgbClr val="4A7A5C"/>
+                </a:solidFill>
+              </a:defRPr>
+            </a:pPr>
+            <a:r>
+              <a:t>GDCMAS | PHINMA University of Iloilo - CITE</a:t>
             </a:r>
           </a:p>
         </p:txBody>
@@ -3473,7 +3537,7 @@
         <p:spPr>
           <a:xfrm>
             <a:off x="0" y="0"/>
-            <a:ext cx="9144000" cy="731520"/>
+            <a:ext cx="9144000" cy="822960"/>
           </a:xfrm>
           <a:prstGeom prst="rect">
             <a:avLst/>
@@ -3515,8 +3579,8 @@
         </p:nvSpPr>
         <p:spPr>
           <a:xfrm>
-            <a:off x="457200" y="91440"/>
-            <a:ext cx="8229600" cy="548640"/>
+            <a:off x="457200" y="137160"/>
+            <a:ext cx="8229600" cy="640080"/>
           </a:xfrm>
           <a:prstGeom prst="rect">
             <a:avLst/>
@@ -3537,7 +3601,7 @@
               </a:defRPr>
             </a:pPr>
             <a:r>
-              <a:t>BUSINESS PROBLEM</a:t>
+              <a:t>OUTLINE</a:t>
             </a:r>
           </a:p>
         </p:txBody>
@@ -3550,8 +3614,8 @@
         </p:nvSpPr>
         <p:spPr>
           <a:xfrm>
-            <a:off x="457200" y="1097280"/>
-            <a:ext cx="8229600" cy="4572000"/>
+            <a:off x="731520" y="1188720"/>
+            <a:ext cx="7680960" cy="4572000"/>
           </a:xfrm>
           <a:prstGeom prst="rect">
             <a:avLst/>
@@ -3565,71 +3629,79 @@
           <a:lstStyle/>
           <a:p>
             <a:r>
-              <a:t>Gonzaga Dental Clinic currently uses a paper-based system:</a:t>
+              <a:t>1. Business Problem</a:t>
             </a:r>
           </a:p>
           <a:p>
             <a:pPr lvl="1">
-              <a:defRPr sz="2000"/>
-            </a:pPr>
-            <a:r>
-              <a:t>• Patient records stored in physical envelopes, binders, and cabinets</a:t>
+              <a:defRPr sz="2400"/>
+            </a:pPr>
+            <a:r>
+              <a:t>2. Current Process (As-Is)</a:t>
             </a:r>
           </a:p>
           <a:p>
             <a:pPr lvl="1">
-              <a:defRPr sz="2000"/>
-            </a:pPr>
-            <a:r>
-              <a:t>• Appointment information maintained in a logbook</a:t>
+              <a:defRPr sz="2400"/>
+            </a:pPr>
+            <a:r>
+              <a:t>3. Problems Identified</a:t>
             </a:r>
           </a:p>
           <a:p>
             <a:pPr lvl="1">
-              <a:defRPr sz="2000"/>
-            </a:pPr>
-            <a:r>
-              <a:t>• Treatment updates recorded on index cards</a:t>
+              <a:defRPr sz="2400"/>
+            </a:pPr>
+            <a:r>
+              <a:t>4. Proposed Solution (GDCMAS)</a:t>
             </a:r>
           </a:p>
           <a:p>
             <a:pPr lvl="1">
-              <a:defRPr sz="2000"/>
-            </a:pPr>
-            <a:r>
-              <a:t>• Records not accessible between branches (Main Branch &amp; Second Branch)</a:t>
+              <a:defRPr sz="2400"/>
+            </a:pPr>
+            <a:r>
+              <a:t>5. Future-State Process (To-Be)</a:t>
             </a:r>
           </a:p>
           <a:p>
             <a:pPr lvl="1">
-              <a:defRPr sz="2000"/>
-            </a:pPr>
-            <a:r>
-              <a:t>• No backup system for physical records</a:t>
+              <a:defRPr sz="2400"/>
+            </a:pPr>
+            <a:r>
+              <a:t>6. System Features &amp; Benefits</a:t>
             </a:r>
           </a:p>
           <a:p>
             <a:pPr lvl="1">
-              <a:defRPr sz="2000"/>
-            </a:pPr>
-            <a:r>
-              <a:t>• Risk of duplicate patient records</a:t>
+              <a:defRPr sz="2400"/>
+            </a:pPr>
+            <a:r>
+              <a:t>7. Technology Stack &amp; Security</a:t>
             </a:r>
           </a:p>
           <a:p>
             <a:pPr lvl="1">
-              <a:defRPr sz="2000"/>
-            </a:pPr>
-            <a:r>
-              <a:t>• Difficulty in checking schedule availability</a:t>
+              <a:defRPr sz="2400"/>
+            </a:pPr>
+            <a:r>
+              <a:t>8. System Modules</a:t>
             </a:r>
           </a:p>
           <a:p>
             <a:pPr lvl="1">
-              <a:defRPr sz="2000"/>
-            </a:pPr>
-            <a:r>
-              <a:t>• Reliance on sharing photos/messages between branches</a:t>
+              <a:defRPr sz="2400"/>
+            </a:pPr>
+            <a:r>
+              <a:t>9. Conclusion</a:t>
+            </a:r>
+          </a:p>
+          <a:p>
+            <a:pPr lvl="1">
+              <a:defRPr sz="2400"/>
+            </a:pPr>
+            <a:r>
+              <a:t>10. Q &amp; A</a:t>
             </a:r>
           </a:p>
         </p:txBody>
@@ -3661,7 +3733,7 @@
         <p:spPr>
           <a:xfrm>
             <a:off x="0" y="0"/>
-            <a:ext cx="9144000" cy="731520"/>
+            <a:ext cx="9144000" cy="822960"/>
           </a:xfrm>
           <a:prstGeom prst="rect">
             <a:avLst/>
@@ -3703,8 +3775,8 @@
         </p:nvSpPr>
         <p:spPr>
           <a:xfrm>
-            <a:off x="457200" y="91440"/>
-            <a:ext cx="8229600" cy="548640"/>
+            <a:off x="457200" y="137160"/>
+            <a:ext cx="8229600" cy="640080"/>
           </a:xfrm>
           <a:prstGeom prst="rect">
             <a:avLst/>
@@ -3725,7 +3797,7 @@
               </a:defRPr>
             </a:pPr>
             <a:r>
-              <a:t>CURRENT PROCESS (AS-IS)</a:t>
+              <a:t>BUSINESS PROBLEM</a:t>
             </a:r>
           </a:p>
         </p:txBody>
@@ -3738,8 +3810,8 @@
         </p:nvSpPr>
         <p:spPr>
           <a:xfrm>
-            <a:off x="457200" y="1097280"/>
-            <a:ext cx="8229600" cy="4572000"/>
+            <a:off x="548640" y="1188720"/>
+            <a:ext cx="8046720" cy="4572000"/>
           </a:xfrm>
           <a:prstGeom prst="rect">
             <a:avLst/>
@@ -3753,47 +3825,55 @@
           <a:lstStyle/>
           <a:p>
             <a:r>
-              <a:t>1. Patient Registration - Fill out paper intake forms and consent documents</a:t>
+              <a:t>Gonzaga Dental Clinic currently uses a paper-based system:</a:t>
             </a:r>
           </a:p>
           <a:p>
             <a:pPr lvl="1">
-              <a:defRPr sz="2200"/>
-            </a:pPr>
-            <a:r>
-              <a:t>2. Record Storage - Documents placed in labeled envelopes and cabinets</a:t>
+              <a:defRPr sz="1900"/>
+            </a:pPr>
+            <a:r>
+              <a:t>• Patient records stored in physical envelopes, binders, and cabinets</a:t>
             </a:r>
           </a:p>
           <a:p>
             <a:pPr lvl="1">
-              <a:defRPr sz="2200"/>
-            </a:pPr>
-            <a:r>
-              <a:t>3. Consultation - Dentist reviews patient history from physical files</a:t>
+              <a:defRPr sz="1900"/>
+            </a:pPr>
+            <a:r>
+              <a:t>• Appointment information maintained in a logbook</a:t>
             </a:r>
           </a:p>
           <a:p>
             <a:pPr lvl="1">
-              <a:defRPr sz="2200"/>
-            </a:pPr>
-            <a:r>
-              <a:t>4. Treatment Recording - Updates written on index cards</a:t>
+              <a:defRPr sz="1900"/>
+            </a:pPr>
+            <a:r>
+              <a:t>• Treatment updates recorded on index cards</a:t>
             </a:r>
           </a:p>
           <a:p>
             <a:pPr lvl="1">
-              <a:defRPr sz="2200"/>
-            </a:pPr>
-            <a:r>
-              <a:t>5. Appointment Booking - Recorded manually in a logbook</a:t>
+              <a:defRPr sz="1900"/>
+            </a:pPr>
+            <a:r>
+              <a:t>• Records are NOT accessible between branches (Main &amp; Second Branch)</a:t>
             </a:r>
           </a:p>
           <a:p>
             <a:pPr lvl="1">
-              <a:defRPr sz="2200"/>
-            </a:pPr>
-            <a:r>
-              <a:t>6. Inter-Branch Coordination - Through text messages or sharing photos</a:t>
+              <a:defRPr sz="1900"/>
+            </a:pPr>
+            <a:r>
+              <a:t>• No backup system for physical records</a:t>
+            </a:r>
+          </a:p>
+          <a:p>
+            <a:pPr lvl="1">
+              <a:defRPr sz="1900"/>
+            </a:pPr>
+            <a:r>
+              <a:t>• Risk of duplicate patient records</a:t>
             </a:r>
           </a:p>
         </p:txBody>
@@ -3825,7 +3905,7 @@
         <p:spPr>
           <a:xfrm>
             <a:off x="0" y="0"/>
-            <a:ext cx="9144000" cy="731520"/>
+            <a:ext cx="9144000" cy="822960"/>
           </a:xfrm>
           <a:prstGeom prst="rect">
             <a:avLst/>
@@ -3867,8 +3947,8 @@
         </p:nvSpPr>
         <p:spPr>
           <a:xfrm>
-            <a:off x="457200" y="91440"/>
-            <a:ext cx="8229600" cy="548640"/>
+            <a:off x="457200" y="137160"/>
+            <a:ext cx="8229600" cy="640080"/>
           </a:xfrm>
           <a:prstGeom prst="rect">
             <a:avLst/>
@@ -3889,7 +3969,7 @@
               </a:defRPr>
             </a:pPr>
             <a:r>
-              <a:t>PROBLEMS IDENTIFIED</a:t>
+              <a:t>CURRENT PROCESS (AS-IS)</a:t>
             </a:r>
           </a:p>
         </p:txBody>
@@ -3902,8 +3982,8 @@
         </p:nvSpPr>
         <p:spPr>
           <a:xfrm>
-            <a:off x="457200" y="1097280"/>
-            <a:ext cx="8229600" cy="4572000"/>
+            <a:off x="548640" y="1188720"/>
+            <a:ext cx="8046720" cy="4572000"/>
           </a:xfrm>
           <a:prstGeom prst="rect">
             <a:avLst/>
@@ -3917,63 +3997,47 @@
           <a:lstStyle/>
           <a:p>
             <a:r>
-              <a:t>• Fragmented Records - Scattered across physical storage</a:t>
+              <a:t>1. Patient Registration – Fill out paper intake forms and consent documents</a:t>
             </a:r>
           </a:p>
           <a:p>
             <a:pPr lvl="1">
-              <a:defRPr sz="2000"/>
-            </a:pPr>
-            <a:r>
-              <a:t>• Limited Accessibility - Cannot access records instantly between branches</a:t>
+              <a:defRPr sz="1900"/>
+            </a:pPr>
+            <a:r>
+              <a:t>2. Record Storage – Documents placed in labeled envelopes in cabinets</a:t>
             </a:r>
           </a:p>
           <a:p>
             <a:pPr lvl="1">
-              <a:defRPr sz="2000"/>
-            </a:pPr>
-            <a:r>
-              <a:t>• Manual Tracking - Time-consuming search for patient records</a:t>
+              <a:defRPr sz="1900"/>
+            </a:pPr>
+            <a:r>
+              <a:t>3. Consultation – Dentist reviews patient history from physical files</a:t>
             </a:r>
           </a:p>
           <a:p>
             <a:pPr lvl="1">
-              <a:defRPr sz="2000"/>
-            </a:pPr>
-            <a:r>
-              <a:t>• Scheduling Conflicts - Risk of double-booking due to manual logbook</a:t>
+              <a:defRPr sz="1900"/>
+            </a:pPr>
+            <a:r>
+              <a:t>4. Treatment Recording – Updates written manually on index cards</a:t>
             </a:r>
           </a:p>
           <a:p>
             <a:pPr lvl="1">
-              <a:defRPr sz="2000"/>
-            </a:pPr>
-            <a:r>
-              <a:t>• No Data Backup - Records vulnerable to loss or damage</a:t>
+              <a:defRPr sz="1900"/>
+            </a:pPr>
+            <a:r>
+              <a:t>5. Appointment Booking – Recorded manually in a logbook</a:t>
             </a:r>
           </a:p>
           <a:p>
             <a:pPr lvl="1">
-              <a:defRPr sz="2000"/>
-            </a:pPr>
-            <a:r>
-              <a:t>• Duplicate Records - Created when existing files cannot be located</a:t>
-            </a:r>
-          </a:p>
-          <a:p>
-            <a:pPr lvl="1">
-              <a:defRPr sz="2000"/>
-            </a:pPr>
-            <a:r>
-              <a:t>• Lack of Accountability - No audit trail of system activities</a:t>
-            </a:r>
-          </a:p>
-          <a:p>
-            <a:pPr lvl="1">
-              <a:defRPr sz="2000"/>
-            </a:pPr>
-            <a:r>
-              <a:t>• Inefficient Coordination - Delays in inter-branch record sharing</a:t>
+              <a:defRPr sz="1900"/>
+            </a:pPr>
+            <a:r>
+              <a:t>6. Inter-Branch Coordination – Done through texts or sharing photos of records</a:t>
             </a:r>
           </a:p>
         </p:txBody>
@@ -4005,7 +4069,7 @@
         <p:spPr>
           <a:xfrm>
             <a:off x="0" y="0"/>
-            <a:ext cx="9144000" cy="731520"/>
+            <a:ext cx="9144000" cy="822960"/>
           </a:xfrm>
           <a:prstGeom prst="rect">
             <a:avLst/>
@@ -4047,8 +4111,8 @@
         </p:nvSpPr>
         <p:spPr>
           <a:xfrm>
-            <a:off x="457200" y="91440"/>
-            <a:ext cx="8229600" cy="548640"/>
+            <a:off x="457200" y="137160"/>
+            <a:ext cx="8229600" cy="640080"/>
           </a:xfrm>
           <a:prstGeom prst="rect">
             <a:avLst/>
@@ -4069,7 +4133,7 @@
               </a:defRPr>
             </a:pPr>
             <a:r>
-              <a:t>PROPOSED SOLUTION</a:t>
+              <a:t>PROBLEMS IDENTIFIED</a:t>
             </a:r>
           </a:p>
         </p:txBody>
@@ -4082,8 +4146,8 @@
         </p:nvSpPr>
         <p:spPr>
           <a:xfrm>
-            <a:off x="457200" y="914400"/>
-            <a:ext cx="8229600" cy="914400"/>
+            <a:off x="548640" y="1188720"/>
+            <a:ext cx="8046720" cy="4572000"/>
           </a:xfrm>
           <a:prstGeom prst="rect">
             <a:avLst/>
@@ -4096,75 +4160,64 @@
           </a:bodyPr>
           <a:lstStyle/>
           <a:p>
-            <a:pPr>
-              <a:defRPr sz="2400" b="1">
-                <a:solidFill>
-                  <a:srgbClr val="1E3A8A"/>
-                </a:solidFill>
-              </a:defRPr>
-            </a:pPr>
-            <a:r>
-              <a:t>GDCMAS - Gonzaga Dental Clinic Management Automation System</a:t>
-            </a:r>
-          </a:p>
-        </p:txBody>
-      </p:sp>
-      <p:sp>
-        <p:nvSpPr>
-          <p:cNvPr id="5" name="TextBox 4"/>
-          <p:cNvSpPr txBox="1"/>
-          <p:nvPr/>
-        </p:nvSpPr>
-        <p:spPr>
-          <a:xfrm>
-            <a:off x="457200" y="2011680"/>
-            <a:ext cx="8229600" cy="3657600"/>
-          </a:xfrm>
-          <a:prstGeom prst="rect">
-            <a:avLst/>
-          </a:prstGeom>
-          <a:noFill/>
-        </p:spPr>
-        <p:txBody>
-          <a:bodyPr wrap="none">
-            <a:spAutoFit/>
-          </a:bodyPr>
-          <a:lstStyle/>
-          <a:p>
-            <a:r>
-              <a:t>A centralized, web-based system that digitizes:</a:t>
+            <a:r>
+              <a:t>• Fragmented Records – Scattered across physical storage</a:t>
             </a:r>
           </a:p>
           <a:p>
             <a:pPr lvl="1">
-              <a:defRPr sz="1800"/>
-            </a:pPr>
-            <a:r>
-              <a:t>• Patient Records Management | • Treatment History with FDI Tooth Chart</a:t>
+              <a:defRPr sz="1900"/>
+            </a:pPr>
+            <a:r>
+              <a:t>• Limited Accessibility – No instant access between branches</a:t>
             </a:r>
           </a:p>
           <a:p>
             <a:pPr lvl="1">
-              <a:defRPr sz="1800"/>
-            </a:pPr>
-            <a:r>
-              <a:t>• Appointment Scheduling &amp; Calendar Management | • Digital Consent Forms</a:t>
+              <a:defRPr sz="1900"/>
+            </a:pPr>
+            <a:r>
+              <a:t>• Manual Tracking – Time-consuming search for patient records</a:t>
             </a:r>
           </a:p>
           <a:p>
             <a:pPr lvl="1">
-              <a:defRPr sz="1800"/>
-            </a:pPr>
-            <a:r>
-              <a:t>• Inter-Branch Access | • Role-Based Access Control</a:t>
+              <a:defRPr sz="1900"/>
+            </a:pPr>
+            <a:r>
+              <a:t>• Scheduling Conflicts – Risk of double-booking</a:t>
             </a:r>
           </a:p>
           <a:p>
             <a:pPr lvl="1">
-              <a:defRPr sz="1800"/>
-            </a:pPr>
-            <a:r>
-              <a:t>• Public Patient Booking Portal | • Audit Logging &amp; Security</a:t>
+              <a:defRPr sz="1900"/>
+            </a:pPr>
+            <a:r>
+              <a:t>• No Data Backup – Vulnerable to loss or damage</a:t>
+            </a:r>
+          </a:p>
+          <a:p>
+            <a:pPr lvl="1">
+              <a:defRPr sz="1900"/>
+            </a:pPr>
+            <a:r>
+              <a:t>• Duplicate Records – Fragmentation of patient history</a:t>
+            </a:r>
+          </a:p>
+          <a:p>
+            <a:pPr lvl="1">
+              <a:defRPr sz="1900"/>
+            </a:pPr>
+            <a:r>
+              <a:t>• Lack of Accountability – No audit trail</a:t>
+            </a:r>
+          </a:p>
+          <a:p>
+            <a:pPr lvl="1">
+              <a:defRPr sz="1900"/>
+            </a:pPr>
+            <a:r>
+              <a:t>• Inefficient Coordination – Delays between branches</a:t>
             </a:r>
           </a:p>
         </p:txBody>
@@ -4196,7 +4249,7 @@
         <p:spPr>
           <a:xfrm>
             <a:off x="0" y="0"/>
-            <a:ext cx="9144000" cy="731520"/>
+            <a:ext cx="9144000" cy="822960"/>
           </a:xfrm>
           <a:prstGeom prst="rect">
             <a:avLst/>
@@ -4238,8 +4291,8 @@
         </p:nvSpPr>
         <p:spPr>
           <a:xfrm>
-            <a:off x="457200" y="91440"/>
-            <a:ext cx="8229600" cy="548640"/>
+            <a:off x="457200" y="137160"/>
+            <a:ext cx="8229600" cy="640080"/>
           </a:xfrm>
           <a:prstGeom prst="rect">
             <a:avLst/>
@@ -4253,14 +4306,14 @@
           <a:lstStyle/>
           <a:p>
             <a:pPr>
-              <a:defRPr sz="2800" b="1">
+              <a:defRPr sz="3200" b="1">
                 <a:solidFill>
                   <a:srgbClr val="FFFFFF"/>
                 </a:solidFill>
               </a:defRPr>
             </a:pPr>
             <a:r>
-              <a:t>FUTURE-STATE PROCESS (TO-BE)</a:t>
+              <a:t>PROPOSED SOLUTION</a:t>
             </a:r>
           </a:p>
         </p:txBody>
@@ -4273,8 +4326,8 @@
         </p:nvSpPr>
         <p:spPr>
           <a:xfrm>
-            <a:off x="457200" y="1097280"/>
-            <a:ext cx="8229600" cy="4572000"/>
+            <a:off x="548640" y="1005840"/>
+            <a:ext cx="8046720" cy="731520"/>
           </a:xfrm>
           <a:prstGeom prst="rect">
             <a:avLst/>
@@ -4287,60 +4340,56 @@
           </a:bodyPr>
           <a:lstStyle/>
           <a:p>
-            <a:r>
-              <a:t>1. Patient Registration/Retrieval → Search or register in centralized system</a:t>
-            </a:r>
-          </a:p>
-          <a:p>
-            <a:pPr lvl="1">
-              <a:defRPr sz="1800"/>
-            </a:pPr>
-            <a:r>
-              <a:t>2. Appointment Booking → Schedule with automatic availability checking</a:t>
-            </a:r>
-          </a:p>
-          <a:p>
-            <a:pPr lvl="1">
-              <a:defRPr sz="1800"/>
-            </a:pPr>
-            <a:r>
-              <a:t>3. Consultation &amp; Treatment → Access digital records, update via digital tooth chart</a:t>
-            </a:r>
-          </a:p>
-          <a:p>
-            <a:pPr lvl="1">
-              <a:defRPr sz="1800"/>
-            </a:pPr>
-            <a:r>
-              <a:t>4. Record Management → All data automatically stored and synced across branches</a:t>
-            </a:r>
-          </a:p>
-          <a:p>
-            <a:pPr lvl="1">
-              <a:defRPr sz="1800"/>
-            </a:pPr>
-            <a:r>
-              <a:t>5. Consent Documentation → Digital consent captured with audit trail</a:t>
-            </a:r>
-          </a:p>
-          <a:p>
-            <a:pPr lvl="1">
-              <a:defRPr sz="1800"/>
-            </a:pPr>
-            <a:r>
-              <a:t>6. Reporting &amp; Monitoring → Real-time overview of appointments and operations</a:t>
-            </a:r>
-          </a:p>
-          <a:p>
-            <a:pPr lvl="1">
-              <a:defRPr sz="2000" b="1">
+            <a:pPr algn="ctr">
+              <a:defRPr sz="2200" b="1">
                 <a:solidFill>
-                  <a:srgbClr val="4A7A5C"/>
+                  <a:srgbClr val="1E3A8A"/>
                 </a:solidFill>
               </a:defRPr>
             </a:pPr>
             <a:r>
-              <a:t>Key Improvement: Standardized, automated, and centralized process with full traceability</a:t>
+              <a:t>GDCMAS - Gonzaga Dental Clinic Management Automation System</a:t>
+            </a:r>
+          </a:p>
+        </p:txBody>
+      </p:sp>
+      <p:sp>
+        <p:nvSpPr>
+          <p:cNvPr id="5" name="TextBox 4"/>
+          <p:cNvSpPr txBox="1"/>
+          <p:nvPr/>
+        </p:nvSpPr>
+        <p:spPr>
+          <a:xfrm>
+            <a:off x="548640" y="1828800"/>
+            <a:ext cx="8046720" cy="3657600"/>
+          </a:xfrm>
+          <a:prstGeom prst="rect">
+            <a:avLst/>
+          </a:prstGeom>
+          <a:noFill/>
+        </p:spPr>
+        <p:txBody>
+          <a:bodyPr wrap="none">
+            <a:spAutoFit/>
+          </a:bodyPr>
+          <a:lstStyle/>
+          <a:p>
+            <a:r>
+              <a:t>A centralized, web-based system that automates and digitizes all clinic operations to replace the paper-based workflow with a secure, efficient digital solution.</a:t>
+            </a:r>
+          </a:p>
+          <a:p>
+            <a:pPr>
+              <a:defRPr sz="1800"/>
+            </a:pPr>
+          </a:p>
+          <a:p>
+            <a:pPr>
+              <a:defRPr sz="1800" b="1"/>
+            </a:pPr>
+            <a:r>
+              <a:t>Goal: Provide a unified platform for patient records, treatment history, appointments, and clinic management accessible across both branches.</a:t>
             </a:r>
           </a:p>
         </p:txBody>
@@ -4372,7 +4421,7 @@
         <p:spPr>
           <a:xfrm>
             <a:off x="0" y="0"/>
-            <a:ext cx="9144000" cy="731520"/>
+            <a:ext cx="9144000" cy="822960"/>
           </a:xfrm>
           <a:prstGeom prst="rect">
             <a:avLst/>
@@ -4414,8 +4463,8 @@
         </p:nvSpPr>
         <p:spPr>
           <a:xfrm>
-            <a:off x="457200" y="91440"/>
-            <a:ext cx="8229600" cy="548640"/>
+            <a:off x="457200" y="137160"/>
+            <a:ext cx="8229600" cy="640080"/>
           </a:xfrm>
           <a:prstGeom prst="rect">
             <a:avLst/>
@@ -4436,7 +4485,7 @@
               </a:defRPr>
             </a:pPr>
             <a:r>
-              <a:t>BUSINESS BENEFITS</a:t>
+              <a:t>CORE FEATURES</a:t>
             </a:r>
           </a:p>
         </p:txBody>
@@ -4449,8 +4498,8 @@
         </p:nvSpPr>
         <p:spPr>
           <a:xfrm>
-            <a:off x="457200" y="1097280"/>
-            <a:ext cx="4114800" cy="4572000"/>
+            <a:off x="548640" y="1188720"/>
+            <a:ext cx="8046720" cy="4572000"/>
           </a:xfrm>
           <a:prstGeom prst="rect">
             <a:avLst/>
@@ -4464,83 +4513,63 @@
           <a:lstStyle/>
           <a:p>
             <a:r>
-              <a:t>• Centralization</a:t>
+              <a:t>• Patient Management - Registration, search, duplicate detection</a:t>
             </a:r>
           </a:p>
           <a:p>
             <a:pPr lvl="1">
-              <a:defRPr sz="2200"/>
-            </a:pPr>
-            <a:r>
-              <a:t>• Accessibility</a:t>
+              <a:defRPr sz="1900"/>
+            </a:pPr>
+            <a:r>
+              <a:t>• Treatment Records - FDI Tooth Chart &amp; procedure tracking</a:t>
             </a:r>
           </a:p>
           <a:p>
             <a:pPr lvl="1">
-              <a:defRPr sz="2200"/>
-            </a:pPr>
-            <a:r>
-              <a:t>• Efficiency</a:t>
+              <a:defRPr sz="1900"/>
+            </a:pPr>
+            <a:r>
+              <a:t>• Appointment Scheduling - Per-branch calendar with slot generation</a:t>
             </a:r>
           </a:p>
           <a:p>
             <a:pPr lvl="1">
-              <a:defRPr sz="2200"/>
-            </a:pPr>
-            <a:r>
-              <a:t>• Accountability</a:t>
-            </a:r>
-          </a:p>
-        </p:txBody>
-      </p:sp>
-      <p:sp>
-        <p:nvSpPr>
-          <p:cNvPr id="5" name="TextBox 4"/>
-          <p:cNvSpPr txBox="1"/>
-          <p:nvPr/>
-        </p:nvSpPr>
-        <p:spPr>
-          <a:xfrm>
-            <a:off x="4572000" y="1097280"/>
-            <a:ext cx="4114800" cy="4572000"/>
-          </a:xfrm>
-          <a:prstGeom prst="rect">
-            <a:avLst/>
-          </a:prstGeom>
-          <a:noFill/>
-        </p:spPr>
-        <p:txBody>
-          <a:bodyPr wrap="none">
-            <a:spAutoFit/>
-          </a:bodyPr>
-          <a:lstStyle/>
-          <a:p>
-            <a:r>
-              <a:t>• Data Security</a:t>
+              <a:defRPr sz="1900"/>
+            </a:pPr>
+            <a:r>
+              <a:t>• Consent Management - Digital versioned consent forms</a:t>
             </a:r>
           </a:p>
           <a:p>
             <a:pPr lvl="1">
-              <a:defRPr sz="2200"/>
-            </a:pPr>
-            <a:r>
-              <a:t>• Accuracy</a:t>
+              <a:defRPr sz="1900"/>
+            </a:pPr>
+            <a:r>
+              <a:t>• Public Booking Portal - Online appointment requests</a:t>
             </a:r>
           </a:p>
           <a:p>
             <a:pPr lvl="1">
-              <a:defRPr sz="2200"/>
-            </a:pPr>
-            <a:r>
-              <a:t>• Convenience</a:t>
+              <a:defRPr sz="1900"/>
+            </a:pPr>
+            <a:r>
+              <a:t>• Staff Management - Role-based user administration</a:t>
             </a:r>
           </a:p>
           <a:p>
             <a:pPr lvl="1">
-              <a:defRPr sz="2200"/>
-            </a:pPr>
-            <a:r>
-              <a:t>• Data Integrity</a:t>
+              <a:defRPr sz="1900"/>
+            </a:pPr>
+            <a:r>
+              <a:t>• Branch Overview - Real-time clinic statistics</a:t>
+            </a:r>
+          </a:p>
+          <a:p>
+            <a:pPr lvl="1">
+              <a:defRPr sz="1900"/>
+            </a:pPr>
+            <a:r>
+              <a:t>• Audit &amp; Governance - Complete activity logging</a:t>
             </a:r>
           </a:p>
         </p:txBody>
@@ -4572,7 +4601,7 @@
         <p:spPr>
           <a:xfrm>
             <a:off x="0" y="0"/>
-            <a:ext cx="9144000" cy="731520"/>
+            <a:ext cx="9144000" cy="822960"/>
           </a:xfrm>
           <a:prstGeom prst="rect">
             <a:avLst/>
@@ -4614,8 +4643,8 @@
         </p:nvSpPr>
         <p:spPr>
           <a:xfrm>
-            <a:off x="457200" y="91440"/>
-            <a:ext cx="8229600" cy="548640"/>
+            <a:off x="457200" y="137160"/>
+            <a:ext cx="8229600" cy="640080"/>
           </a:xfrm>
           <a:prstGeom prst="rect">
             <a:avLst/>
@@ -4636,7 +4665,7 @@
               </a:defRPr>
             </a:pPr>
             <a:r>
-              <a:t>TECHNOLOGY STACK &amp; SECURITY</a:t>
+              <a:t>FUTURE-STATE PROCESS (TO-BE)</a:t>
             </a:r>
           </a:p>
         </p:txBody>
@@ -4649,8 +4678,8 @@
         </p:nvSpPr>
         <p:spPr>
           <a:xfrm>
-            <a:off x="457200" y="914400"/>
-            <a:ext cx="8229600" cy="1828800"/>
+            <a:off x="548640" y="1188720"/>
+            <a:ext cx="8046720" cy="4572000"/>
           </a:xfrm>
           <a:prstGeom prst="rect">
             <a:avLst/>
@@ -4664,95 +4693,47 @@
           <a:lstStyle/>
           <a:p>
             <a:r>
-              <a:t>Technology Stack:</a:t>
-            </a:r>
-          </a:p>
-          <a:p>
-            <a:pPr lvl="2">
+              <a:t>1. Patient Registration/Retrieval → Centralized digital search &amp; registration</a:t>
+            </a:r>
+          </a:p>
+          <a:p>
+            <a:pPr lvl="1">
               <a:defRPr sz="1800"/>
             </a:pPr>
             <a:r>
-              <a:t>• Frontend: Next.js 16, React 19, TypeScript, Tailwind CSS 4</a:t>
-            </a:r>
-          </a:p>
-          <a:p>
-            <a:pPr lvl="2">
+              <a:t>2. Appointment Booking → System-based with real-time availability</a:t>
+            </a:r>
+          </a:p>
+          <a:p>
+            <a:pPr lvl="1">
               <a:defRPr sz="1800"/>
             </a:pPr>
             <a:r>
-              <a:t>• Backend/Database: Supabase (PostgreSQL, Auth, Row Level Security)</a:t>
-            </a:r>
-          </a:p>
-          <a:p>
-            <a:pPr lvl="2">
+              <a:t>3. Consultation &amp; Treatment → Digital records with FDI tooth chart</a:t>
+            </a:r>
+          </a:p>
+          <a:p>
+            <a:pPr lvl="1">
               <a:defRPr sz="1800"/>
             </a:pPr>
             <a:r>
-              <a:t>• Validation: Zod</a:t>
-            </a:r>
-          </a:p>
-        </p:txBody>
-      </p:sp>
-      <p:sp>
-        <p:nvSpPr>
-          <p:cNvPr id="5" name="TextBox 4"/>
-          <p:cNvSpPr txBox="1"/>
-          <p:nvPr/>
-        </p:nvSpPr>
-        <p:spPr>
-          <a:xfrm>
-            <a:off x="457200" y="2926080"/>
-            <a:ext cx="8229600" cy="2743200"/>
-          </a:xfrm>
-          <a:prstGeom prst="rect">
-            <a:avLst/>
-          </a:prstGeom>
-          <a:noFill/>
-        </p:spPr>
-        <p:txBody>
-          <a:bodyPr wrap="none">
-            <a:spAutoFit/>
-          </a:bodyPr>
-          <a:lstStyle/>
-          <a:p>
-            <a:r>
-              <a:t>3-Layer Security Protection:</a:t>
+              <a:t>4. Consent Documentation → Digital versioned consent with audit trail</a:t>
             </a:r>
           </a:p>
           <a:p>
             <a:pPr lvl="1">
-              <a:defRPr sz="1600"/>
-            </a:pPr>
-            <a:r>
-              <a:t>1. Proxy Layer - Fast redirect for unauthenticated sessions</a:t>
+              <a:defRPr sz="1800"/>
+            </a:pPr>
+            <a:r>
+              <a:t>5. Inter-Branch Access → Seamless access across both branches</a:t>
             </a:r>
           </a:p>
           <a:p>
             <a:pPr lvl="1">
-              <a:defRPr sz="1600"/>
-            </a:pPr>
-            <a:r>
-              <a:t>2. Server Layer - Database-validated sessions &amp; role checking</a:t>
-            </a:r>
-          </a:p>
-          <a:p>
-            <a:pPr lvl="1">
-              <a:defRPr sz="1600"/>
-            </a:pPr>
-            <a:r>
-              <a:t>3. Database Layer (RLS) - Row Level Security as the real boundary</a:t>
-            </a:r>
-          </a:p>
-          <a:p>
-            <a:pPr lvl="1">
-              <a:defRPr sz="1800" b="1">
-                <a:solidFill>
-                  <a:srgbClr val="4A7A5C"/>
-                </a:solidFill>
-              </a:defRPr>
-            </a:pPr>
-            <a:r>
-              <a:t>User Roles: Dentist | Secretary | Administrator</a:t>
+              <a:defRPr sz="1800"/>
+            </a:pPr>
+            <a:r>
+              <a:t>6. Monitoring &amp; Reporting → Real-time dashboards and audit logs</a:t>
             </a:r>
           </a:p>
         </p:txBody>
@@ -4784,7 +4765,7 @@
         <p:spPr>
           <a:xfrm>
             <a:off x="0" y="0"/>
-            <a:ext cx="9144000" cy="731520"/>
+            <a:ext cx="9144000" cy="822960"/>
           </a:xfrm>
           <a:prstGeom prst="rect">
             <a:avLst/>
@@ -4826,8 +4807,8 @@
         </p:nvSpPr>
         <p:spPr>
           <a:xfrm>
-            <a:off x="457200" y="91440"/>
-            <a:ext cx="8229600" cy="548640"/>
+            <a:off x="457200" y="137160"/>
+            <a:ext cx="8229600" cy="640080"/>
           </a:xfrm>
           <a:prstGeom prst="rect">
             <a:avLst/>
@@ -4841,14 +4822,14 @@
           <a:lstStyle/>
           <a:p>
             <a:pPr>
-              <a:defRPr sz="3200" b="1">
+              <a:defRPr sz="2400" b="1">
                 <a:solidFill>
                   <a:srgbClr val="FFFFFF"/>
                 </a:solidFill>
               </a:defRPr>
             </a:pPr>
             <a:r>
-              <a:t>CONCLUSION</a:t>
+              <a:t>TECHNOLOGY STACK, SECURITY &amp; BENEFITS</a:t>
             </a:r>
           </a:p>
         </p:txBody>
@@ -4861,8 +4842,8 @@
         </p:nvSpPr>
         <p:spPr>
           <a:xfrm>
-            <a:off x="457200" y="1097280"/>
-            <a:ext cx="8229600" cy="4572000"/>
+            <a:off x="457200" y="1005840"/>
+            <a:ext cx="4114800" cy="2286000"/>
           </a:xfrm>
           <a:prstGeom prst="rect">
             <a:avLst/>
@@ -4876,59 +4857,139 @@
           <a:lstStyle/>
           <a:p>
             <a:r>
-              <a:t>• The problem is not just absence of software, but lack of a standardized process</a:t>
+              <a:t>TECH STACK:</a:t>
+            </a:r>
+          </a:p>
+          <a:p>
+            <a:pPr lvl="2">
+              <a:defRPr sz="1400"/>
+            </a:pPr>
+            <a:r>
+              <a:t>• Next.js 16 | React 19</a:t>
+            </a:r>
+          </a:p>
+          <a:p>
+            <a:pPr lvl="2">
+              <a:defRPr sz="1400"/>
+            </a:pPr>
+            <a:r>
+              <a:t>• TypeScript | Tailwind CSS 4</a:t>
+            </a:r>
+          </a:p>
+          <a:p>
+            <a:pPr lvl="2">
+              <a:defRPr sz="1400"/>
+            </a:pPr>
+            <a:r>
+              <a:t>• Supabase (Postgres, Auth, RLS)</a:t>
+            </a:r>
+          </a:p>
+          <a:p>
+            <a:pPr lvl="2">
+              <a:defRPr sz="1400"/>
+            </a:pPr>
+            <a:r>
+              <a:t>• Zod Validation</a:t>
+            </a:r>
+          </a:p>
+        </p:txBody>
+      </p:sp>
+      <p:sp>
+        <p:nvSpPr>
+          <p:cNvPr id="5" name="TextBox 4"/>
+          <p:cNvSpPr txBox="1"/>
+          <p:nvPr/>
+        </p:nvSpPr>
+        <p:spPr>
+          <a:xfrm>
+            <a:off x="4572000" y="1005840"/>
+            <a:ext cx="4114800" cy="2286000"/>
+          </a:xfrm>
+          <a:prstGeom prst="rect">
+            <a:avLst/>
+          </a:prstGeom>
+          <a:noFill/>
+        </p:spPr>
+        <p:txBody>
+          <a:bodyPr wrap="none">
+            <a:spAutoFit/>
+          </a:bodyPr>
+          <a:lstStyle/>
+          <a:p>
+            <a:r>
+              <a:t>SECURITY (3-LAYERS):</a:t>
             </a:r>
           </a:p>
           <a:p>
             <a:pPr lvl="1">
-              <a:defRPr sz="1800"/>
-            </a:pPr>
-            <a:r>
-              <a:t>• Business Process Automation: Standardize first, then automate with technology</a:t>
+              <a:defRPr sz="1400"/>
+            </a:pPr>
+            <a:r>
+              <a:t>1. Proxy Layer</a:t>
             </a:r>
           </a:p>
           <a:p>
             <a:pPr lvl="1">
-              <a:defRPr sz="1800"/>
-            </a:pPr>
-            <a:r>
-              <a:t>• GDCMAS addresses all identified issues through centralization and automation</a:t>
+              <a:defRPr sz="1400"/>
+            </a:pPr>
+            <a:r>
+              <a:t>2. Server Validation</a:t>
             </a:r>
           </a:p>
           <a:p>
             <a:pPr lvl="1">
-              <a:defRPr sz="1800"/>
-            </a:pPr>
-            <a:r>
-              <a:t>• Improves efficiency, accessibility, security, accountability, and patient care</a:t>
+              <a:defRPr sz="1400"/>
+            </a:pPr>
+            <a:r>
+              <a:t>3. PostgreSQL RLS</a:t>
             </a:r>
           </a:p>
           <a:p>
             <a:pPr lvl="1">
-              <a:defRPr sz="1800"/>
-            </a:pPr>
-            <a:r>
-              <a:t>• Enables better continuity of care across both branches</a:t>
-            </a:r>
-          </a:p>
-          <a:p>
-            <a:pPr lvl="1">
-              <a:defRPr sz="1800"/>
-            </a:pPr>
-            <a:r>
-              <a:t>• Provides a solid foundation for the clinic's digital transformation</a:t>
-            </a:r>
-          </a:p>
-          <a:p>
-            <a:pPr lvl="1">
-              <a:defRPr sz="1600" i="1">
+              <a:defRPr sz="1400" b="1"/>
+            </a:pPr>
+            <a:r>
+              <a:t>Roles: Dentist | Secretary | Admin</a:t>
+            </a:r>
+          </a:p>
+        </p:txBody>
+      </p:sp>
+      <p:sp>
+        <p:nvSpPr>
+          <p:cNvPr id="6" name="TextBox 5"/>
+          <p:cNvSpPr txBox="1"/>
+          <p:nvPr/>
+        </p:nvSpPr>
+        <p:spPr>
+          <a:xfrm>
+            <a:off x="457200" y="3474720"/>
+            <a:ext cx="8229600" cy="2743200"/>
+          </a:xfrm>
+          <a:prstGeom prst="rect">
+            <a:avLst/>
+          </a:prstGeom>
+          <a:noFill/>
+        </p:spPr>
+        <p:txBody>
+          <a:bodyPr wrap="none">
+            <a:spAutoFit/>
+          </a:bodyPr>
+          <a:lstStyle/>
+          <a:p>
+            <a:r>
+              <a:t>KEY BENEFITS:</a:t>
+            </a:r>
+          </a:p>
+          <a:p>
+            <a:pPr algn="ctr">
+              <a:defRPr sz="1800" b="1">
                 <a:solidFill>
                   <a:srgbClr val="4A7A5C"/>
                 </a:solidFill>
               </a:defRPr>
             </a:pPr>
             <a:r>
-              <a:t>"Business Process Automation allows the organization to standardize the process first and then use technology to support and automate it."</a:t>
+              <a:t>Centralization • Accessibility • Efficiency • Accountability • Security • Accuracy • Convenience</a:t>
             </a:r>
           </a:p>
         </p:txBody>

</xml_diff>

<commit_message>
Add detailed security features to defense presentation
</commit_message>
<xml_diff>
--- a/GDCMAS_Final_Defense_Presentation.pptx
+++ b/GDCMAS_Final_Defense_Presentation.pptx
@@ -13,8 +13,6 @@
     <p:sldId id="261" r:id="rId12"/>
     <p:sldId id="262" r:id="rId13"/>
     <p:sldId id="263" r:id="rId14"/>
-    <p:sldId id="264" r:id="rId15"/>
-    <p:sldId id="265" r:id="rId16"/>
   </p:sldIdLst>
   <p:sldSz cx="9144000" cy="6858000" type="screen4x3"/>
   <p:notesSz cx="6858000" cy="9144000"/>
@@ -3163,9 +3161,6 @@
           <a:lstStyle/>
           <a:p>
             <a:pPr algn="ctr">
-              <a:lnSpc>
-                <a:spcPct val="120000"/>
-              </a:lnSpc>
               <a:defRPr sz="2800" b="1">
                 <a:solidFill>
                   <a:srgbClr val="1E3A8A"/>
@@ -3201,11 +3196,7 @@
           <a:lstStyle/>
           <a:p>
             <a:pPr algn="ctr">
-              <a:defRPr sz="1600">
-                <a:solidFill>
-                  <a:srgbClr val="333333"/>
-                </a:solidFill>
-              </a:defRPr>
+              <a:defRPr sz="1600"/>
             </a:pPr>
             <a:r>
               <a:t>A Business Process Automation Plan for Streamlining Patient Records,</a:t>
@@ -3290,222 +3281,6 @@
             </a:pPr>
             <a:r>
               <a:t>PHINMA University of Iloilo | College of Information Technology Education | October 2026</a:t>
-            </a:r>
-          </a:p>
-        </p:txBody>
-      </p:sp>
-    </p:spTree>
-  </p:cSld>
-  <p:clrMapOvr>
-    <a:masterClrMapping/>
-  </p:clrMapOvr>
-</p:sld>
-</file>
-
-<file path=ppt/slides/slide10.xml><?xml version="1.0" encoding="utf-8"?>
-<p:sld xmlns:a="http://schemas.openxmlformats.org/drawingml/2006/main" xmlns:p="http://schemas.openxmlformats.org/presentationml/2006/main" xmlns:r="http://schemas.openxmlformats.org/officeDocument/2006/relationships">
-  <p:cSld>
-    <p:spTree>
-      <p:nvGrpSpPr>
-        <p:cNvPr id="1" name=""/>
-        <p:cNvGrpSpPr/>
-        <p:nvPr/>
-      </p:nvGrpSpPr>
-      <p:grpSpPr/>
-      <p:sp>
-        <p:nvSpPr>
-          <p:cNvPr id="2" name="Rectangle 1"/>
-          <p:cNvSpPr/>
-          <p:nvPr/>
-        </p:nvSpPr>
-        <p:spPr>
-          <a:xfrm>
-            <a:off x="0" y="0"/>
-            <a:ext cx="9144000" cy="822960"/>
-          </a:xfrm>
-          <a:prstGeom prst="rect">
-            <a:avLst/>
-          </a:prstGeom>
-          <a:solidFill>
-            <a:srgbClr val="4A7A5C"/>
-          </a:solidFill>
-          <a:ln>
-            <a:noFill/>
-          </a:ln>
-        </p:spPr>
-        <p:style>
-          <a:lnRef idx="1">
-            <a:schemeClr val="accent1"/>
-          </a:lnRef>
-          <a:fillRef idx="3">
-            <a:schemeClr val="accent1"/>
-          </a:fillRef>
-          <a:effectRef idx="2">
-            <a:schemeClr val="accent1"/>
-          </a:effectRef>
-          <a:fontRef idx="minor">
-            <a:schemeClr val="lt1"/>
-          </a:fontRef>
-        </p:style>
-        <p:txBody>
-          <a:bodyPr rtlCol="0" anchor="ctr"/>
-          <a:lstStyle/>
-          <a:p>
-            <a:pPr algn="ctr"/>
-          </a:p>
-        </p:txBody>
-      </p:sp>
-      <p:sp>
-        <p:nvSpPr>
-          <p:cNvPr id="3" name="TextBox 2"/>
-          <p:cNvSpPr txBox="1"/>
-          <p:nvPr/>
-        </p:nvSpPr>
-        <p:spPr>
-          <a:xfrm>
-            <a:off x="457200" y="137160"/>
-            <a:ext cx="8229600" cy="640080"/>
-          </a:xfrm>
-          <a:prstGeom prst="rect">
-            <a:avLst/>
-          </a:prstGeom>
-          <a:noFill/>
-        </p:spPr>
-        <p:txBody>
-          <a:bodyPr wrap="none">
-            <a:spAutoFit/>
-          </a:bodyPr>
-          <a:lstStyle/>
-          <a:p>
-            <a:pPr>
-              <a:defRPr sz="3200" b="1">
-                <a:solidFill>
-                  <a:srgbClr val="FFFFFF"/>
-                </a:solidFill>
-              </a:defRPr>
-            </a:pPr>
-            <a:r>
-              <a:t>CONCLUSION</a:t>
-            </a:r>
-          </a:p>
-        </p:txBody>
-      </p:sp>
-      <p:sp>
-        <p:nvSpPr>
-          <p:cNvPr id="4" name="TextBox 3"/>
-          <p:cNvSpPr txBox="1"/>
-          <p:nvPr/>
-        </p:nvSpPr>
-        <p:spPr>
-          <a:xfrm>
-            <a:off x="548640" y="1188720"/>
-            <a:ext cx="8046720" cy="3200400"/>
-          </a:xfrm>
-          <a:prstGeom prst="rect">
-            <a:avLst/>
-          </a:prstGeom>
-          <a:noFill/>
-        </p:spPr>
-        <p:txBody>
-          <a:bodyPr wrap="none">
-            <a:spAutoFit/>
-          </a:bodyPr>
-          <a:lstStyle/>
-          <a:p>
-            <a:r>
-              <a:t>• The problem is the lack of a standardized, centralized process - NOT just software</a:t>
-            </a:r>
-          </a:p>
-          <a:p>
-            <a:pPr lvl="1">
-              <a:defRPr sz="1700"/>
-            </a:pPr>
-            <a:r>
-              <a:t>• GDCMAS standardizes the workflow first, then automates it through technology</a:t>
-            </a:r>
-          </a:p>
-          <a:p>
-            <a:pPr lvl="1">
-              <a:defRPr sz="1700"/>
-            </a:pPr>
-            <a:r>
-              <a:t>• Successfully addresses all identified issues in clinic operations</a:t>
-            </a:r>
-          </a:p>
-          <a:p>
-            <a:pPr lvl="1">
-              <a:defRPr sz="1700"/>
-            </a:pPr>
-            <a:r>
-              <a:t>• Improves efficiency, accessibility, security, accountability &amp; patient care</a:t>
-            </a:r>
-          </a:p>
-          <a:p>
-            <a:pPr lvl="1">
-              <a:defRPr sz="1700"/>
-            </a:pPr>
-            <a:r>
-              <a:t>• Provides a solid foundation for the clinic's digital transformation</a:t>
-            </a:r>
-          </a:p>
-          <a:p>
-            <a:pPr lvl="1">
-              <a:defRPr sz="1700"/>
-            </a:pPr>
-            <a:r>
-              <a:t>• Ready for implementation with proper validation and training</a:t>
-            </a:r>
-          </a:p>
-        </p:txBody>
-      </p:sp>
-      <p:sp>
-        <p:nvSpPr>
-          <p:cNvPr id="5" name="TextBox 4"/>
-          <p:cNvSpPr txBox="1"/>
-          <p:nvPr/>
-        </p:nvSpPr>
-        <p:spPr>
-          <a:xfrm>
-            <a:off x="457200" y="4754880"/>
-            <a:ext cx="8229600" cy="1371600"/>
-          </a:xfrm>
-          <a:prstGeom prst="rect">
-            <a:avLst/>
-          </a:prstGeom>
-          <a:noFill/>
-        </p:spPr>
-        <p:txBody>
-          <a:bodyPr wrap="none">
-            <a:spAutoFit/>
-          </a:bodyPr>
-          <a:lstStyle/>
-          <a:p>
-            <a:pPr algn="ctr">
-              <a:defRPr sz="4000" b="1">
-                <a:solidFill>
-                  <a:srgbClr val="1E3A8A"/>
-                </a:solidFill>
-              </a:defRPr>
-            </a:pPr>
-            <a:r>
-              <a:t>THANK YOU!</a:t>
-            </a:r>
-          </a:p>
-          <a:p>
-            <a:r>
-              <a:t>Questions and Answers</a:t>
-            </a:r>
-          </a:p>
-          <a:p>
-            <a:pPr algn="ctr">
-              <a:defRPr sz="1600">
-                <a:solidFill>
-                  <a:srgbClr val="4A7A5C"/>
-                </a:solidFill>
-              </a:defRPr>
-            </a:pPr>
-            <a:r>
-              <a:t>GDCMAS | PHINMA University of Iloilo - CITE</a:t>
             </a:r>
           </a:p>
         </p:txBody>
@@ -3634,7 +3409,7 @@
           </a:p>
           <a:p>
             <a:pPr lvl="1">
-              <a:defRPr sz="2400"/>
+              <a:defRPr sz="2200"/>
             </a:pPr>
             <a:r>
               <a:t>2. Current Process (As-Is)</a:t>
@@ -3642,7 +3417,7 @@
           </a:p>
           <a:p>
             <a:pPr lvl="1">
-              <a:defRPr sz="2400"/>
+              <a:defRPr sz="2200"/>
             </a:pPr>
             <a:r>
               <a:t>3. Problems Identified</a:t>
@@ -3650,7 +3425,7 @@
           </a:p>
           <a:p>
             <a:pPr lvl="1">
-              <a:defRPr sz="2400"/>
+              <a:defRPr sz="2200"/>
             </a:pPr>
             <a:r>
               <a:t>4. Proposed Solution (GDCMAS)</a:t>
@@ -3658,47 +3433,47 @@
           </a:p>
           <a:p>
             <a:pPr lvl="1">
-              <a:defRPr sz="2400"/>
-            </a:pPr>
-            <a:r>
-              <a:t>5. Future-State Process (To-Be)</a:t>
+              <a:defRPr sz="2200"/>
+            </a:pPr>
+            <a:r>
+              <a:t>5. Core Features</a:t>
             </a:r>
           </a:p>
           <a:p>
             <a:pPr lvl="1">
-              <a:defRPr sz="2400"/>
-            </a:pPr>
-            <a:r>
-              <a:t>6. System Features &amp; Benefits</a:t>
+              <a:defRPr sz="2200"/>
+            </a:pPr>
+            <a:r>
+              <a:t>6. Future-State Process (To-Be)</a:t>
             </a:r>
           </a:p>
           <a:p>
             <a:pPr lvl="1">
-              <a:defRPr sz="2400"/>
-            </a:pPr>
-            <a:r>
-              <a:t>7. Technology Stack &amp; Security</a:t>
+              <a:defRPr sz="2200"/>
+            </a:pPr>
+            <a:r>
+              <a:t>7. Technology Stack</a:t>
             </a:r>
           </a:p>
           <a:p>
             <a:pPr lvl="1">
-              <a:defRPr sz="2400"/>
-            </a:pPr>
-            <a:r>
-              <a:t>8. System Modules</a:t>
+              <a:defRPr sz="2200"/>
+            </a:pPr>
+            <a:r>
+              <a:t>8. Security Features</a:t>
             </a:r>
           </a:p>
           <a:p>
             <a:pPr lvl="1">
-              <a:defRPr sz="2400"/>
-            </a:pPr>
-            <a:r>
-              <a:t>9. Conclusion</a:t>
+              <a:defRPr sz="2200"/>
+            </a:pPr>
+            <a:r>
+              <a:t>9. Benefits &amp; Conclusion</a:t>
             </a:r>
           </a:p>
           <a:p>
             <a:pPr lvl="1">
-              <a:defRPr sz="2400"/>
+              <a:defRPr sz="2200"/>
             </a:pPr>
             <a:r>
               <a:t>10. Q &amp; A</a:t>
@@ -3830,39 +3605,39 @@
           </a:p>
           <a:p>
             <a:pPr lvl="1">
-              <a:defRPr sz="1900"/>
-            </a:pPr>
-            <a:r>
-              <a:t>• Patient records stored in physical envelopes, binders, and cabinets</a:t>
+              <a:defRPr sz="2000"/>
+            </a:pPr>
+            <a:r>
+              <a:t>• Patient records in physical envelopes, binders, and cabinets</a:t>
             </a:r>
           </a:p>
           <a:p>
             <a:pPr lvl="1">
-              <a:defRPr sz="1900"/>
-            </a:pPr>
-            <a:r>
-              <a:t>• Appointment information maintained in a logbook</a:t>
+              <a:defRPr sz="2000"/>
+            </a:pPr>
+            <a:r>
+              <a:t>• Appointments recorded in a logbook</a:t>
             </a:r>
           </a:p>
           <a:p>
             <a:pPr lvl="1">
-              <a:defRPr sz="1900"/>
-            </a:pPr>
-            <a:r>
-              <a:t>• Treatment updates recorded on index cards</a:t>
+              <a:defRPr sz="2000"/>
+            </a:pPr>
+            <a:r>
+              <a:t>• Treatments recorded on index cards</a:t>
             </a:r>
           </a:p>
           <a:p>
             <a:pPr lvl="1">
-              <a:defRPr sz="1900"/>
-            </a:pPr>
-            <a:r>
-              <a:t>• Records are NOT accessible between branches (Main &amp; Second Branch)</a:t>
+              <a:defRPr sz="2000"/>
+            </a:pPr>
+            <a:r>
+              <a:t>• No inter-branch record accessibility</a:t>
             </a:r>
           </a:p>
           <a:p>
             <a:pPr lvl="1">
-              <a:defRPr sz="1900"/>
+              <a:defRPr sz="2000"/>
             </a:pPr>
             <a:r>
               <a:t>• No backup system for physical records</a:t>
@@ -3870,10 +3645,10 @@
           </a:p>
           <a:p>
             <a:pPr lvl="1">
-              <a:defRPr sz="1900"/>
-            </a:pPr>
-            <a:r>
-              <a:t>• Risk of duplicate patient records</a:t>
+              <a:defRPr sz="2000"/>
+            </a:pPr>
+            <a:r>
+              <a:t>• Risk of duplicate records &amp; data loss</a:t>
             </a:r>
           </a:p>
         </p:txBody>
@@ -3969,7 +3744,7 @@
               </a:defRPr>
             </a:pPr>
             <a:r>
-              <a:t>CURRENT PROCESS (AS-IS)</a:t>
+              <a:t>PROBLEMS IDENTIFIED</a:t>
             </a:r>
           </a:p>
         </p:txBody>
@@ -3997,47 +3772,55 @@
           <a:lstStyle/>
           <a:p>
             <a:r>
-              <a:t>1. Patient Registration – Fill out paper intake forms and consent documents</a:t>
+              <a:t>• Fragmented Records &amp; Limited Accessibility</a:t>
             </a:r>
           </a:p>
           <a:p>
             <a:pPr lvl="1">
-              <a:defRPr sz="1900"/>
-            </a:pPr>
-            <a:r>
-              <a:t>2. Record Storage – Documents placed in labeled envelopes in cabinets</a:t>
+              <a:defRPr sz="2000"/>
+            </a:pPr>
+            <a:r>
+              <a:t>• Manual Tracking - Time-consuming searches</a:t>
             </a:r>
           </a:p>
           <a:p>
             <a:pPr lvl="1">
-              <a:defRPr sz="1900"/>
-            </a:pPr>
-            <a:r>
-              <a:t>3. Consultation – Dentist reviews patient history from physical files</a:t>
+              <a:defRPr sz="2000"/>
+            </a:pPr>
+            <a:r>
+              <a:t>• Scheduling Conflicts - Risk of double-booking</a:t>
             </a:r>
           </a:p>
           <a:p>
             <a:pPr lvl="1">
-              <a:defRPr sz="1900"/>
-            </a:pPr>
-            <a:r>
-              <a:t>4. Treatment Recording – Updates written manually on index cards</a:t>
+              <a:defRPr sz="2000"/>
+            </a:pPr>
+            <a:r>
+              <a:t>• No Data Backup - Vulnerable to loss/damage</a:t>
             </a:r>
           </a:p>
           <a:p>
             <a:pPr lvl="1">
-              <a:defRPr sz="1900"/>
-            </a:pPr>
-            <a:r>
-              <a:t>5. Appointment Booking – Recorded manually in a logbook</a:t>
+              <a:defRPr sz="2000"/>
+            </a:pPr>
+            <a:r>
+              <a:t>• Duplicate Records - Fragmented patient history</a:t>
             </a:r>
           </a:p>
           <a:p>
             <a:pPr lvl="1">
-              <a:defRPr sz="1900"/>
-            </a:pPr>
-            <a:r>
-              <a:t>6. Inter-Branch Coordination – Done through texts or sharing photos of records</a:t>
+              <a:defRPr sz="2000"/>
+            </a:pPr>
+            <a:r>
+              <a:t>• Lack of Accountability - No audit trail</a:t>
+            </a:r>
+          </a:p>
+          <a:p>
+            <a:pPr lvl="1">
+              <a:defRPr sz="2000"/>
+            </a:pPr>
+            <a:r>
+              <a:t>• Inefficient Inter-Branch Coordination</a:t>
             </a:r>
           </a:p>
         </p:txBody>
@@ -4133,7 +3916,7 @@
               </a:defRPr>
             </a:pPr>
             <a:r>
-              <a:t>PROBLEMS IDENTIFIED</a:t>
+              <a:t>PROPOSED SOLUTION</a:t>
             </a:r>
           </a:p>
         </p:txBody>
@@ -4146,8 +3929,8 @@
         </p:nvSpPr>
         <p:spPr>
           <a:xfrm>
-            <a:off x="548640" y="1188720"/>
-            <a:ext cx="8046720" cy="4572000"/>
+            <a:off x="548640" y="1005840"/>
+            <a:ext cx="8046720" cy="731520"/>
           </a:xfrm>
           <a:prstGeom prst="rect">
             <a:avLst/>
@@ -4160,8 +3943,43 @@
           </a:bodyPr>
           <a:lstStyle/>
           <a:p>
-            <a:r>
-              <a:t>• Fragmented Records – Scattered across physical storage</a:t>
+            <a:pPr algn="ctr">
+              <a:defRPr sz="2200" b="1">
+                <a:solidFill>
+                  <a:srgbClr val="1E3A8A"/>
+                </a:solidFill>
+              </a:defRPr>
+            </a:pPr>
+            <a:r>
+              <a:t>GDCMAS - Gonzaga Dental Clinic Management Automation System</a:t>
+            </a:r>
+          </a:p>
+        </p:txBody>
+      </p:sp>
+      <p:sp>
+        <p:nvSpPr>
+          <p:cNvPr id="5" name="TextBox 4"/>
+          <p:cNvSpPr txBox="1"/>
+          <p:nvPr/>
+        </p:nvSpPr>
+        <p:spPr>
+          <a:xfrm>
+            <a:off x="548640" y="2011680"/>
+            <a:ext cx="8046720" cy="3200400"/>
+          </a:xfrm>
+          <a:prstGeom prst="rect">
+            <a:avLst/>
+          </a:prstGeom>
+          <a:noFill/>
+        </p:spPr>
+        <p:txBody>
+          <a:bodyPr wrap="none">
+            <a:spAutoFit/>
+          </a:bodyPr>
+          <a:lstStyle/>
+          <a:p>
+            <a:r>
+              <a:t>A centralized, web-based system that automates and digitizes clinic operations with:</a:t>
             </a:r>
           </a:p>
           <a:p>
@@ -4169,7 +3987,7 @@
               <a:defRPr sz="1900"/>
             </a:pPr>
             <a:r>
-              <a:t>• Limited Accessibility – No instant access between branches</a:t>
+              <a:t>✓ Centralized Patient Records  ✓ Digital Treatment History</a:t>
             </a:r>
           </a:p>
           <a:p>
@@ -4177,7 +3995,7 @@
               <a:defRPr sz="1900"/>
             </a:pPr>
             <a:r>
-              <a:t>• Manual Tracking – Time-consuming search for patient records</a:t>
+              <a:t>✓ Appointment Scheduling  ✓ Role-Based Access Control</a:t>
             </a:r>
           </a:p>
           <a:p>
@@ -4185,7 +4003,7 @@
               <a:defRPr sz="1900"/>
             </a:pPr>
             <a:r>
-              <a:t>• Scheduling Conflicts – Risk of double-booking</a:t>
+              <a:t>✓ Public Booking Portal  ✓ Multi-Layer Security</a:t>
             </a:r>
           </a:p>
           <a:p>
@@ -4193,31 +4011,7 @@
               <a:defRPr sz="1900"/>
             </a:pPr>
             <a:r>
-              <a:t>• No Data Backup – Vulnerable to loss or damage</a:t>
-            </a:r>
-          </a:p>
-          <a:p>
-            <a:pPr lvl="1">
-              <a:defRPr sz="1900"/>
-            </a:pPr>
-            <a:r>
-              <a:t>• Duplicate Records – Fragmentation of patient history</a:t>
-            </a:r>
-          </a:p>
-          <a:p>
-            <a:pPr lvl="1">
-              <a:defRPr sz="1900"/>
-            </a:pPr>
-            <a:r>
-              <a:t>• Lack of Accountability – No audit trail</a:t>
-            </a:r>
-          </a:p>
-          <a:p>
-            <a:pPr lvl="1">
-              <a:defRPr sz="1900"/>
-            </a:pPr>
-            <a:r>
-              <a:t>• Inefficient Coordination – Delays between branches</a:t>
+              <a:t>✓ Audit Logging  ✓ Inter-Branch Accessibility</a:t>
             </a:r>
           </a:p>
         </p:txBody>
@@ -4313,7 +4107,7 @@
               </a:defRPr>
             </a:pPr>
             <a:r>
-              <a:t>PROPOSED SOLUTION</a:t>
+              <a:t>SECURITY FEATURES</a:t>
             </a:r>
           </a:p>
         </p:txBody>
@@ -4326,8 +4120,8 @@
         </p:nvSpPr>
         <p:spPr>
           <a:xfrm>
-            <a:off x="548640" y="1005840"/>
-            <a:ext cx="8046720" cy="731520"/>
+            <a:off x="365760" y="1005840"/>
+            <a:ext cx="4297680" cy="4754880"/>
           </a:xfrm>
           <a:prstGeom prst="rect">
             <a:avLst/>
@@ -4340,15 +4134,80 @@
           </a:bodyPr>
           <a:lstStyle/>
           <a:p>
-            <a:pPr algn="ctr">
-              <a:defRPr sz="2200" b="1">
-                <a:solidFill>
-                  <a:srgbClr val="1E3A8A"/>
-                </a:solidFill>
-              </a:defRPr>
-            </a:pPr>
-            <a:r>
-              <a:t>GDCMAS - Gonzaga Dental Clinic Management Automation System</a:t>
+            <a:r>
+              <a:t>AUTHENTICATION &amp; ACCESS</a:t>
+            </a:r>
+          </a:p>
+          <a:p>
+            <a:pPr lvl="1">
+              <a:defRPr sz="1200"/>
+            </a:pPr>
+            <a:r>
+              <a:t>• 3-Layer Authorization (Proxy → Server → RLS)</a:t>
+            </a:r>
+          </a:p>
+          <a:p>
+            <a:pPr lvl="1">
+              <a:defRPr sz="1200"/>
+            </a:pPr>
+            <a:r>
+              <a:t>• Roles from DB, not JWT</a:t>
+            </a:r>
+          </a:p>
+          <a:p>
+            <a:pPr lvl="1">
+              <a:defRPr sz="1200"/>
+            </a:pPr>
+            <a:r>
+              <a:t>• Active-account gate</a:t>
+            </a:r>
+          </a:p>
+          <a:p>
+            <a:pPr lvl="1">
+              <a:defRPr sz="1200"/>
+            </a:pPr>
+            <a:r>
+              <a:t>• No self-promotion/deactivation</a:t>
+            </a:r>
+          </a:p>
+          <a:p>
+            <a:pPr lvl="1">
+              <a:defRPr sz="1200"/>
+            </a:pPr>
+            <a:r>
+              <a:t>• Branch isolation &amp; unassigned=no access</a:t>
+            </a:r>
+          </a:p>
+          <a:p>
+            <a:pPr lvl="1">
+              <a:defRPr b="1" sz="1300"/>
+            </a:pPr>
+            <a:r>
+              <a:t>DATA PROTECTION</a:t>
+            </a:r>
+          </a:p>
+          <a:p>
+            <a:pPr lvl="1">
+              <a:defRPr sz="1200"/>
+            </a:pPr>
+            <a:r>
+              <a:t>• RLS on all 9 tables</a:t>
+            </a:r>
+          </a:p>
+          <a:p>
+            <a:pPr lvl="1">
+              <a:defRPr sz="1200"/>
+            </a:pPr>
+            <a:r>
+              <a:t>• Clinical writes: Dentist/Admin only</a:t>
+            </a:r>
+          </a:p>
+          <a:p>
+            <a:pPr lvl="1">
+              <a:defRPr sz="1200"/>
+            </a:pPr>
+            <a:r>
+              <a:t>• Admin-only ops (staff, audit, settings)</a:t>
             </a:r>
           </a:p>
         </p:txBody>
@@ -4361,8 +4220,8 @@
         </p:nvSpPr>
         <p:spPr>
           <a:xfrm>
-            <a:off x="548640" y="1828800"/>
-            <a:ext cx="8046720" cy="3657600"/>
+            <a:off x="4754880" y="1005840"/>
+            <a:ext cx="4023360" cy="4754880"/>
           </a:xfrm>
           <a:prstGeom prst="rect">
             <a:avLst/>
@@ -4376,20 +4235,87 @@
           <a:lstStyle/>
           <a:p>
             <a:r>
-              <a:t>A centralized, web-based system that automates and digitizes all clinic operations to replace the paper-based workflow with a secure, efficient digital solution.</a:t>
-            </a:r>
-          </a:p>
-          <a:p>
-            <a:pPr>
-              <a:defRPr sz="1800"/>
-            </a:pPr>
-          </a:p>
-          <a:p>
-            <a:pPr>
-              <a:defRPr sz="1800" b="1"/>
-            </a:pPr>
-            <a:r>
-              <a:t>Goal: Provide a unified platform for patient records, treatment history, appointments, and clinic management accessible across both branches.</a:t>
+              <a:t>CONSTRAINTS &amp; AUDITING</a:t>
+            </a:r>
+          </a:p>
+          <a:p>
+            <a:pPr lvl="1">
+              <a:defRPr sz="1200"/>
+            </a:pPr>
+            <a:r>
+              <a:t>• No double bookings (DB constraints)</a:t>
+            </a:r>
+          </a:p>
+          <a:p>
+            <a:pPr lvl="1">
+              <a:defRPr sz="1200"/>
+            </a:pPr>
+            <a:r>
+              <a:t>• Cross-branch booking guard</a:t>
+            </a:r>
+          </a:p>
+          <a:p>
+            <a:pPr lvl="1">
+              <a:defRPr sz="1200"/>
+            </a:pPr>
+            <a:r>
+              <a:t>• Records cannot be destroyed</a:t>
+            </a:r>
+          </a:p>
+          <a:p>
+            <a:pPr lvl="1">
+              <a:defRPr sz="1200"/>
+            </a:pPr>
+            <a:r>
+              <a:t>• Append-only audit log</a:t>
+            </a:r>
+          </a:p>
+          <a:p>
+            <a:pPr lvl="1">
+              <a:defRPr sz="1200"/>
+            </a:pPr>
+            <a:r>
+              <a:t>• Input validation (Zod)</a:t>
+            </a:r>
+          </a:p>
+          <a:p>
+            <a:pPr lvl="1">
+              <a:defRPr b="1" sz="1300"/>
+            </a:pPr>
+            <a:r>
+              <a:t>PUBLIC BOOKING SECURITY</a:t>
+            </a:r>
+          </a:p>
+          <a:p>
+            <a:pPr lvl="1">
+              <a:defRPr sz="1200"/>
+            </a:pPr>
+            <a:r>
+              <a:t>• Anon has zero table access</a:t>
+            </a:r>
+          </a:p>
+          <a:p>
+            <a:pPr lvl="1">
+              <a:defRPr sz="1200"/>
+            </a:pPr>
+            <a:r>
+              <a:t>• Only 3 narrow functions accessible</a:t>
+            </a:r>
+          </a:p>
+          <a:p>
+            <a:pPr lvl="1">
+              <a:defRPr sz="1200"/>
+            </a:pPr>
+            <a:r>
+              <a:t>• Service role server-only</a:t>
+            </a:r>
+          </a:p>
+          <a:p>
+            <a:pPr lvl="1">
+              <a:defRPr sz="1200"/>
+            </a:pPr>
+            <a:r>
+              <a:t>• Verified by smoke-test.sql (25 tests)</a:t>
             </a:r>
           </a:p>
         </p:txBody>
@@ -4485,7 +4411,7 @@
               </a:defRPr>
             </a:pPr>
             <a:r>
-              <a:t>CORE FEATURES</a:t>
+              <a:t>TECHNOLOGY STACK</a:t>
             </a:r>
           </a:p>
         </p:txBody>
@@ -4498,8 +4424,8 @@
         </p:nvSpPr>
         <p:spPr>
           <a:xfrm>
-            <a:off x="548640" y="1188720"/>
-            <a:ext cx="8046720" cy="4572000"/>
+            <a:off x="914400" y="1371600"/>
+            <a:ext cx="7315200" cy="3657600"/>
           </a:xfrm>
           <a:prstGeom prst="rect">
             <a:avLst/>
@@ -4513,63 +4439,47 @@
           <a:lstStyle/>
           <a:p>
             <a:r>
-              <a:t>• Patient Management - Registration, search, duplicate detection</a:t>
+              <a:t>FRONTEND</a:t>
+            </a:r>
+          </a:p>
+          <a:p>
+            <a:pPr lvl="2">
+              <a:defRPr sz="1800"/>
+            </a:pPr>
+            <a:r>
+              <a:t>Next.js 16 (App Router) • React 19 • TypeScript • Tailwind CSS 4</a:t>
             </a:r>
           </a:p>
           <a:p>
             <a:pPr lvl="1">
-              <a:defRPr sz="1900"/>
-            </a:pPr>
-            <a:r>
-              <a:t>• Treatment Records - FDI Tooth Chart &amp; procedure tracking</a:t>
+              <a:defRPr b="1" sz="2000"/>
+            </a:pPr>
+            <a:r>
+              <a:t>BACKEND &amp; DATABASE</a:t>
+            </a:r>
+          </a:p>
+          <a:p>
+            <a:pPr lvl="2">
+              <a:defRPr sz="1800"/>
+            </a:pPr>
+            <a:r>
+              <a:t>Supabase (PostgreSQL, GoTrue Auth, Row Level Security)</a:t>
             </a:r>
           </a:p>
           <a:p>
             <a:pPr lvl="1">
-              <a:defRPr sz="1900"/>
-            </a:pPr>
-            <a:r>
-              <a:t>• Appointment Scheduling - Per-branch calendar with slot generation</a:t>
-            </a:r>
-          </a:p>
-          <a:p>
-            <a:pPr lvl="1">
-              <a:defRPr sz="1900"/>
-            </a:pPr>
-            <a:r>
-              <a:t>• Consent Management - Digital versioned consent forms</a:t>
-            </a:r>
-          </a:p>
-          <a:p>
-            <a:pPr lvl="1">
-              <a:defRPr sz="1900"/>
-            </a:pPr>
-            <a:r>
-              <a:t>• Public Booking Portal - Online appointment requests</a:t>
-            </a:r>
-          </a:p>
-          <a:p>
-            <a:pPr lvl="1">
-              <a:defRPr sz="1900"/>
-            </a:pPr>
-            <a:r>
-              <a:t>• Staff Management - Role-based user administration</a:t>
-            </a:r>
-          </a:p>
-          <a:p>
-            <a:pPr lvl="1">
-              <a:defRPr sz="1900"/>
-            </a:pPr>
-            <a:r>
-              <a:t>• Branch Overview - Real-time clinic statistics</a:t>
-            </a:r>
-          </a:p>
-          <a:p>
-            <a:pPr lvl="1">
-              <a:defRPr sz="1900"/>
-            </a:pPr>
-            <a:r>
-              <a:t>• Audit &amp; Governance - Complete activity logging</a:t>
+              <a:defRPr b="1" sz="2000"/>
+            </a:pPr>
+            <a:r>
+              <a:t>VALIDATION &amp; SECURITY</a:t>
+            </a:r>
+          </a:p>
+          <a:p>
+            <a:pPr lvl="2">
+              <a:defRPr sz="1800"/>
+            </a:pPr>
+            <a:r>
+              <a:t>Zod Schema Validation • Multi-Layer Authorization</a:t>
             </a:r>
           </a:p>
         </p:txBody>
@@ -4658,14 +4568,14 @@
           <a:lstStyle/>
           <a:p>
             <a:pPr>
-              <a:defRPr sz="2800" b="1">
+              <a:defRPr sz="3200" b="1">
                 <a:solidFill>
                   <a:srgbClr val="FFFFFF"/>
                 </a:solidFill>
               </a:defRPr>
             </a:pPr>
             <a:r>
-              <a:t>FUTURE-STATE PROCESS (TO-BE)</a:t>
+              <a:t>CONCLUSION</a:t>
             </a:r>
           </a:p>
         </p:txBody>
@@ -4679,7 +4589,7 @@
         <p:spPr>
           <a:xfrm>
             <a:off x="548640" y="1188720"/>
-            <a:ext cx="8046720" cy="4572000"/>
+            <a:ext cx="8046720" cy="3657600"/>
           </a:xfrm>
           <a:prstGeom prst="rect">
             <a:avLst/>
@@ -4693,7 +4603,7 @@
           <a:lstStyle/>
           <a:p>
             <a:r>
-              <a:t>1. Patient Registration/Retrieval → Centralized digital search &amp; registration</a:t>
+              <a:t>• The issue is lack of standardized, centralized process - not just software</a:t>
             </a:r>
           </a:p>
           <a:p>
@@ -4701,7 +4611,7 @@
               <a:defRPr sz="1800"/>
             </a:pPr>
             <a:r>
-              <a:t>2. Appointment Booking → System-based with real-time availability</a:t>
+              <a:t>• GDCMAS standardizes workflow first, then automates with technology</a:t>
             </a:r>
           </a:p>
           <a:p>
@@ -4709,7 +4619,7 @@
               <a:defRPr sz="1800"/>
             </a:pPr>
             <a:r>
-              <a:t>3. Consultation &amp; Treatment → Digital records with FDI tooth chart</a:t>
+              <a:t>• Addresses all identified issues with enterprise-grade security</a:t>
             </a:r>
           </a:p>
           <a:p>
@@ -4717,7 +4627,7 @@
               <a:defRPr sz="1800"/>
             </a:pPr>
             <a:r>
-              <a:t>4. Consent Documentation → Digital versioned consent with audit trail</a:t>
+              <a:t>• Improves efficiency, accessibility, accountability &amp; patient care</a:t>
             </a:r>
           </a:p>
           <a:p>
@@ -4725,7 +4635,7 @@
               <a:defRPr sz="1800"/>
             </a:pPr>
             <a:r>
-              <a:t>5. Inter-Branch Access → Seamless access across both branches</a:t>
+              <a:t>• Centralized records enable better continuity of care across branches</a:t>
             </a:r>
           </a:p>
           <a:p>
@@ -4733,82 +4643,21 @@
               <a:defRPr sz="1800"/>
             </a:pPr>
             <a:r>
-              <a:t>6. Monitoring &amp; Reporting → Real-time dashboards and audit logs</a:t>
-            </a:r>
-          </a:p>
-        </p:txBody>
-      </p:sp>
-    </p:spTree>
-  </p:cSld>
-  <p:clrMapOvr>
-    <a:masterClrMapping/>
-  </p:clrMapOvr>
-</p:sld>
-</file>
-
-<file path=ppt/slides/slide9.xml><?xml version="1.0" encoding="utf-8"?>
-<p:sld xmlns:a="http://schemas.openxmlformats.org/drawingml/2006/main" xmlns:p="http://schemas.openxmlformats.org/presentationml/2006/main" xmlns:r="http://schemas.openxmlformats.org/officeDocument/2006/relationships">
-  <p:cSld>
-    <p:spTree>
-      <p:nvGrpSpPr>
-        <p:cNvPr id="1" name=""/>
-        <p:cNvGrpSpPr/>
-        <p:nvPr/>
-      </p:nvGrpSpPr>
-      <p:grpSpPr/>
-      <p:sp>
-        <p:nvSpPr>
-          <p:cNvPr id="2" name="Rectangle 1"/>
-          <p:cNvSpPr/>
-          <p:nvPr/>
-        </p:nvSpPr>
-        <p:spPr>
-          <a:xfrm>
-            <a:off x="0" y="0"/>
-            <a:ext cx="9144000" cy="822960"/>
-          </a:xfrm>
-          <a:prstGeom prst="rect">
-            <a:avLst/>
-          </a:prstGeom>
-          <a:solidFill>
-            <a:srgbClr val="4A7A5C"/>
-          </a:solidFill>
-          <a:ln>
-            <a:noFill/>
-          </a:ln>
-        </p:spPr>
-        <p:style>
-          <a:lnRef idx="1">
-            <a:schemeClr val="accent1"/>
-          </a:lnRef>
-          <a:fillRef idx="3">
-            <a:schemeClr val="accent1"/>
-          </a:fillRef>
-          <a:effectRef idx="2">
-            <a:schemeClr val="accent1"/>
-          </a:effectRef>
-          <a:fontRef idx="minor">
-            <a:schemeClr val="lt1"/>
-          </a:fontRef>
-        </p:style>
-        <p:txBody>
-          <a:bodyPr rtlCol="0" anchor="ctr"/>
-          <a:lstStyle/>
-          <a:p>
-            <a:pPr algn="ctr"/>
-          </a:p>
-        </p:txBody>
-      </p:sp>
-      <p:sp>
-        <p:nvSpPr>
-          <p:cNvPr id="3" name="TextBox 2"/>
+              <a:t>• Ready for implementation with proper validation and training</a:t>
+            </a:r>
+          </a:p>
+        </p:txBody>
+      </p:sp>
+      <p:sp>
+        <p:nvSpPr>
+          <p:cNvPr id="5" name="TextBox 4"/>
           <p:cNvSpPr txBox="1"/>
           <p:nvPr/>
         </p:nvSpPr>
         <p:spPr>
           <a:xfrm>
-            <a:off x="457200" y="137160"/>
-            <a:ext cx="8229600" cy="640080"/>
+            <a:off x="457200" y="5029200"/>
+            <a:ext cx="8229600" cy="914400"/>
           </a:xfrm>
           <a:prstGeom prst="rect">
             <a:avLst/>
@@ -4821,175 +4670,32 @@
           </a:bodyPr>
           <a:lstStyle/>
           <a:p>
-            <a:pPr>
-              <a:defRPr sz="2400" b="1">
+            <a:pPr algn="ctr">
+              <a:defRPr sz="3600" b="1">
                 <a:solidFill>
-                  <a:srgbClr val="FFFFFF"/>
+                  <a:srgbClr val="1E3A8A"/>
                 </a:solidFill>
               </a:defRPr>
             </a:pPr>
             <a:r>
-              <a:t>TECHNOLOGY STACK, SECURITY &amp; BENEFITS</a:t>
-            </a:r>
-          </a:p>
-        </p:txBody>
-      </p:sp>
-      <p:sp>
-        <p:nvSpPr>
-          <p:cNvPr id="4" name="TextBox 3"/>
-          <p:cNvSpPr txBox="1"/>
-          <p:nvPr/>
-        </p:nvSpPr>
-        <p:spPr>
-          <a:xfrm>
-            <a:off x="457200" y="1005840"/>
-            <a:ext cx="4114800" cy="2286000"/>
-          </a:xfrm>
-          <a:prstGeom prst="rect">
-            <a:avLst/>
-          </a:prstGeom>
-          <a:noFill/>
-        </p:spPr>
-        <p:txBody>
-          <a:bodyPr wrap="none">
-            <a:spAutoFit/>
-          </a:bodyPr>
-          <a:lstStyle/>
-          <a:p>
-            <a:r>
-              <a:t>TECH STACK:</a:t>
-            </a:r>
-          </a:p>
-          <a:p>
-            <a:pPr lvl="2">
-              <a:defRPr sz="1400"/>
-            </a:pPr>
-            <a:r>
-              <a:t>• Next.js 16 | React 19</a:t>
-            </a:r>
-          </a:p>
-          <a:p>
-            <a:pPr lvl="2">
-              <a:defRPr sz="1400"/>
-            </a:pPr>
-            <a:r>
-              <a:t>• TypeScript | Tailwind CSS 4</a:t>
-            </a:r>
-          </a:p>
-          <a:p>
-            <a:pPr lvl="2">
-              <a:defRPr sz="1400"/>
-            </a:pPr>
-            <a:r>
-              <a:t>• Supabase (Postgres, Auth, RLS)</a:t>
-            </a:r>
-          </a:p>
-          <a:p>
-            <a:pPr lvl="2">
-              <a:defRPr sz="1400"/>
-            </a:pPr>
-            <a:r>
-              <a:t>• Zod Validation</a:t>
-            </a:r>
-          </a:p>
-        </p:txBody>
-      </p:sp>
-      <p:sp>
-        <p:nvSpPr>
-          <p:cNvPr id="5" name="TextBox 4"/>
-          <p:cNvSpPr txBox="1"/>
-          <p:nvPr/>
-        </p:nvSpPr>
-        <p:spPr>
-          <a:xfrm>
-            <a:off x="4572000" y="1005840"/>
-            <a:ext cx="4114800" cy="2286000"/>
-          </a:xfrm>
-          <a:prstGeom prst="rect">
-            <a:avLst/>
-          </a:prstGeom>
-          <a:noFill/>
-        </p:spPr>
-        <p:txBody>
-          <a:bodyPr wrap="none">
-            <a:spAutoFit/>
-          </a:bodyPr>
-          <a:lstStyle/>
-          <a:p>
-            <a:r>
-              <a:t>SECURITY (3-LAYERS):</a:t>
-            </a:r>
-          </a:p>
-          <a:p>
-            <a:pPr lvl="1">
-              <a:defRPr sz="1400"/>
-            </a:pPr>
-            <a:r>
-              <a:t>1. Proxy Layer</a:t>
-            </a:r>
-          </a:p>
-          <a:p>
-            <a:pPr lvl="1">
-              <a:defRPr sz="1400"/>
-            </a:pPr>
-            <a:r>
-              <a:t>2. Server Validation</a:t>
-            </a:r>
-          </a:p>
-          <a:p>
-            <a:pPr lvl="1">
-              <a:defRPr sz="1400"/>
-            </a:pPr>
-            <a:r>
-              <a:t>3. PostgreSQL RLS</a:t>
-            </a:r>
-          </a:p>
-          <a:p>
-            <a:pPr lvl="1">
-              <a:defRPr sz="1400" b="1"/>
-            </a:pPr>
-            <a:r>
-              <a:t>Roles: Dentist | Secretary | Admin</a:t>
-            </a:r>
-          </a:p>
-        </p:txBody>
-      </p:sp>
-      <p:sp>
-        <p:nvSpPr>
-          <p:cNvPr id="6" name="TextBox 5"/>
-          <p:cNvSpPr txBox="1"/>
-          <p:nvPr/>
-        </p:nvSpPr>
-        <p:spPr>
-          <a:xfrm>
-            <a:off x="457200" y="3474720"/>
-            <a:ext cx="8229600" cy="2743200"/>
-          </a:xfrm>
-          <a:prstGeom prst="rect">
-            <a:avLst/>
-          </a:prstGeom>
-          <a:noFill/>
-        </p:spPr>
-        <p:txBody>
-          <a:bodyPr wrap="none">
-            <a:spAutoFit/>
-          </a:bodyPr>
-          <a:lstStyle/>
-          <a:p>
-            <a:r>
-              <a:t>KEY BENEFITS:</a:t>
+              <a:t>THANK YOU!</a:t>
+            </a:r>
+          </a:p>
+          <a:p>
+            <a:r>
+              <a:t>Questions and Answers</a:t>
             </a:r>
           </a:p>
           <a:p>
             <a:pPr algn="ctr">
-              <a:defRPr sz="1800" b="1">
+              <a:defRPr sz="1400">
                 <a:solidFill>
                   <a:srgbClr val="4A7A5C"/>
                 </a:solidFill>
               </a:defRPr>
             </a:pPr>
             <a:r>
-              <a:t>Centralization • Accessibility • Efficiency • Accountability • Security • Accuracy • Convenience</a:t>
+              <a:t>PHINMA University of Iloilo - College of Information Technology Education</a:t>
             </a:r>
           </a:p>
         </p:txBody>

</xml_diff>

<commit_message>
Redesign defense PPT with professional dental/medical theme and enhanced visuals
</commit_message>
<xml_diff>
--- a/GDCMAS_Final_Defense_Presentation.pptx
+++ b/GDCMAS_Final_Defense_Presentation.pptx
@@ -3104,13 +3104,13 @@
         <p:spPr>
           <a:xfrm>
             <a:off x="0" y="0"/>
-            <a:ext cx="9144000" cy="1188720"/>
+            <a:ext cx="9144000" cy="1463040"/>
           </a:xfrm>
           <a:prstGeom prst="rect">
             <a:avLst/>
           </a:prstGeom>
           <a:solidFill>
-            <a:srgbClr val="4A7A5C"/>
+            <a:srgbClr val="1B5E20"/>
           </a:solidFill>
           <a:ln>
             <a:noFill/>
@@ -3140,185 +3140,20 @@
       </p:sp>
       <p:sp>
         <p:nvSpPr>
-          <p:cNvPr id="3" name="TextBox 2"/>
-          <p:cNvSpPr txBox="1"/>
+          <p:cNvPr id="3" name="Rectangle 2"/>
+          <p:cNvSpPr/>
           <p:nvPr/>
         </p:nvSpPr>
         <p:spPr>
           <a:xfrm>
-            <a:off x="274320" y="1463040"/>
-            <a:ext cx="8595360" cy="1828800"/>
-          </a:xfrm>
-          <a:prstGeom prst="rect">
-            <a:avLst/>
-          </a:prstGeom>
-          <a:noFill/>
-        </p:spPr>
-        <p:txBody>
-          <a:bodyPr wrap="none">
-            <a:spAutoFit/>
-          </a:bodyPr>
-          <a:lstStyle/>
-          <a:p>
-            <a:pPr algn="ctr">
-              <a:defRPr sz="2800" b="1">
-                <a:solidFill>
-                  <a:srgbClr val="1E3A8A"/>
-                </a:solidFill>
-              </a:defRPr>
-            </a:pPr>
-            <a:r>
-              <a:t>GONZAGA DENTAL CLINIC MANAGEMENT AUTOMATION SYSTEM (GDCMAS)</a:t>
-            </a:r>
-          </a:p>
-        </p:txBody>
-      </p:sp>
-      <p:sp>
-        <p:nvSpPr>
-          <p:cNvPr id="4" name="TextBox 3"/>
-          <p:cNvSpPr txBox="1"/>
-          <p:nvPr/>
-        </p:nvSpPr>
-        <p:spPr>
-          <a:xfrm>
-            <a:off x="274320" y="3474720"/>
-            <a:ext cx="8595360" cy="1097280"/>
-          </a:xfrm>
-          <a:prstGeom prst="rect">
-            <a:avLst/>
-          </a:prstGeom>
-          <a:noFill/>
-        </p:spPr>
-        <p:txBody>
-          <a:bodyPr wrap="none">
-            <a:spAutoFit/>
-          </a:bodyPr>
-          <a:lstStyle/>
-          <a:p>
-            <a:pPr algn="ctr">
-              <a:defRPr sz="1600"/>
-            </a:pPr>
-            <a:r>
-              <a:t>A Business Process Automation Plan for Streamlining Patient Records,</a:t>
-            </a:r>
-          </a:p>
-          <a:p>
-            <a:r>
-              <a:t>Appointment Scheduling, and Dental Clinic Operations at Gonzaga Dental Clinic</a:t>
-            </a:r>
-          </a:p>
-        </p:txBody>
-      </p:sp>
-      <p:sp>
-        <p:nvSpPr>
-          <p:cNvPr id="5" name="TextBox 4"/>
-          <p:cNvSpPr txBox="1"/>
-          <p:nvPr/>
-        </p:nvSpPr>
-        <p:spPr>
-          <a:xfrm>
-            <a:off x="274320" y="4754880"/>
-            <a:ext cx="8595360" cy="1371600"/>
-          </a:xfrm>
-          <a:prstGeom prst="rect">
-            <a:avLst/>
-          </a:prstGeom>
-          <a:noFill/>
-        </p:spPr>
-        <p:txBody>
-          <a:bodyPr wrap="none">
-            <a:spAutoFit/>
-          </a:bodyPr>
-          <a:lstStyle/>
-          <a:p>
-            <a:pPr algn="ctr">
-              <a:defRPr sz="1400"/>
-            </a:pPr>
-            <a:r>
-              <a:t>Amor, Khent Vincent C. | Galve, Fritz Michael G. | Gayem, Vince</a:t>
-            </a:r>
-          </a:p>
-          <a:p>
-            <a:r>
-              <a:t>Jeruta, John Paul | Perez, Godwin | Simba, Via Marie</a:t>
-            </a:r>
-          </a:p>
-          <a:p>
-            <a:r>
-              <a:t>Suasin, Ela | Tamba, Mon Wilbert</a:t>
-            </a:r>
-          </a:p>
-        </p:txBody>
-      </p:sp>
-      <p:sp>
-        <p:nvSpPr>
-          <p:cNvPr id="6" name="TextBox 5"/>
-          <p:cNvSpPr txBox="1"/>
-          <p:nvPr/>
-        </p:nvSpPr>
-        <p:spPr>
-          <a:xfrm>
-            <a:off x="274320" y="6217920"/>
-            <a:ext cx="8595360" cy="548640"/>
-          </a:xfrm>
-          <a:prstGeom prst="rect">
-            <a:avLst/>
-          </a:prstGeom>
-          <a:noFill/>
-        </p:spPr>
-        <p:txBody>
-          <a:bodyPr wrap="none">
-            <a:spAutoFit/>
-          </a:bodyPr>
-          <a:lstStyle/>
-          <a:p>
-            <a:pPr algn="ctr">
-              <a:defRPr sz="1200">
-                <a:solidFill>
-                  <a:srgbClr val="4A7A5C"/>
-                </a:solidFill>
-              </a:defRPr>
-            </a:pPr>
-            <a:r>
-              <a:t>PHINMA University of Iloilo | College of Information Technology Education | October 2026</a:t>
-            </a:r>
-          </a:p>
-        </p:txBody>
-      </p:sp>
-    </p:spTree>
-  </p:cSld>
-  <p:clrMapOvr>
-    <a:masterClrMapping/>
-  </p:clrMapOvr>
-</p:sld>
-</file>
-
-<file path=ppt/slides/slide2.xml><?xml version="1.0" encoding="utf-8"?>
-<p:sld xmlns:a="http://schemas.openxmlformats.org/drawingml/2006/main" xmlns:p="http://schemas.openxmlformats.org/presentationml/2006/main" xmlns:r="http://schemas.openxmlformats.org/officeDocument/2006/relationships">
-  <p:cSld>
-    <p:spTree>
-      <p:nvGrpSpPr>
-        <p:cNvPr id="1" name=""/>
-        <p:cNvGrpSpPr/>
-        <p:nvPr/>
-      </p:nvGrpSpPr>
-      <p:grpSpPr/>
-      <p:sp>
-        <p:nvSpPr>
-          <p:cNvPr id="2" name="Rectangle 1"/>
-          <p:cNvSpPr/>
-          <p:nvPr/>
-        </p:nvSpPr>
-        <p:spPr>
-          <a:xfrm>
-            <a:off x="0" y="0"/>
-            <a:ext cx="9144000" cy="822960"/>
+            <a:off x="0" y="6400800"/>
+            <a:ext cx="9144000" cy="109728"/>
           </a:xfrm>
           <a:prstGeom prst="rect">
             <a:avLst/>
           </a:prstGeom>
           <a:solidFill>
-            <a:srgbClr val="4A7A5C"/>
+            <a:srgbClr val="00897B"/>
           </a:solidFill>
           <a:ln>
             <a:noFill/>
@@ -3348,13 +3183,152 @@
       </p:sp>
       <p:sp>
         <p:nvSpPr>
-          <p:cNvPr id="3" name="TextBox 2"/>
+          <p:cNvPr id="4" name="Oval 3"/>
+          <p:cNvSpPr/>
+          <p:nvPr/>
+        </p:nvSpPr>
+        <p:spPr>
+          <a:xfrm>
+            <a:off x="3886200" y="1097280"/>
+            <a:ext cx="1371600" cy="1371600"/>
+          </a:xfrm>
+          <a:prstGeom prst="ellipse">
+            <a:avLst/>
+          </a:prstGeom>
+          <a:solidFill>
+            <a:srgbClr val="FFFFFF"/>
+          </a:solidFill>
+          <a:ln w="38100">
+            <a:solidFill>
+              <a:srgbClr val="FFFFFF"/>
+            </a:solidFill>
+          </a:ln>
+        </p:spPr>
+        <p:style>
+          <a:lnRef idx="1">
+            <a:schemeClr val="accent1"/>
+          </a:lnRef>
+          <a:fillRef idx="3">
+            <a:schemeClr val="accent1"/>
+          </a:fillRef>
+          <a:effectRef idx="2">
+            <a:schemeClr val="accent1"/>
+          </a:effectRef>
+          <a:fontRef idx="minor">
+            <a:schemeClr val="lt1"/>
+          </a:fontRef>
+        </p:style>
+        <p:txBody>
+          <a:bodyPr rtlCol="0" anchor="ctr"/>
+          <a:lstStyle/>
+          <a:p>
+            <a:pPr algn="ctr"/>
+          </a:p>
+        </p:txBody>
+      </p:sp>
+      <p:sp>
+        <p:nvSpPr>
+          <p:cNvPr id="5" name="TextBox 4"/>
           <p:cNvSpPr txBox="1"/>
           <p:nvPr/>
         </p:nvSpPr>
         <p:spPr>
           <a:xfrm>
-            <a:off x="457200" y="137160"/>
+            <a:off x="274320" y="2651760"/>
+            <a:ext cx="8595360" cy="1828800"/>
+          </a:xfrm>
+          <a:prstGeom prst="rect">
+            <a:avLst/>
+          </a:prstGeom>
+          <a:noFill/>
+        </p:spPr>
+        <p:txBody>
+          <a:bodyPr wrap="square">
+            <a:spAutoFit/>
+          </a:bodyPr>
+          <a:lstStyle/>
+          <a:p>
+            <a:pPr algn="ctr">
+              <a:defRPr sz="3000" b="1">
+                <a:solidFill>
+                  <a:srgbClr val="1B5E20"/>
+                </a:solidFill>
+              </a:defRPr>
+            </a:pPr>
+            <a:r>
+              <a:t>GONZAGA DENTAL CLINIC MANAGEMENT</a:t>
+            </a:r>
+          </a:p>
+          <a:p>
+            <a:pPr algn="ctr">
+              <a:defRPr sz="3000" b="1">
+                <a:solidFill>
+                  <a:srgbClr val="1B5E20"/>
+                </a:solidFill>
+              </a:defRPr>
+            </a:pPr>
+            <a:r>
+              <a:t>AUTOMATION SYSTEM (GDCMAS)</a:t>
+            </a:r>
+          </a:p>
+        </p:txBody>
+      </p:sp>
+      <p:sp>
+        <p:nvSpPr>
+          <p:cNvPr id="6" name="TextBox 5"/>
+          <p:cNvSpPr txBox="1"/>
+          <p:nvPr/>
+        </p:nvSpPr>
+        <p:spPr>
+          <a:xfrm>
+            <a:off x="731520" y="4572000"/>
+            <a:ext cx="7680960" cy="914400"/>
+          </a:xfrm>
+          <a:prstGeom prst="rect">
+            <a:avLst/>
+          </a:prstGeom>
+          <a:noFill/>
+        </p:spPr>
+        <p:txBody>
+          <a:bodyPr wrap="square">
+            <a:spAutoFit/>
+          </a:bodyPr>
+          <a:lstStyle/>
+          <a:p>
+            <a:pPr algn="ctr">
+              <a:defRPr sz="1400">
+                <a:solidFill>
+                  <a:srgbClr val="424242"/>
+                </a:solidFill>
+              </a:defRPr>
+            </a:pPr>
+            <a:r>
+              <a:t>A Business Process Automation Plan for Streamlining Patient Records,</a:t>
+            </a:r>
+          </a:p>
+          <a:p>
+            <a:pPr algn="ctr">
+              <a:defRPr sz="1400">
+                <a:solidFill>
+                  <a:srgbClr val="424242"/>
+                </a:solidFill>
+              </a:defRPr>
+            </a:pPr>
+            <a:r>
+              <a:t>Appointment Scheduling, and Dental Clinic Operations at Gonzaga Dental Clinic</a:t>
+            </a:r>
+          </a:p>
+        </p:txBody>
+      </p:sp>
+      <p:sp>
+        <p:nvSpPr>
+          <p:cNvPr id="7" name="TextBox 6"/>
+          <p:cNvSpPr txBox="1"/>
+          <p:nvPr/>
+        </p:nvSpPr>
+        <p:spPr>
+          <a:xfrm>
+            <a:off x="457200" y="5669280"/>
             <a:ext cx="8229600" cy="640080"/>
           </a:xfrm>
           <a:prstGeom prst="rect">
@@ -3368,115 +3342,15 @@
           </a:bodyPr>
           <a:lstStyle/>
           <a:p>
-            <a:pPr>
-              <a:defRPr sz="3200" b="1">
-                <a:solidFill>
-                  <a:srgbClr val="FFFFFF"/>
-                </a:solidFill>
-              </a:defRPr>
-            </a:pPr>
-            <a:r>
-              <a:t>OUTLINE</a:t>
-            </a:r>
-          </a:p>
-        </p:txBody>
-      </p:sp>
-      <p:sp>
-        <p:nvSpPr>
-          <p:cNvPr id="4" name="TextBox 3"/>
-          <p:cNvSpPr txBox="1"/>
-          <p:nvPr/>
-        </p:nvSpPr>
-        <p:spPr>
-          <a:xfrm>
-            <a:off x="731520" y="1188720"/>
-            <a:ext cx="7680960" cy="4572000"/>
-          </a:xfrm>
-          <a:prstGeom prst="rect">
-            <a:avLst/>
-          </a:prstGeom>
-          <a:noFill/>
-        </p:spPr>
-        <p:txBody>
-          <a:bodyPr wrap="none">
-            <a:spAutoFit/>
-          </a:bodyPr>
-          <a:lstStyle/>
-          <a:p>
-            <a:r>
-              <a:t>1. Business Problem</a:t>
-            </a:r>
-          </a:p>
-          <a:p>
-            <a:pPr lvl="1">
-              <a:defRPr sz="2200"/>
-            </a:pPr>
-            <a:r>
-              <a:t>2. Current Process (As-Is)</a:t>
-            </a:r>
-          </a:p>
-          <a:p>
-            <a:pPr lvl="1">
-              <a:defRPr sz="2200"/>
-            </a:pPr>
-            <a:r>
-              <a:t>3. Problems Identified</a:t>
-            </a:r>
-          </a:p>
-          <a:p>
-            <a:pPr lvl="1">
-              <a:defRPr sz="2200"/>
-            </a:pPr>
-            <a:r>
-              <a:t>4. Proposed Solution (GDCMAS)</a:t>
-            </a:r>
-          </a:p>
-          <a:p>
-            <a:pPr lvl="1">
-              <a:defRPr sz="2200"/>
-            </a:pPr>
-            <a:r>
-              <a:t>5. Core Features</a:t>
-            </a:r>
-          </a:p>
-          <a:p>
-            <a:pPr lvl="1">
-              <a:defRPr sz="2200"/>
-            </a:pPr>
-            <a:r>
-              <a:t>6. Future-State Process (To-Be)</a:t>
-            </a:r>
-          </a:p>
-          <a:p>
-            <a:pPr lvl="1">
-              <a:defRPr sz="2200"/>
-            </a:pPr>
-            <a:r>
-              <a:t>7. Technology Stack</a:t>
-            </a:r>
-          </a:p>
-          <a:p>
-            <a:pPr lvl="1">
-              <a:defRPr sz="2200"/>
-            </a:pPr>
-            <a:r>
-              <a:t>8. Security Features</a:t>
-            </a:r>
-          </a:p>
-          <a:p>
-            <a:pPr lvl="1">
-              <a:defRPr sz="2200"/>
-            </a:pPr>
-            <a:r>
-              <a:t>9. Benefits &amp; Conclusion</a:t>
-            </a:r>
-          </a:p>
-          <a:p>
-            <a:pPr lvl="1">
-              <a:defRPr sz="2200"/>
-            </a:pPr>
-            <a:r>
-              <a:t>10. Q &amp; A</a:t>
+            <a:pPr algn="ctr">
+              <a:defRPr sz="1200">
+                <a:solidFill>
+                  <a:srgbClr val="212121"/>
+                </a:solidFill>
+              </a:defRPr>
+            </a:pPr>
+            <a:r>
+              <a:t>Amor • Galve • Gayem • Jeruta • Perez • Simba • Suasin • Tamba</a:t>
             </a:r>
           </a:p>
         </p:txBody>
@@ -3489,7 +3363,7 @@
 </p:sld>
 </file>
 
-<file path=ppt/slides/slide3.xml><?xml version="1.0" encoding="utf-8"?>
+<file path=ppt/slides/slide2.xml><?xml version="1.0" encoding="utf-8"?>
 <p:sld xmlns:a="http://schemas.openxmlformats.org/drawingml/2006/main" xmlns:p="http://schemas.openxmlformats.org/presentationml/2006/main" xmlns:r="http://schemas.openxmlformats.org/officeDocument/2006/relationships">
   <p:cSld>
     <p:spTree>
@@ -3514,7 +3388,7 @@
             <a:avLst/>
           </a:prstGeom>
           <a:solidFill>
-            <a:srgbClr val="4A7A5C"/>
+            <a:srgbClr val="1B5E20"/>
           </a:solidFill>
           <a:ln>
             <a:noFill/>
@@ -3550,8 +3424,8 @@
         </p:nvSpPr>
         <p:spPr>
           <a:xfrm>
-            <a:off x="457200" y="137160"/>
-            <a:ext cx="8229600" cy="640080"/>
+            <a:off x="548640" y="137160"/>
+            <a:ext cx="8046720" cy="640080"/>
           </a:xfrm>
           <a:prstGeom prst="rect">
             <a:avLst/>
@@ -3572,7 +3446,7 @@
               </a:defRPr>
             </a:pPr>
             <a:r>
-              <a:t>BUSINESS PROBLEM</a:t>
+              <a:t>OUTLINE</a:t>
             </a:r>
           </a:p>
         </p:txBody>
@@ -3585,8 +3459,8 @@
         </p:nvSpPr>
         <p:spPr>
           <a:xfrm>
-            <a:off x="548640" y="1188720"/>
-            <a:ext cx="8046720" cy="4572000"/>
+            <a:off x="1188720" y="1280160"/>
+            <a:ext cx="6766560" cy="4754880"/>
           </a:xfrm>
           <a:prstGeom prst="rect">
             <a:avLst/>
@@ -3599,56 +3473,183 @@
           </a:bodyPr>
           <a:lstStyle/>
           <a:p>
-            <a:r>
-              <a:t>Gonzaga Dental Clinic currently uses a paper-based system:</a:t>
-            </a:r>
-          </a:p>
-          <a:p>
-            <a:pPr lvl="1">
-              <a:defRPr sz="2000"/>
-            </a:pPr>
-            <a:r>
-              <a:t>• Patient records in physical envelopes, binders, and cabinets</a:t>
-            </a:r>
-          </a:p>
-          <a:p>
-            <a:pPr lvl="1">
-              <a:defRPr sz="2000"/>
-            </a:pPr>
-            <a:r>
-              <a:t>• Appointments recorded in a logbook</a:t>
-            </a:r>
-          </a:p>
-          <a:p>
-            <a:pPr lvl="1">
-              <a:defRPr sz="2000"/>
-            </a:pPr>
-            <a:r>
-              <a:t>• Treatments recorded on index cards</a:t>
-            </a:r>
-          </a:p>
-          <a:p>
-            <a:pPr lvl="1">
-              <a:defRPr sz="2000"/>
-            </a:pPr>
-            <a:r>
-              <a:t>• No inter-branch record accessibility</a:t>
-            </a:r>
-          </a:p>
-          <a:p>
-            <a:pPr lvl="1">
-              <a:defRPr sz="2000"/>
-            </a:pPr>
-            <a:r>
-              <a:t>• No backup system for physical records</a:t>
-            </a:r>
-          </a:p>
-          <a:p>
-            <a:pPr lvl="1">
-              <a:defRPr sz="2000"/>
-            </a:pPr>
-            <a:r>
-              <a:t>• Risk of duplicate records &amp; data loss</a:t>
+            <a:pPr>
+              <a:spcBef>
+                <a:spcPts val="600"/>
+              </a:spcBef>
+              <a:spcAft>
+                <a:spcPts val="600"/>
+              </a:spcAft>
+              <a:defRPr sz="2300">
+                <a:solidFill>
+                  <a:srgbClr val="212121"/>
+                </a:solidFill>
+              </a:defRPr>
+            </a:pPr>
+            <a:r>
+              <a:t>1. Rationale of the Study</a:t>
+            </a:r>
+          </a:p>
+          <a:p>
+            <a:pPr>
+              <a:spcBef>
+                <a:spcPts val="600"/>
+              </a:spcBef>
+              <a:spcAft>
+                <a:spcPts val="600"/>
+              </a:spcAft>
+              <a:defRPr sz="2300">
+                <a:solidFill>
+                  <a:srgbClr val="212121"/>
+                </a:solidFill>
+              </a:defRPr>
+            </a:pPr>
+            <a:r>
+              <a:t>2. Business Problem</a:t>
+            </a:r>
+          </a:p>
+          <a:p>
+            <a:pPr>
+              <a:spcBef>
+                <a:spcPts val="600"/>
+              </a:spcBef>
+              <a:spcAft>
+                <a:spcPts val="600"/>
+              </a:spcAft>
+              <a:defRPr sz="2300">
+                <a:solidFill>
+                  <a:srgbClr val="212121"/>
+                </a:solidFill>
+              </a:defRPr>
+            </a:pPr>
+            <a:r>
+              <a:t>3. Current vs Proposed Process</a:t>
+            </a:r>
+          </a:p>
+          <a:p>
+            <a:pPr>
+              <a:spcBef>
+                <a:spcPts val="600"/>
+              </a:spcBef>
+              <a:spcAft>
+                <a:spcPts val="600"/>
+              </a:spcAft>
+              <a:defRPr sz="2300">
+                <a:solidFill>
+                  <a:srgbClr val="212121"/>
+                </a:solidFill>
+              </a:defRPr>
+            </a:pPr>
+            <a:r>
+              <a:t>4. Problems Identified</a:t>
+            </a:r>
+          </a:p>
+          <a:p>
+            <a:pPr>
+              <a:spcBef>
+                <a:spcPts val="600"/>
+              </a:spcBef>
+              <a:spcAft>
+                <a:spcPts val="600"/>
+              </a:spcAft>
+              <a:defRPr sz="2300">
+                <a:solidFill>
+                  <a:srgbClr val="212121"/>
+                </a:solidFill>
+              </a:defRPr>
+            </a:pPr>
+            <a:r>
+              <a:t>5. Proposed Solution</a:t>
+            </a:r>
+          </a:p>
+          <a:p>
+            <a:pPr>
+              <a:spcBef>
+                <a:spcPts val="600"/>
+              </a:spcBef>
+              <a:spcAft>
+                <a:spcPts val="600"/>
+              </a:spcAft>
+              <a:defRPr sz="2300">
+                <a:solidFill>
+                  <a:srgbClr val="212121"/>
+                </a:solidFill>
+              </a:defRPr>
+            </a:pPr>
+            <a:r>
+              <a:t>6. System Features</a:t>
+            </a:r>
+          </a:p>
+          <a:p>
+            <a:pPr>
+              <a:spcBef>
+                <a:spcPts val="600"/>
+              </a:spcBef>
+              <a:spcAft>
+                <a:spcPts val="600"/>
+              </a:spcAft>
+              <a:defRPr sz="2300">
+                <a:solidFill>
+                  <a:srgbClr val="212121"/>
+                </a:solidFill>
+              </a:defRPr>
+            </a:pPr>
+            <a:r>
+              <a:t>7. Technology Stack</a:t>
+            </a:r>
+          </a:p>
+          <a:p>
+            <a:pPr>
+              <a:spcBef>
+                <a:spcPts val="600"/>
+              </a:spcBef>
+              <a:spcAft>
+                <a:spcPts val="600"/>
+              </a:spcAft>
+              <a:defRPr sz="2300">
+                <a:solidFill>
+                  <a:srgbClr val="212121"/>
+                </a:solidFill>
+              </a:defRPr>
+            </a:pPr>
+            <a:r>
+              <a:t>8. Security Features</a:t>
+            </a:r>
+          </a:p>
+          <a:p>
+            <a:pPr>
+              <a:spcBef>
+                <a:spcPts val="600"/>
+              </a:spcBef>
+              <a:spcAft>
+                <a:spcPts val="600"/>
+              </a:spcAft>
+              <a:defRPr sz="2300">
+                <a:solidFill>
+                  <a:srgbClr val="212121"/>
+                </a:solidFill>
+              </a:defRPr>
+            </a:pPr>
+            <a:r>
+              <a:t>9. Benefits and Conclusion</a:t>
+            </a:r>
+          </a:p>
+          <a:p>
+            <a:pPr>
+              <a:spcBef>
+                <a:spcPts val="600"/>
+              </a:spcBef>
+              <a:spcAft>
+                <a:spcPts val="600"/>
+              </a:spcAft>
+              <a:defRPr sz="2300">
+                <a:solidFill>
+                  <a:srgbClr val="212121"/>
+                </a:solidFill>
+              </a:defRPr>
+            </a:pPr>
+            <a:r>
+              <a:t>10. References &amp; Q &amp; A</a:t>
             </a:r>
           </a:p>
         </p:txBody>
@@ -3661,7 +3662,7 @@
 </p:sld>
 </file>
 
-<file path=ppt/slides/slide4.xml><?xml version="1.0" encoding="utf-8"?>
+<file path=ppt/slides/slide3.xml><?xml version="1.0" encoding="utf-8"?>
 <p:sld xmlns:a="http://schemas.openxmlformats.org/drawingml/2006/main" xmlns:p="http://schemas.openxmlformats.org/presentationml/2006/main" xmlns:r="http://schemas.openxmlformats.org/officeDocument/2006/relationships">
   <p:cSld>
     <p:spTree>
@@ -3686,7 +3687,7 @@
             <a:avLst/>
           </a:prstGeom>
           <a:solidFill>
-            <a:srgbClr val="4A7A5C"/>
+            <a:srgbClr val="1B5E20"/>
           </a:solidFill>
           <a:ln>
             <a:noFill/>
@@ -3722,8 +3723,8 @@
         </p:nvSpPr>
         <p:spPr>
           <a:xfrm>
-            <a:off x="457200" y="137160"/>
-            <a:ext cx="8229600" cy="640080"/>
+            <a:off x="548640" y="137160"/>
+            <a:ext cx="8046720" cy="640080"/>
           </a:xfrm>
           <a:prstGeom prst="rect">
             <a:avLst/>
@@ -3744,7 +3745,7 @@
               </a:defRPr>
             </a:pPr>
             <a:r>
-              <a:t>PROBLEMS IDENTIFIED</a:t>
+              <a:t>BUSINESS PROBLEM</a:t>
             </a:r>
           </a:p>
         </p:txBody>
@@ -3757,8 +3758,8 @@
         </p:nvSpPr>
         <p:spPr>
           <a:xfrm>
-            <a:off x="548640" y="1188720"/>
-            <a:ext cx="8046720" cy="4572000"/>
+            <a:off x="731520" y="1280160"/>
+            <a:ext cx="7680960" cy="4572000"/>
           </a:xfrm>
           <a:prstGeom prst="rect">
             <a:avLst/>
@@ -3766,61 +3767,98 @@
           <a:noFill/>
         </p:spPr>
         <p:txBody>
-          <a:bodyPr wrap="none">
+          <a:bodyPr wrap="square">
             <a:spAutoFit/>
           </a:bodyPr>
           <a:lstStyle/>
           <a:p>
-            <a:r>
-              <a:t>• Fragmented Records &amp; Limited Accessibility</a:t>
-            </a:r>
-          </a:p>
-          <a:p>
-            <a:pPr lvl="1">
-              <a:defRPr sz="2000"/>
-            </a:pPr>
-            <a:r>
-              <a:t>• Manual Tracking - Time-consuming searches</a:t>
-            </a:r>
-          </a:p>
-          <a:p>
-            <a:pPr lvl="1">
-              <a:defRPr sz="2000"/>
-            </a:pPr>
-            <a:r>
-              <a:t>• Scheduling Conflicts - Risk of double-booking</a:t>
-            </a:r>
-          </a:p>
-          <a:p>
-            <a:pPr lvl="1">
-              <a:defRPr sz="2000"/>
-            </a:pPr>
-            <a:r>
-              <a:t>• No Data Backup - Vulnerable to loss/damage</a:t>
-            </a:r>
-          </a:p>
-          <a:p>
-            <a:pPr lvl="1">
-              <a:defRPr sz="2000"/>
-            </a:pPr>
-            <a:r>
-              <a:t>• Duplicate Records - Fragmented patient history</a:t>
-            </a:r>
-          </a:p>
-          <a:p>
-            <a:pPr lvl="1">
-              <a:defRPr sz="2000"/>
-            </a:pPr>
-            <a:r>
-              <a:t>• Lack of Accountability - No audit trail</a:t>
-            </a:r>
-          </a:p>
-          <a:p>
-            <a:pPr lvl="1">
-              <a:defRPr sz="2000"/>
-            </a:pPr>
-            <a:r>
-              <a:t>• Inefficient Inter-Branch Coordination</a:t>
+            <a:pPr>
+              <a:spcAft>
+                <a:spcPts val="1800"/>
+              </a:spcAft>
+              <a:defRPr sz="1900">
+                <a:solidFill>
+                  <a:srgbClr val="212121"/>
+                </a:solidFill>
+              </a:defRPr>
+            </a:pPr>
+            <a:r>
+              <a:t>Gonzaga Dental Clinic relies on a traditional paper-based system to manage its daily operations, leading to inefficiencies across both branches.</a:t>
+            </a:r>
+          </a:p>
+          <a:p>
+            <a:pPr>
+              <a:spcBef>
+                <a:spcPts val="800"/>
+              </a:spcBef>
+              <a:defRPr sz="1900">
+                <a:solidFill>
+                  <a:srgbClr val="212121"/>
+                </a:solidFill>
+              </a:defRPr>
+            </a:pPr>
+            <a:r>
+              <a:t>• Manual record-keeping using envelopes, binders, and cabinets</a:t>
+            </a:r>
+          </a:p>
+          <a:p>
+            <a:pPr>
+              <a:spcBef>
+                <a:spcPts val="800"/>
+              </a:spcBef>
+              <a:defRPr sz="1900">
+                <a:solidFill>
+                  <a:srgbClr val="212121"/>
+                </a:solidFill>
+              </a:defRPr>
+            </a:pPr>
+            <a:r>
+              <a:t>• Appointments tracked through a physical logbook</a:t>
+            </a:r>
+          </a:p>
+          <a:p>
+            <a:pPr>
+              <a:spcBef>
+                <a:spcPts val="800"/>
+              </a:spcBef>
+              <a:defRPr sz="1900">
+                <a:solidFill>
+                  <a:srgbClr val="212121"/>
+                </a:solidFill>
+              </a:defRPr>
+            </a:pPr>
+            <a:r>
+              <a:t>• Treatment history recorded on index cards</a:t>
+            </a:r>
+          </a:p>
+          <a:p>
+            <a:pPr>
+              <a:spcBef>
+                <a:spcPts val="800"/>
+              </a:spcBef>
+              <a:defRPr sz="1900">
+                <a:solidFill>
+                  <a:srgbClr val="212121"/>
+                </a:solidFill>
+              </a:defRPr>
+            </a:pPr>
+            <a:r>
+              <a:t>• Limited to no inter-branch access to patient records</a:t>
+            </a:r>
+          </a:p>
+          <a:p>
+            <a:pPr>
+              <a:spcBef>
+                <a:spcPts val="800"/>
+              </a:spcBef>
+              <a:defRPr sz="1900">
+                <a:solidFill>
+                  <a:srgbClr val="212121"/>
+                </a:solidFill>
+              </a:defRPr>
+            </a:pPr>
+            <a:r>
+              <a:t>• Absence of digital backup and audit mechanisms</a:t>
             </a:r>
           </a:p>
         </p:txBody>
@@ -3833,7 +3871,7 @@
 </p:sld>
 </file>
 
-<file path=ppt/slides/slide5.xml><?xml version="1.0" encoding="utf-8"?>
+<file path=ppt/slides/slide4.xml><?xml version="1.0" encoding="utf-8"?>
 <p:sld xmlns:a="http://schemas.openxmlformats.org/drawingml/2006/main" xmlns:p="http://schemas.openxmlformats.org/presentationml/2006/main" xmlns:r="http://schemas.openxmlformats.org/officeDocument/2006/relationships">
   <p:cSld>
     <p:spTree>
@@ -3858,7 +3896,7 @@
             <a:avLst/>
           </a:prstGeom>
           <a:solidFill>
-            <a:srgbClr val="4A7A5C"/>
+            <a:srgbClr val="1B5E20"/>
           </a:solidFill>
           <a:ln>
             <a:noFill/>
@@ -3894,8 +3932,8 @@
         </p:nvSpPr>
         <p:spPr>
           <a:xfrm>
-            <a:off x="457200" y="137160"/>
-            <a:ext cx="8229600" cy="640080"/>
+            <a:off x="548640" y="137160"/>
+            <a:ext cx="8046720" cy="640080"/>
           </a:xfrm>
           <a:prstGeom prst="rect">
             <a:avLst/>
@@ -3916,7 +3954,7 @@
               </a:defRPr>
             </a:pPr>
             <a:r>
-              <a:t>PROPOSED SOLUTION</a:t>
+              <a:t>PROBLEMS IDENTIFIED</a:t>
             </a:r>
           </a:p>
         </p:txBody>
@@ -3929,8 +3967,8 @@
         </p:nvSpPr>
         <p:spPr>
           <a:xfrm>
-            <a:off x="548640" y="1005840"/>
-            <a:ext cx="8046720" cy="731520"/>
+            <a:off x="731520" y="1280160"/>
+            <a:ext cx="7680960" cy="4754880"/>
           </a:xfrm>
           <a:prstGeom prst="rect">
             <a:avLst/>
@@ -3943,75 +3981,147 @@
           </a:bodyPr>
           <a:lstStyle/>
           <a:p>
-            <a:pPr algn="ctr">
-              <a:defRPr sz="2200" b="1">
-                <a:solidFill>
-                  <a:srgbClr val="1E3A8A"/>
-                </a:solidFill>
-              </a:defRPr>
-            </a:pPr>
-            <a:r>
-              <a:t>GDCMAS - Gonzaga Dental Clinic Management Automation System</a:t>
-            </a:r>
-          </a:p>
-        </p:txBody>
-      </p:sp>
-      <p:sp>
-        <p:nvSpPr>
-          <p:cNvPr id="5" name="TextBox 4"/>
-          <p:cNvSpPr txBox="1"/>
-          <p:nvPr/>
-        </p:nvSpPr>
-        <p:spPr>
-          <a:xfrm>
-            <a:off x="548640" y="2011680"/>
-            <a:ext cx="8046720" cy="3200400"/>
-          </a:xfrm>
-          <a:prstGeom prst="rect">
-            <a:avLst/>
-          </a:prstGeom>
-          <a:noFill/>
-        </p:spPr>
-        <p:txBody>
-          <a:bodyPr wrap="none">
-            <a:spAutoFit/>
-          </a:bodyPr>
-          <a:lstStyle/>
-          <a:p>
-            <a:r>
-              <a:t>A centralized, web-based system that automates and digitizes clinic operations with:</a:t>
-            </a:r>
-          </a:p>
-          <a:p>
-            <a:pPr lvl="1">
-              <a:defRPr sz="1900"/>
-            </a:pPr>
-            <a:r>
-              <a:t>✓ Centralized Patient Records  ✓ Digital Treatment History</a:t>
-            </a:r>
-          </a:p>
-          <a:p>
-            <a:pPr lvl="1">
-              <a:defRPr sz="1900"/>
-            </a:pPr>
-            <a:r>
-              <a:t>✓ Appointment Scheduling  ✓ Role-Based Access Control</a:t>
-            </a:r>
-          </a:p>
-          <a:p>
-            <a:pPr lvl="1">
-              <a:defRPr sz="1900"/>
-            </a:pPr>
-            <a:r>
-              <a:t>✓ Public Booking Portal  ✓ Multi-Layer Security</a:t>
-            </a:r>
-          </a:p>
-          <a:p>
-            <a:pPr lvl="1">
-              <a:defRPr sz="1900"/>
-            </a:pPr>
-            <a:r>
-              <a:t>✓ Audit Logging  ✓ Inter-Branch Accessibility</a:t>
+            <a:pPr>
+              <a:spcBef>
+                <a:spcPts val="1000"/>
+              </a:spcBef>
+              <a:spcAft>
+                <a:spcPts val="1000"/>
+              </a:spcAft>
+              <a:defRPr sz="2000">
+                <a:solidFill>
+                  <a:srgbClr val="212121"/>
+                </a:solidFill>
+              </a:defRPr>
+            </a:pPr>
+            <a:r>
+              <a:t>• Fragmented &amp; Disorganized Records</a:t>
+            </a:r>
+          </a:p>
+          <a:p>
+            <a:pPr>
+              <a:spcBef>
+                <a:spcPts val="1000"/>
+              </a:spcBef>
+              <a:spcAft>
+                <a:spcPts val="1000"/>
+              </a:spcAft>
+              <a:defRPr sz="2000">
+                <a:solidFill>
+                  <a:srgbClr val="212121"/>
+                </a:solidFill>
+              </a:defRPr>
+            </a:pPr>
+            <a:r>
+              <a:t>• Limited Accessibility Between Branches</a:t>
+            </a:r>
+          </a:p>
+          <a:p>
+            <a:pPr>
+              <a:spcBef>
+                <a:spcPts val="1000"/>
+              </a:spcBef>
+              <a:spcAft>
+                <a:spcPts val="1000"/>
+              </a:spcAft>
+              <a:defRPr sz="2000">
+                <a:solidFill>
+                  <a:srgbClr val="212121"/>
+                </a:solidFill>
+              </a:defRPr>
+            </a:pPr>
+            <a:r>
+              <a:t>• Time-Consuming Manual Tracking</a:t>
+            </a:r>
+          </a:p>
+          <a:p>
+            <a:pPr>
+              <a:spcBef>
+                <a:spcPts val="1000"/>
+              </a:spcBef>
+              <a:spcAft>
+                <a:spcPts val="1000"/>
+              </a:spcAft>
+              <a:defRPr sz="2000">
+                <a:solidFill>
+                  <a:srgbClr val="212121"/>
+                </a:solidFill>
+              </a:defRPr>
+            </a:pPr>
+            <a:r>
+              <a:t>• High Risk of Scheduling Conflicts</a:t>
+            </a:r>
+          </a:p>
+          <a:p>
+            <a:pPr>
+              <a:spcBef>
+                <a:spcPts val="1000"/>
+              </a:spcBef>
+              <a:spcAft>
+                <a:spcPts val="1000"/>
+              </a:spcAft>
+              <a:defRPr sz="2000">
+                <a:solidFill>
+                  <a:srgbClr val="212121"/>
+                </a:solidFill>
+              </a:defRPr>
+            </a:pPr>
+            <a:r>
+              <a:t>• Duplicate Patient Records</a:t>
+            </a:r>
+          </a:p>
+          <a:p>
+            <a:pPr>
+              <a:spcBef>
+                <a:spcPts val="1000"/>
+              </a:spcBef>
+              <a:spcAft>
+                <a:spcPts val="1000"/>
+              </a:spcAft>
+              <a:defRPr sz="2000">
+                <a:solidFill>
+                  <a:srgbClr val="212121"/>
+                </a:solidFill>
+              </a:defRPr>
+            </a:pPr>
+            <a:r>
+              <a:t>• No Data Backup or Recovery</a:t>
+            </a:r>
+          </a:p>
+          <a:p>
+            <a:pPr>
+              <a:spcBef>
+                <a:spcPts val="1000"/>
+              </a:spcBef>
+              <a:spcAft>
+                <a:spcPts val="1000"/>
+              </a:spcAft>
+              <a:defRPr sz="2000">
+                <a:solidFill>
+                  <a:srgbClr val="212121"/>
+                </a:solidFill>
+              </a:defRPr>
+            </a:pPr>
+            <a:r>
+              <a:t>• Lack of Accountability &amp; Audit Trail</a:t>
+            </a:r>
+          </a:p>
+          <a:p>
+            <a:pPr>
+              <a:spcBef>
+                <a:spcPts val="1000"/>
+              </a:spcBef>
+              <a:spcAft>
+                <a:spcPts val="1000"/>
+              </a:spcAft>
+              <a:defRPr sz="2000">
+                <a:solidFill>
+                  <a:srgbClr val="212121"/>
+                </a:solidFill>
+              </a:defRPr>
+            </a:pPr>
+            <a:r>
+              <a:t>• Inefficient Inter-Branch Coordination</a:t>
             </a:r>
           </a:p>
         </p:txBody>
@@ -4024,7 +4134,7 @@
 </p:sld>
 </file>
 
-<file path=ppt/slides/slide6.xml><?xml version="1.0" encoding="utf-8"?>
+<file path=ppt/slides/slide5.xml><?xml version="1.0" encoding="utf-8"?>
 <p:sld xmlns:a="http://schemas.openxmlformats.org/drawingml/2006/main" xmlns:p="http://schemas.openxmlformats.org/presentationml/2006/main" xmlns:r="http://schemas.openxmlformats.org/officeDocument/2006/relationships">
   <p:cSld>
     <p:spTree>
@@ -4049,7 +4159,7 @@
             <a:avLst/>
           </a:prstGeom>
           <a:solidFill>
-            <a:srgbClr val="4A7A5C"/>
+            <a:srgbClr val="1B5E20"/>
           </a:solidFill>
           <a:ln>
             <a:noFill/>
@@ -4085,8 +4195,8 @@
         </p:nvSpPr>
         <p:spPr>
           <a:xfrm>
-            <a:off x="457200" y="137160"/>
-            <a:ext cx="8229600" cy="640080"/>
+            <a:off x="548640" y="137160"/>
+            <a:ext cx="8046720" cy="640080"/>
           </a:xfrm>
           <a:prstGeom prst="rect">
             <a:avLst/>
@@ -4107,7 +4217,7 @@
               </a:defRPr>
             </a:pPr>
             <a:r>
-              <a:t>SECURITY FEATURES</a:t>
+              <a:t>PROPOSED SOLUTION</a:t>
             </a:r>
           </a:p>
         </p:txBody>
@@ -4120,8 +4230,8 @@
         </p:nvSpPr>
         <p:spPr>
           <a:xfrm>
-            <a:off x="365760" y="1005840"/>
-            <a:ext cx="4297680" cy="4754880"/>
+            <a:off x="731520" y="1097280"/>
+            <a:ext cx="7680960" cy="731520"/>
           </a:xfrm>
           <a:prstGeom prst="rect">
             <a:avLst/>
@@ -4134,80 +4244,15 @@
           </a:bodyPr>
           <a:lstStyle/>
           <a:p>
-            <a:r>
-              <a:t>AUTHENTICATION &amp; ACCESS</a:t>
-            </a:r>
-          </a:p>
-          <a:p>
-            <a:pPr lvl="1">
-              <a:defRPr sz="1200"/>
-            </a:pPr>
-            <a:r>
-              <a:t>• 3-Layer Authorization (Proxy → Server → RLS)</a:t>
-            </a:r>
-          </a:p>
-          <a:p>
-            <a:pPr lvl="1">
-              <a:defRPr sz="1200"/>
-            </a:pPr>
-            <a:r>
-              <a:t>• Roles from DB, not JWT</a:t>
-            </a:r>
-          </a:p>
-          <a:p>
-            <a:pPr lvl="1">
-              <a:defRPr sz="1200"/>
-            </a:pPr>
-            <a:r>
-              <a:t>• Active-account gate</a:t>
-            </a:r>
-          </a:p>
-          <a:p>
-            <a:pPr lvl="1">
-              <a:defRPr sz="1200"/>
-            </a:pPr>
-            <a:r>
-              <a:t>• No self-promotion/deactivation</a:t>
-            </a:r>
-          </a:p>
-          <a:p>
-            <a:pPr lvl="1">
-              <a:defRPr sz="1200"/>
-            </a:pPr>
-            <a:r>
-              <a:t>• Branch isolation &amp; unassigned=no access</a:t>
-            </a:r>
-          </a:p>
-          <a:p>
-            <a:pPr lvl="1">
-              <a:defRPr b="1" sz="1300"/>
-            </a:pPr>
-            <a:r>
-              <a:t>DATA PROTECTION</a:t>
-            </a:r>
-          </a:p>
-          <a:p>
-            <a:pPr lvl="1">
-              <a:defRPr sz="1200"/>
-            </a:pPr>
-            <a:r>
-              <a:t>• RLS on all 9 tables</a:t>
-            </a:r>
-          </a:p>
-          <a:p>
-            <a:pPr lvl="1">
-              <a:defRPr sz="1200"/>
-            </a:pPr>
-            <a:r>
-              <a:t>• Clinical writes: Dentist/Admin only</a:t>
-            </a:r>
-          </a:p>
-          <a:p>
-            <a:pPr lvl="1">
-              <a:defRPr sz="1200"/>
-            </a:pPr>
-            <a:r>
-              <a:t>• Admin-only ops (staff, audit, settings)</a:t>
+            <a:pPr algn="ctr">
+              <a:defRPr sz="1800" b="1">
+                <a:solidFill>
+                  <a:srgbClr val="1B5E20"/>
+                </a:solidFill>
+              </a:defRPr>
+            </a:pPr>
+            <a:r>
+              <a:t>GONZAGA DENTAL CLINIC MANAGEMENT AUTOMATION SYSTEM (GDCMAS)</a:t>
             </a:r>
           </a:p>
         </p:txBody>
@@ -4220,8 +4265,8 @@
         </p:nvSpPr>
         <p:spPr>
           <a:xfrm>
-            <a:off x="4754880" y="1005840"/>
-            <a:ext cx="4023360" cy="4754880"/>
+            <a:off x="822960" y="2103120"/>
+            <a:ext cx="7498079" cy="3657600"/>
           </a:xfrm>
           <a:prstGeom prst="rect">
             <a:avLst/>
@@ -4229,93 +4274,35 @@
           <a:noFill/>
         </p:spPr>
         <p:txBody>
-          <a:bodyPr wrap="none">
+          <a:bodyPr wrap="square">
             <a:spAutoFit/>
           </a:bodyPr>
           <a:lstStyle/>
           <a:p>
-            <a:r>
-              <a:t>CONSTRAINTS &amp; AUDITING</a:t>
-            </a:r>
-          </a:p>
-          <a:p>
-            <a:pPr lvl="1">
-              <a:defRPr sz="1200"/>
-            </a:pPr>
-            <a:r>
-              <a:t>• No double bookings (DB constraints)</a:t>
-            </a:r>
-          </a:p>
-          <a:p>
-            <a:pPr lvl="1">
-              <a:defRPr sz="1200"/>
-            </a:pPr>
-            <a:r>
-              <a:t>• Cross-branch booking guard</a:t>
-            </a:r>
-          </a:p>
-          <a:p>
-            <a:pPr lvl="1">
-              <a:defRPr sz="1200"/>
-            </a:pPr>
-            <a:r>
-              <a:t>• Records cannot be destroyed</a:t>
-            </a:r>
-          </a:p>
-          <a:p>
-            <a:pPr lvl="1">
-              <a:defRPr sz="1200"/>
-            </a:pPr>
-            <a:r>
-              <a:t>• Append-only audit log</a:t>
-            </a:r>
-          </a:p>
-          <a:p>
-            <a:pPr lvl="1">
-              <a:defRPr sz="1200"/>
-            </a:pPr>
-            <a:r>
-              <a:t>• Input validation (Zod)</a:t>
-            </a:r>
-          </a:p>
-          <a:p>
-            <a:pPr lvl="1">
-              <a:defRPr b="1" sz="1300"/>
-            </a:pPr>
-            <a:r>
-              <a:t>PUBLIC BOOKING SECURITY</a:t>
-            </a:r>
-          </a:p>
-          <a:p>
-            <a:pPr lvl="1">
-              <a:defRPr sz="1200"/>
-            </a:pPr>
-            <a:r>
-              <a:t>• Anon has zero table access</a:t>
-            </a:r>
-          </a:p>
-          <a:p>
-            <a:pPr lvl="1">
-              <a:defRPr sz="1200"/>
-            </a:pPr>
-            <a:r>
-              <a:t>• Only 3 narrow functions accessible</a:t>
-            </a:r>
-          </a:p>
-          <a:p>
-            <a:pPr lvl="1">
-              <a:defRPr sz="1200"/>
-            </a:pPr>
-            <a:r>
-              <a:t>• Service role server-only</a:t>
-            </a:r>
-          </a:p>
-          <a:p>
-            <a:pPr lvl="1">
-              <a:defRPr sz="1200"/>
-            </a:pPr>
-            <a:r>
-              <a:t>• Verified by smoke-test.sql (25 tests)</a:t>
+            <a:pPr algn="ctr">
+              <a:spcAft>
+                <a:spcPts val="2500"/>
+              </a:spcAft>
+              <a:defRPr sz="1900">
+                <a:solidFill>
+                  <a:srgbClr val="212121"/>
+                </a:solidFill>
+              </a:defRPr>
+            </a:pPr>
+            <a:r>
+              <a:t>A centralized, web-based business process automation system designed to digitize, standardize, and secure all clinic operations across both branches.</a:t>
+            </a:r>
+          </a:p>
+          <a:p>
+            <a:pPr algn="ctr">
+              <a:defRPr sz="1800" b="1">
+                <a:solidFill>
+                  <a:srgbClr val="2E7D32"/>
+                </a:solidFill>
+              </a:defRPr>
+            </a:pPr>
+            <a:r>
+              <a:t>Goal: Replace manual workflows with an integrated platform that ensures efficiency, accessibility, security, and accountability.</a:t>
             </a:r>
           </a:p>
         </p:txBody>
@@ -4328,7 +4315,7 @@
 </p:sld>
 </file>
 
-<file path=ppt/slides/slide7.xml><?xml version="1.0" encoding="utf-8"?>
+<file path=ppt/slides/slide6.xml><?xml version="1.0" encoding="utf-8"?>
 <p:sld xmlns:a="http://schemas.openxmlformats.org/drawingml/2006/main" xmlns:p="http://schemas.openxmlformats.org/presentationml/2006/main" xmlns:r="http://schemas.openxmlformats.org/officeDocument/2006/relationships">
   <p:cSld>
     <p:spTree>
@@ -4353,7 +4340,7 @@
             <a:avLst/>
           </a:prstGeom>
           <a:solidFill>
-            <a:srgbClr val="4A7A5C"/>
+            <a:srgbClr val="1B5E20"/>
           </a:solidFill>
           <a:ln>
             <a:noFill/>
@@ -4389,8 +4376,8 @@
         </p:nvSpPr>
         <p:spPr>
           <a:xfrm>
-            <a:off x="457200" y="137160"/>
-            <a:ext cx="8229600" cy="640080"/>
+            <a:off x="548640" y="137160"/>
+            <a:ext cx="8046720" cy="640080"/>
           </a:xfrm>
           <a:prstGeom prst="rect">
             <a:avLst/>
@@ -4411,7 +4398,7 @@
               </a:defRPr>
             </a:pPr>
             <a:r>
-              <a:t>TECHNOLOGY STACK</a:t>
+              <a:t>SECURITY FEATURES</a:t>
             </a:r>
           </a:p>
         </p:txBody>
@@ -4424,8 +4411,8 @@
         </p:nvSpPr>
         <p:spPr>
           <a:xfrm>
-            <a:off x="914400" y="1371600"/>
-            <a:ext cx="7315200" cy="3657600"/>
+            <a:off x="457200" y="1097280"/>
+            <a:ext cx="4206240" cy="4846320"/>
           </a:xfrm>
           <a:prstGeom prst="rect">
             <a:avLst/>
@@ -4438,48 +4425,387 @@
           </a:bodyPr>
           <a:lstStyle/>
           <a:p>
-            <a:r>
-              <a:t>FRONTEND</a:t>
-            </a:r>
-          </a:p>
-          <a:p>
-            <a:pPr lvl="2">
-              <a:defRPr sz="1800"/>
-            </a:pPr>
-            <a:r>
-              <a:t>Next.js 16 (App Router) • React 19 • TypeScript • Tailwind CSS 4</a:t>
-            </a:r>
-          </a:p>
-          <a:p>
-            <a:pPr lvl="1">
-              <a:defRPr b="1" sz="2000"/>
-            </a:pPr>
-            <a:r>
-              <a:t>BACKEND &amp; DATABASE</a:t>
-            </a:r>
-          </a:p>
-          <a:p>
-            <a:pPr lvl="2">
-              <a:defRPr sz="1800"/>
-            </a:pPr>
-            <a:r>
-              <a:t>Supabase (PostgreSQL, GoTrue Auth, Row Level Security)</a:t>
-            </a:r>
-          </a:p>
-          <a:p>
-            <a:pPr lvl="1">
-              <a:defRPr b="1" sz="2000"/>
-            </a:pPr>
-            <a:r>
-              <a:t>VALIDATION &amp; SECURITY</a:t>
-            </a:r>
-          </a:p>
-          <a:p>
-            <a:pPr lvl="2">
-              <a:defRPr sz="1800"/>
-            </a:pPr>
-            <a:r>
-              <a:t>Zod Schema Validation • Multi-Layer Authorization</a:t>
+            <a:pPr>
+              <a:spcAft>
+                <a:spcPts val="800"/>
+              </a:spcAft>
+              <a:defRPr sz="1400" b="1">
+                <a:solidFill>
+                  <a:srgbClr val="1B5E20"/>
+                </a:solidFill>
+              </a:defRPr>
+            </a:pPr>
+            <a:r>
+              <a:t>AUTHENTICATION &amp; ACCESS</a:t>
+            </a:r>
+          </a:p>
+          <a:p>
+            <a:pPr>
+              <a:spcBef>
+                <a:spcPts val="600"/>
+              </a:spcBef>
+              <a:defRPr sz="1200">
+                <a:solidFill>
+                  <a:srgbClr val="212121"/>
+                </a:solidFill>
+              </a:defRPr>
+            </a:pPr>
+            <a:r>
+              <a:t>• Three-Layer Authorization</a:t>
+            </a:r>
+          </a:p>
+          <a:p>
+            <a:pPr>
+              <a:spcBef>
+                <a:spcPts val="600"/>
+              </a:spcBef>
+              <a:defRPr sz="1200">
+                <a:solidFill>
+                  <a:srgbClr val="212121"/>
+                </a:solidFill>
+              </a:defRPr>
+            </a:pPr>
+            <a:r>
+              <a:t>• Roles from Database, Not JWT</a:t>
+            </a:r>
+          </a:p>
+          <a:p>
+            <a:pPr>
+              <a:spcBef>
+                <a:spcPts val="600"/>
+              </a:spcBef>
+              <a:defRPr sz="1200">
+                <a:solidFill>
+                  <a:srgbClr val="212121"/>
+                </a:solidFill>
+              </a:defRPr>
+            </a:pPr>
+            <a:r>
+              <a:t>• Active-Account Gate</a:t>
+            </a:r>
+          </a:p>
+          <a:p>
+            <a:pPr>
+              <a:spcBef>
+                <a:spcPts val="600"/>
+              </a:spcBef>
+              <a:defRPr sz="1200">
+                <a:solidFill>
+                  <a:srgbClr val="212121"/>
+                </a:solidFill>
+              </a:defRPr>
+            </a:pPr>
+            <a:r>
+              <a:t>• No Self-Promotion/Deactivation</a:t>
+            </a:r>
+          </a:p>
+          <a:p>
+            <a:pPr>
+              <a:spcBef>
+                <a:spcPts val="600"/>
+              </a:spcBef>
+              <a:defRPr sz="1200">
+                <a:solidFill>
+                  <a:srgbClr val="212121"/>
+                </a:solidFill>
+              </a:defRPr>
+            </a:pPr>
+            <a:r>
+              <a:t>• Branch Isolation &amp; Unassigned=No Access</a:t>
+            </a:r>
+          </a:p>
+          <a:p>
+            <a:pPr>
+              <a:defRPr sz="800"/>
+            </a:pPr>
+          </a:p>
+          <a:p>
+            <a:pPr>
+              <a:spcBef>
+                <a:spcPts val="1000"/>
+              </a:spcBef>
+              <a:spcAft>
+                <a:spcPts val="800"/>
+              </a:spcAft>
+              <a:defRPr sz="1400" b="1">
+                <a:solidFill>
+                  <a:srgbClr val="1B5E20"/>
+                </a:solidFill>
+              </a:defRPr>
+            </a:pPr>
+            <a:r>
+              <a:t>DATA PROTECTION</a:t>
+            </a:r>
+          </a:p>
+          <a:p>
+            <a:pPr>
+              <a:spcBef>
+                <a:spcPts val="600"/>
+              </a:spcBef>
+              <a:defRPr sz="1200">
+                <a:solidFill>
+                  <a:srgbClr val="212121"/>
+                </a:solidFill>
+              </a:defRPr>
+            </a:pPr>
+            <a:r>
+              <a:t>• RLS on All 9 Tables</a:t>
+            </a:r>
+          </a:p>
+          <a:p>
+            <a:pPr>
+              <a:spcBef>
+                <a:spcPts val="600"/>
+              </a:spcBef>
+              <a:defRPr sz="1200">
+                <a:solidFill>
+                  <a:srgbClr val="212121"/>
+                </a:solidFill>
+              </a:defRPr>
+            </a:pPr>
+            <a:r>
+              <a:t>• Clinical Writes: Dentist/Admin Only</a:t>
+            </a:r>
+          </a:p>
+          <a:p>
+            <a:pPr>
+              <a:spcBef>
+                <a:spcPts val="600"/>
+              </a:spcBef>
+              <a:defRPr sz="1200">
+                <a:solidFill>
+                  <a:srgbClr val="212121"/>
+                </a:solidFill>
+              </a:defRPr>
+            </a:pPr>
+            <a:r>
+              <a:t>• Admin-Only Operations</a:t>
+            </a:r>
+          </a:p>
+          <a:p>
+            <a:pPr>
+              <a:spcBef>
+                <a:spcPts val="600"/>
+              </a:spcBef>
+              <a:defRPr sz="1200">
+                <a:solidFill>
+                  <a:srgbClr val="212121"/>
+                </a:solidFill>
+              </a:defRPr>
+            </a:pPr>
+            <a:r>
+              <a:t>• Function Permissions Locked Down</a:t>
+            </a:r>
+          </a:p>
+        </p:txBody>
+      </p:sp>
+      <p:sp>
+        <p:nvSpPr>
+          <p:cNvPr id="5" name="TextBox 4"/>
+          <p:cNvSpPr txBox="1"/>
+          <p:nvPr/>
+        </p:nvSpPr>
+        <p:spPr>
+          <a:xfrm>
+            <a:off x="4663440" y="1097280"/>
+            <a:ext cx="4023360" cy="4846320"/>
+          </a:xfrm>
+          <a:prstGeom prst="rect">
+            <a:avLst/>
+          </a:prstGeom>
+          <a:noFill/>
+        </p:spPr>
+        <p:txBody>
+          <a:bodyPr wrap="none">
+            <a:spAutoFit/>
+          </a:bodyPr>
+          <a:lstStyle/>
+          <a:p>
+            <a:pPr>
+              <a:spcAft>
+                <a:spcPts val="800"/>
+              </a:spcAft>
+              <a:defRPr sz="1400" b="1">
+                <a:solidFill>
+                  <a:srgbClr val="1B5E20"/>
+                </a:solidFill>
+              </a:defRPr>
+            </a:pPr>
+            <a:r>
+              <a:t>DATA INTEGRITY</a:t>
+            </a:r>
+          </a:p>
+          <a:p>
+            <a:pPr>
+              <a:spcBef>
+                <a:spcPts val="600"/>
+              </a:spcBef>
+              <a:defRPr sz="1200">
+                <a:solidFill>
+                  <a:srgbClr val="212121"/>
+                </a:solidFill>
+              </a:defRPr>
+            </a:pPr>
+            <a:r>
+              <a:t>• No Double Bookings</a:t>
+            </a:r>
+          </a:p>
+          <a:p>
+            <a:pPr>
+              <a:spcBef>
+                <a:spcPts val="600"/>
+              </a:spcBef>
+              <a:defRPr sz="1200">
+                <a:solidFill>
+                  <a:srgbClr val="212121"/>
+                </a:solidFill>
+              </a:defRPr>
+            </a:pPr>
+            <a:r>
+              <a:t>• Cross-Branch Booking Guard</a:t>
+            </a:r>
+          </a:p>
+          <a:p>
+            <a:pPr>
+              <a:spcBef>
+                <a:spcPts val="600"/>
+              </a:spcBef>
+              <a:defRPr sz="1200">
+                <a:solidFill>
+                  <a:srgbClr val="212121"/>
+                </a:solidFill>
+              </a:defRPr>
+            </a:pPr>
+            <a:r>
+              <a:t>• Records Cannot Be Destroyed</a:t>
+            </a:r>
+          </a:p>
+          <a:p>
+            <a:pPr>
+              <a:spcBef>
+                <a:spcPts val="600"/>
+              </a:spcBef>
+              <a:defRPr sz="1200">
+                <a:solidFill>
+                  <a:srgbClr val="212121"/>
+                </a:solidFill>
+              </a:defRPr>
+            </a:pPr>
+            <a:r>
+              <a:t>• Input Validation (Zod)</a:t>
+            </a:r>
+          </a:p>
+          <a:p>
+            <a:pPr>
+              <a:spcBef>
+                <a:spcPts val="600"/>
+              </a:spcBef>
+              <a:defRPr sz="1200">
+                <a:solidFill>
+                  <a:srgbClr val="212121"/>
+                </a:solidFill>
+              </a:defRPr>
+            </a:pPr>
+            <a:r>
+              <a:t>• Strong Password Policy</a:t>
+            </a:r>
+          </a:p>
+          <a:p>
+            <a:pPr>
+              <a:defRPr sz="800"/>
+            </a:pPr>
+          </a:p>
+          <a:p>
+            <a:pPr>
+              <a:spcBef>
+                <a:spcPts val="1000"/>
+              </a:spcBef>
+              <a:spcAft>
+                <a:spcPts val="800"/>
+              </a:spcAft>
+              <a:defRPr sz="1400" b="1">
+                <a:solidFill>
+                  <a:srgbClr val="1B5E20"/>
+                </a:solidFill>
+              </a:defRPr>
+            </a:pPr>
+            <a:r>
+              <a:t>AUDITING &amp; PUBLIC BOOKING</a:t>
+            </a:r>
+          </a:p>
+          <a:p>
+            <a:pPr>
+              <a:spcBef>
+                <a:spcPts val="600"/>
+              </a:spcBef>
+              <a:defRPr sz="1200">
+                <a:solidFill>
+                  <a:srgbClr val="212121"/>
+                </a:solidFill>
+              </a:defRPr>
+            </a:pPr>
+            <a:r>
+              <a:t>• Append-Only Audit Log</a:t>
+            </a:r>
+          </a:p>
+          <a:p>
+            <a:pPr>
+              <a:spcBef>
+                <a:spcPts val="600"/>
+              </a:spcBef>
+              <a:defRPr sz="1200">
+                <a:solidFill>
+                  <a:srgbClr val="212121"/>
+                </a:solidFill>
+              </a:defRPr>
+            </a:pPr>
+            <a:r>
+              <a:t>• Anon: Zero Table Access</a:t>
+            </a:r>
+          </a:p>
+          <a:p>
+            <a:pPr>
+              <a:spcBef>
+                <a:spcPts val="600"/>
+              </a:spcBef>
+              <a:defRPr sz="1200">
+                <a:solidFill>
+                  <a:srgbClr val="212121"/>
+                </a:solidFill>
+              </a:defRPr>
+            </a:pPr>
+            <a:r>
+              <a:t>• Only 3 Narrow Public Functions</a:t>
+            </a:r>
+          </a:p>
+          <a:p>
+            <a:pPr>
+              <a:spcBef>
+                <a:spcPts val="600"/>
+              </a:spcBef>
+              <a:defRPr sz="1200">
+                <a:solidFill>
+                  <a:srgbClr val="212121"/>
+                </a:solidFill>
+              </a:defRPr>
+            </a:pPr>
+            <a:r>
+              <a:t>• Service Role: Server-Only</a:t>
+            </a:r>
+          </a:p>
+          <a:p>
+            <a:pPr>
+              <a:spcBef>
+                <a:spcPts val="600"/>
+              </a:spcBef>
+              <a:defRPr sz="1200">
+                <a:solidFill>
+                  <a:srgbClr val="212121"/>
+                </a:solidFill>
+              </a:defRPr>
+            </a:pPr>
+            <a:r>
+              <a:t>• Verified by smoke-test.sql</a:t>
             </a:r>
           </a:p>
         </p:txBody>
@@ -4492,7 +4818,7 @@
 </p:sld>
 </file>
 
-<file path=ppt/slides/slide8.xml><?xml version="1.0" encoding="utf-8"?>
+<file path=ppt/slides/slide7.xml><?xml version="1.0" encoding="utf-8"?>
 <p:sld xmlns:a="http://schemas.openxmlformats.org/drawingml/2006/main" xmlns:p="http://schemas.openxmlformats.org/presentationml/2006/main" xmlns:r="http://schemas.openxmlformats.org/officeDocument/2006/relationships">
   <p:cSld>
     <p:spTree>
@@ -4517,7 +4843,7 @@
             <a:avLst/>
           </a:prstGeom>
           <a:solidFill>
-            <a:srgbClr val="4A7A5C"/>
+            <a:srgbClr val="1B5E20"/>
           </a:solidFill>
           <a:ln>
             <a:noFill/>
@@ -4553,8 +4879,8 @@
         </p:nvSpPr>
         <p:spPr>
           <a:xfrm>
-            <a:off x="457200" y="137160"/>
-            <a:ext cx="8229600" cy="640080"/>
+            <a:off x="548640" y="137160"/>
+            <a:ext cx="8046720" cy="640080"/>
           </a:xfrm>
           <a:prstGeom prst="rect">
             <a:avLst/>
@@ -4588,8 +4914,8 @@
         </p:nvSpPr>
         <p:spPr>
           <a:xfrm>
-            <a:off x="548640" y="1188720"/>
-            <a:ext cx="8046720" cy="3657600"/>
+            <a:off x="822960" y="1280160"/>
+            <a:ext cx="7498079" cy="3657600"/>
           </a:xfrm>
           <a:prstGeom prst="rect">
             <a:avLst/>
@@ -4602,48 +4928,232 @@
           </a:bodyPr>
           <a:lstStyle/>
           <a:p>
-            <a:r>
-              <a:t>• The issue is lack of standardized, centralized process - not just software</a:t>
-            </a:r>
-          </a:p>
-          <a:p>
-            <a:pPr lvl="1">
-              <a:defRPr sz="1800"/>
-            </a:pPr>
-            <a:r>
-              <a:t>• GDCMAS standardizes workflow first, then automates with technology</a:t>
-            </a:r>
-          </a:p>
-          <a:p>
-            <a:pPr lvl="1">
-              <a:defRPr sz="1800"/>
-            </a:pPr>
-            <a:r>
-              <a:t>• Addresses all identified issues with enterprise-grade security</a:t>
-            </a:r>
-          </a:p>
-          <a:p>
-            <a:pPr lvl="1">
-              <a:defRPr sz="1800"/>
-            </a:pPr>
-            <a:r>
-              <a:t>• Improves efficiency, accessibility, accountability &amp; patient care</a:t>
-            </a:r>
-          </a:p>
-          <a:p>
-            <a:pPr lvl="1">
-              <a:defRPr sz="1800"/>
-            </a:pPr>
-            <a:r>
-              <a:t>• Centralized records enable better continuity of care across branches</a:t>
-            </a:r>
-          </a:p>
-          <a:p>
-            <a:pPr lvl="1">
-              <a:defRPr sz="1800"/>
-            </a:pPr>
-            <a:r>
-              <a:t>• Ready for implementation with proper validation and training</a:t>
+            <a:pPr>
+              <a:spcBef>
+                <a:spcPts val="1200"/>
+              </a:spcBef>
+              <a:defRPr sz="1800">
+                <a:solidFill>
+                  <a:srgbClr val="212121"/>
+                </a:solidFill>
+              </a:defRPr>
+            </a:pPr>
+            <a:r>
+              <a:t>• The core issue is the lack of a standardized, centralized process.</a:t>
+            </a:r>
+          </a:p>
+          <a:p>
+            <a:pPr>
+              <a:spcBef>
+                <a:spcPts val="1200"/>
+              </a:spcBef>
+              <a:defRPr sz="1800">
+                <a:solidFill>
+                  <a:srgbClr val="212121"/>
+                </a:solidFill>
+              </a:defRPr>
+            </a:pPr>
+            <a:r>
+              <a:t>• GDCMAS standardizes the workflow first, then automates it through technology.</a:t>
+            </a:r>
+          </a:p>
+          <a:p>
+            <a:pPr>
+              <a:spcBef>
+                <a:spcPts val="1200"/>
+              </a:spcBef>
+              <a:defRPr sz="1800">
+                <a:solidFill>
+                  <a:srgbClr val="212121"/>
+                </a:solidFill>
+              </a:defRPr>
+            </a:pPr>
+            <a:r>
+              <a:t>• It addresses all identified issues with enterprise-grade, multi-layered security.</a:t>
+            </a:r>
+          </a:p>
+          <a:p>
+            <a:pPr>
+              <a:spcBef>
+                <a:spcPts val="1200"/>
+              </a:spcBef>
+              <a:defRPr sz="1800">
+                <a:solidFill>
+                  <a:srgbClr val="212121"/>
+                </a:solidFill>
+              </a:defRPr>
+            </a:pPr>
+            <a:r>
+              <a:t>• Improves efficiency, accessibility, accountability, and patient care quality.</a:t>
+            </a:r>
+          </a:p>
+          <a:p>
+            <a:pPr>
+              <a:spcBef>
+                <a:spcPts val="1200"/>
+              </a:spcBef>
+              <a:defRPr sz="1800">
+                <a:solidFill>
+                  <a:srgbClr val="212121"/>
+                </a:solidFill>
+              </a:defRPr>
+            </a:pPr>
+            <a:r>
+              <a:t>• Enables seamless inter-branch operations and better continuity of care.</a:t>
+            </a:r>
+          </a:p>
+          <a:p>
+            <a:pPr>
+              <a:spcBef>
+                <a:spcPts val="1200"/>
+              </a:spcBef>
+              <a:defRPr sz="1800">
+                <a:solidFill>
+                  <a:srgbClr val="212121"/>
+                </a:solidFill>
+              </a:defRPr>
+            </a:pPr>
+            <a:r>
+              <a:t>• Provides a solid foundation for the clinic's digital transformation.</a:t>
+            </a:r>
+          </a:p>
+        </p:txBody>
+      </p:sp>
+    </p:spTree>
+  </p:cSld>
+  <p:clrMapOvr>
+    <a:masterClrMapping/>
+  </p:clrMapOvr>
+</p:sld>
+</file>
+
+<file path=ppt/slides/slide8.xml><?xml version="1.0" encoding="utf-8"?>
+<p:sld xmlns:a="http://schemas.openxmlformats.org/drawingml/2006/main" xmlns:p="http://schemas.openxmlformats.org/presentationml/2006/main" xmlns:r="http://schemas.openxmlformats.org/officeDocument/2006/relationships">
+  <p:cSld>
+    <p:spTree>
+      <p:nvGrpSpPr>
+        <p:cNvPr id="1" name=""/>
+        <p:cNvGrpSpPr/>
+        <p:nvPr/>
+      </p:nvGrpSpPr>
+      <p:grpSpPr/>
+      <p:sp>
+        <p:nvSpPr>
+          <p:cNvPr id="2" name="Rectangle 1"/>
+          <p:cNvSpPr/>
+          <p:nvPr/>
+        </p:nvSpPr>
+        <p:spPr>
+          <a:xfrm>
+            <a:off x="0" y="0"/>
+            <a:ext cx="9144000" cy="1645920"/>
+          </a:xfrm>
+          <a:prstGeom prst="rect">
+            <a:avLst/>
+          </a:prstGeom>
+          <a:solidFill>
+            <a:srgbClr val="1B5E20"/>
+          </a:solidFill>
+          <a:ln>
+            <a:noFill/>
+          </a:ln>
+        </p:spPr>
+        <p:style>
+          <a:lnRef idx="1">
+            <a:schemeClr val="accent1"/>
+          </a:lnRef>
+          <a:fillRef idx="3">
+            <a:schemeClr val="accent1"/>
+          </a:fillRef>
+          <a:effectRef idx="2">
+            <a:schemeClr val="accent1"/>
+          </a:effectRef>
+          <a:fontRef idx="minor">
+            <a:schemeClr val="lt1"/>
+          </a:fontRef>
+        </p:style>
+        <p:txBody>
+          <a:bodyPr rtlCol="0" anchor="ctr"/>
+          <a:lstStyle/>
+          <a:p>
+            <a:pPr algn="ctr"/>
+          </a:p>
+        </p:txBody>
+      </p:sp>
+      <p:sp>
+        <p:nvSpPr>
+          <p:cNvPr id="3" name="Rectangle 2"/>
+          <p:cNvSpPr/>
+          <p:nvPr/>
+        </p:nvSpPr>
+        <p:spPr>
+          <a:xfrm>
+            <a:off x="0" y="6217920"/>
+            <a:ext cx="9144000" cy="109728"/>
+          </a:xfrm>
+          <a:prstGeom prst="rect">
+            <a:avLst/>
+          </a:prstGeom>
+          <a:solidFill>
+            <a:srgbClr val="00897B"/>
+          </a:solidFill>
+          <a:ln>
+            <a:noFill/>
+          </a:ln>
+        </p:spPr>
+        <p:style>
+          <a:lnRef idx="1">
+            <a:schemeClr val="accent1"/>
+          </a:lnRef>
+          <a:fillRef idx="3">
+            <a:schemeClr val="accent1"/>
+          </a:fillRef>
+          <a:effectRef idx="2">
+            <a:schemeClr val="accent1"/>
+          </a:effectRef>
+          <a:fontRef idx="minor">
+            <a:schemeClr val="lt1"/>
+          </a:fontRef>
+        </p:style>
+        <p:txBody>
+          <a:bodyPr rtlCol="0" anchor="ctr"/>
+          <a:lstStyle/>
+          <a:p>
+            <a:pPr algn="ctr"/>
+          </a:p>
+        </p:txBody>
+      </p:sp>
+      <p:sp>
+        <p:nvSpPr>
+          <p:cNvPr id="4" name="TextBox 3"/>
+          <p:cNvSpPr txBox="1"/>
+          <p:nvPr/>
+        </p:nvSpPr>
+        <p:spPr>
+          <a:xfrm>
+            <a:off x="457200" y="2560320"/>
+            <a:ext cx="8229600" cy="1097280"/>
+          </a:xfrm>
+          <a:prstGeom prst="rect">
+            <a:avLst/>
+          </a:prstGeom>
+          <a:noFill/>
+        </p:spPr>
+        <p:txBody>
+          <a:bodyPr wrap="none">
+            <a:spAutoFit/>
+          </a:bodyPr>
+          <a:lstStyle/>
+          <a:p>
+            <a:pPr algn="ctr">
+              <a:defRPr sz="5600" b="1">
+                <a:solidFill>
+                  <a:srgbClr val="1B5E20"/>
+                </a:solidFill>
+              </a:defRPr>
+            </a:pPr>
+            <a:r>
+              <a:t>THANK YOU</a:t>
             </a:r>
           </a:p>
         </p:txBody>
@@ -4651,6 +5161,41 @@
       <p:sp>
         <p:nvSpPr>
           <p:cNvPr id="5" name="TextBox 4"/>
+          <p:cNvSpPr txBox="1"/>
+          <p:nvPr/>
+        </p:nvSpPr>
+        <p:spPr>
+          <a:xfrm>
+            <a:off x="457200" y="3840480"/>
+            <a:ext cx="8229600" cy="731520"/>
+          </a:xfrm>
+          <a:prstGeom prst="rect">
+            <a:avLst/>
+          </a:prstGeom>
+          <a:noFill/>
+        </p:spPr>
+        <p:txBody>
+          <a:bodyPr wrap="none">
+            <a:spAutoFit/>
+          </a:bodyPr>
+          <a:lstStyle/>
+          <a:p>
+            <a:pPr algn="ctr">
+              <a:defRPr sz="2800">
+                <a:solidFill>
+                  <a:srgbClr val="2E7D32"/>
+                </a:solidFill>
+              </a:defRPr>
+            </a:pPr>
+            <a:r>
+              <a:t>WE WELCOME YOUR QUESTIONS</a:t>
+            </a:r>
+          </a:p>
+        </p:txBody>
+      </p:sp>
+      <p:sp>
+        <p:nvSpPr>
+          <p:cNvPr id="6" name="TextBox 5"/>
           <p:cNvSpPr txBox="1"/>
           <p:nvPr/>
         </p:nvSpPr>
@@ -4671,31 +5216,26 @@
           <a:lstStyle/>
           <a:p>
             <a:pPr algn="ctr">
-              <a:defRPr sz="3600" b="1">
-                <a:solidFill>
-                  <a:srgbClr val="1E3A8A"/>
-                </a:solidFill>
-              </a:defRPr>
-            </a:pPr>
-            <a:r>
-              <a:t>THANK YOU!</a:t>
-            </a:r>
-          </a:p>
-          <a:p>
-            <a:r>
-              <a:t>Questions and Answers</a:t>
+              <a:defRPr sz="1400">
+                <a:solidFill>
+                  <a:srgbClr val="424242"/>
+                </a:solidFill>
+              </a:defRPr>
+            </a:pPr>
+            <a:r>
+              <a:t>Gonzaga Dental Clinic Management Automation System (GDCMAS)</a:t>
             </a:r>
           </a:p>
           <a:p>
             <a:pPr algn="ctr">
-              <a:defRPr sz="1400">
-                <a:solidFill>
-                  <a:srgbClr val="4A7A5C"/>
-                </a:solidFill>
-              </a:defRPr>
-            </a:pPr>
-            <a:r>
-              <a:t>PHINMA University of Iloilo - College of Information Technology Education</a:t>
+              <a:defRPr sz="1300">
+                <a:solidFill>
+                  <a:srgbClr val="424242"/>
+                </a:solidFill>
+              </a:defRPr>
+            </a:pPr>
+            <a:r>
+              <a:t>PHINMA University of Iloilo | College of Information Technology Education</a:t>
             </a:r>
           </a:p>
         </p:txBody>

</xml_diff>